<commit_message>
power + sesion 1
</commit_message>
<xml_diff>
--- a/LabBook_20.pptx
+++ b/LabBook_20.pptx
@@ -1,6 +1,6 @@
 
 <file path=ppt/presentation.xml><?xml version="1.0" encoding="utf-8"?>
-<p:presentation xmlns:a="http://schemas.openxmlformats.org/drawingml/2006/main" xmlns:r="http://schemas.openxmlformats.org/officeDocument/2006/relationships" xmlns:p="http://schemas.openxmlformats.org/presentationml/2006/main" showSpecialPlsOnTitleSld="0">
+<p:presentation xmlns:a="http://schemas.openxmlformats.org/drawingml/2006/main" xmlns:r="http://schemas.openxmlformats.org/officeDocument/2006/relationships" xmlns:p="http://schemas.openxmlformats.org/presentationml/2006/main" showSpecialPlsOnTitleSld="0" autoCompressPictures="0">
   <p:sldMasterIdLst>
     <p:sldMasterId id="2147483648" r:id="rId1"/>
   </p:sldMasterIdLst>
@@ -819,7 +819,7 @@
           <a:p>
             <a:fld id="{8438F8DC-35B0-48E6-A86E-42F1F08DD00F}" type="datetimeFigureOut">
               <a:rPr lang="es-ES" smtClean="0"/>
-              <a:t>09/03/2026</a:t>
+              <a:t>10/03/2026</a:t>
             </a:fld>
             <a:endParaRPr lang="es-ES"/>
           </a:p>
@@ -996,7 +996,7 @@
           <a:p>
             <a:fld id="{FACBDC12-F39B-4B97-8F4D-6734F9D366FF}" type="datetimeFigureOut">
               <a:rPr lang="es-ES" smtClean="0"/>
-              <a:t>09/03/2026</a:t>
+              <a:t>10/03/2026</a:t>
             </a:fld>
             <a:endParaRPr lang="es-ES"/>
           </a:p>
@@ -9220,6 +9220,45 @@
             </a:endParaRPr>
           </a:p>
           <a:p>
+            <a:pPr marL="800100" lvl="1" indent="-342900" algn="just">
+              <a:buFont typeface="Arial" panose="020B0604020202020204" pitchFamily="34" charset="0"/>
+              <a:buChar char="•"/>
+            </a:pPr>
+            <a:r>
+              <a:rPr lang="en-US" kern="0" dirty="0">
+                <a:solidFill>
+                  <a:sysClr val="windowText" lastClr="000000"/>
+                </a:solidFill>
+                <a:sym typeface="Wingdings" pitchFamily="2" charset="2"/>
+              </a:rPr>
+              <a:t>Terminal + ‘</a:t>
+            </a:r>
+            <a:r>
+              <a:rPr lang="en-US" kern="0" dirty="0" err="1">
+                <a:solidFill>
+                  <a:sysClr val="windowText" lastClr="000000"/>
+                </a:solidFill>
+                <a:sym typeface="Wingdings" pitchFamily="2" charset="2"/>
+              </a:rPr>
+              <a:t>uv</a:t>
+            </a:r>
+            <a:r>
+              <a:rPr lang="en-US" kern="0">
+                <a:solidFill>
+                  <a:sysClr val="windowText" lastClr="000000"/>
+                </a:solidFill>
+                <a:sym typeface="Wingdings" pitchFamily="2" charset="2"/>
+              </a:rPr>
+              <a:t> sync’</a:t>
+            </a:r>
+            <a:endParaRPr lang="en-US" kern="0" dirty="0">
+              <a:solidFill>
+                <a:sysClr val="windowText" lastClr="000000"/>
+              </a:solidFill>
+              <a:sym typeface="Wingdings" pitchFamily="2" charset="2"/>
+            </a:endParaRPr>
+          </a:p>
+          <a:p>
             <a:pPr marL="342900" indent="-342900" algn="just">
               <a:buFont typeface="Arial" panose="020B0604020202020204" pitchFamily="34" charset="0"/>
               <a:buChar char="•"/>
@@ -11213,8 +11252,8 @@
           </a:p>
         </p:txBody>
       </p:sp>
-      <mc:AlternateContent xmlns:mc="http://schemas.openxmlformats.org/markup-compatibility/2006" xmlns:a14="http://schemas.microsoft.com/office/drawing/2010/main">
-        <mc:Choice Requires="a14">
+      <mc:AlternateContent xmlns:mc="http://schemas.openxmlformats.org/markup-compatibility/2006">
+        <mc:Choice xmlns:a14="http://schemas.microsoft.com/office/drawing/2010/main" Requires="a14">
           <p:sp>
             <p:nvSpPr>
               <p:cNvPr id="4" name="Marcador de texto 2">
@@ -11448,7 +11487,7 @@
             </p:txBody>
           </p:sp>
         </mc:Choice>
-        <mc:Fallback xmlns="">
+        <mc:Fallback>
           <p:sp>
             <p:nvSpPr>
               <p:cNvPr id="4" name="Marcador de texto 2">
@@ -11508,7 +11547,7 @@
         <p:spPr>
           <a:xfrm>
             <a:off x="609441" y="4860334"/>
-            <a:ext cx="11199971" cy="1200329"/>
+            <a:ext cx="11199971" cy="3231654"/>
           </a:xfrm>
           <a:prstGeom prst="rect">
             <a:avLst/>
@@ -11536,33 +11575,8 @@
                 <a:latin typeface="Arial" panose="020B0604020202020204" pitchFamily="34" charset="0"/>
                 <a:cs typeface="Arial" panose="020B0604020202020204" pitchFamily="34" charset="0"/>
               </a:rPr>
-              <a:t>Document all your results (neff, plot fields </a:t>
-            </a:r>
-            <a:r>
-              <a:rPr lang="en-US" sz="1200">
-                <a:latin typeface="Arial" panose="020B0604020202020204" pitchFamily="34" charset="0"/>
-                <a:cs typeface="Arial" panose="020B0604020202020204" pitchFamily="34" charset="0"/>
-              </a:rPr>
-              <a:t>of different modes, </a:t>
-            </a:r>
-            <a:r>
-              <a:rPr lang="en-US" sz="1200" dirty="0">
-                <a:latin typeface="Arial" panose="020B0604020202020204" pitchFamily="34" charset="0"/>
-                <a:cs typeface="Arial" panose="020B0604020202020204" pitchFamily="34" charset="0"/>
-              </a:rPr>
-              <a:t>comparison between </a:t>
-            </a:r>
-            <a:r>
-              <a:rPr lang="en-US" sz="1200">
-                <a:latin typeface="Arial" panose="020B0604020202020204" pitchFamily="34" charset="0"/>
-                <a:cs typeface="Arial" panose="020B0604020202020204" pitchFamily="34" charset="0"/>
-              </a:rPr>
-              <a:t>different polarizations…)</a:t>
-            </a:r>
-            <a:endParaRPr lang="en-US" sz="1200" dirty="0">
-              <a:latin typeface="Arial" panose="020B0604020202020204" pitchFamily="34" charset="0"/>
-              <a:cs typeface="Arial" panose="020B0604020202020204" pitchFamily="34" charset="0"/>
-            </a:endParaRPr>
+              <a:t>Document all your results (neff, plot fields of different modes, comparison between different polarizations…)</a:t>
+            </a:r>
           </a:p>
           <a:p>
             <a:pPr algn="just"/>
@@ -11573,6 +11587,48 @@
           </a:p>
           <a:p>
             <a:pPr algn="just"/>
+            <a:r>
+              <a:rPr lang="en-US" sz="1200" dirty="0">
+                <a:solidFill>
+                  <a:srgbClr val="FF0000"/>
+                </a:solidFill>
+                <a:highlight>
+                  <a:srgbClr val="FFFF00"/>
+                </a:highlight>
+                <a:latin typeface="Arial" panose="020B0604020202020204" pitchFamily="34" charset="0"/>
+                <a:cs typeface="Arial" panose="020B0604020202020204" pitchFamily="34" charset="0"/>
+              </a:rPr>
+              <a:t>HAY UN </a:t>
+            </a:r>
+            <a:r>
+              <a:rPr lang="en-US" sz="1200" dirty="0" err="1">
+                <a:solidFill>
+                  <a:srgbClr val="FF0000"/>
+                </a:solidFill>
+                <a:highlight>
+                  <a:srgbClr val="FFFF00"/>
+                </a:highlight>
+                <a:latin typeface="Arial" panose="020B0604020202020204" pitchFamily="34" charset="0"/>
+                <a:cs typeface="Arial" panose="020B0604020202020204" pitchFamily="34" charset="0"/>
+              </a:rPr>
+              <a:t>Lpi</a:t>
+            </a:r>
+            <a:r>
+              <a:rPr lang="en-US" sz="1200" dirty="0">
+                <a:solidFill>
+                  <a:srgbClr val="FF0000"/>
+                </a:solidFill>
+                <a:highlight>
+                  <a:srgbClr val="FFFF00"/>
+                </a:highlight>
+                <a:latin typeface="Arial" panose="020B0604020202020204" pitchFamily="34" charset="0"/>
+                <a:cs typeface="Arial" panose="020B0604020202020204" pitchFamily="34" charset="0"/>
+              </a:rPr>
+              <a:t> PARA TE y TM?</a:t>
+            </a:r>
+          </a:p>
+          <a:p>
+            <a:pPr algn="just"/>
             <a:endParaRPr lang="en-US" sz="1200" dirty="0">
               <a:latin typeface="Arial" panose="020B0604020202020204" pitchFamily="34" charset="0"/>
               <a:cs typeface="Arial" panose="020B0604020202020204" pitchFamily="34" charset="0"/>
@@ -11580,7 +11636,1158 @@
           </a:p>
           <a:p>
             <a:pPr algn="just"/>
+            <a:r>
+              <a:rPr lang="en-US" sz="1200" dirty="0">
+                <a:solidFill>
+                  <a:srgbClr val="FF0000"/>
+                </a:solidFill>
+                <a:latin typeface="Arial" panose="020B0604020202020204" pitchFamily="34" charset="0"/>
+                <a:cs typeface="Arial" panose="020B0604020202020204" pitchFamily="34" charset="0"/>
+              </a:rPr>
+              <a:t>Hacer </a:t>
+            </a:r>
+            <a:r>
+              <a:rPr lang="en-US" sz="1200" dirty="0" err="1">
+                <a:solidFill>
+                  <a:srgbClr val="FF0000"/>
+                </a:solidFill>
+                <a:latin typeface="Arial" panose="020B0604020202020204" pitchFamily="34" charset="0"/>
+                <a:cs typeface="Arial" panose="020B0604020202020204" pitchFamily="34" charset="0"/>
+              </a:rPr>
+              <a:t>una</a:t>
+            </a:r>
+            <a:r>
+              <a:rPr lang="en-US" sz="1200" dirty="0">
+                <a:solidFill>
+                  <a:srgbClr val="FF0000"/>
+                </a:solidFill>
+                <a:latin typeface="Arial" panose="020B0604020202020204" pitchFamily="34" charset="0"/>
+                <a:cs typeface="Arial" panose="020B0604020202020204" pitchFamily="34" charset="0"/>
+              </a:rPr>
+              <a:t> </a:t>
+            </a:r>
+            <a:r>
+              <a:rPr lang="en-US" sz="1200" dirty="0" err="1">
+                <a:solidFill>
+                  <a:srgbClr val="FF0000"/>
+                </a:solidFill>
+                <a:latin typeface="Arial" panose="020B0604020202020204" pitchFamily="34" charset="0"/>
+                <a:cs typeface="Arial" panose="020B0604020202020204" pitchFamily="34" charset="0"/>
+              </a:rPr>
+              <a:t>diapo</a:t>
+            </a:r>
+            <a:r>
+              <a:rPr lang="en-US" sz="1200" dirty="0">
+                <a:solidFill>
+                  <a:srgbClr val="FF0000"/>
+                </a:solidFill>
+                <a:latin typeface="Arial" panose="020B0604020202020204" pitchFamily="34" charset="0"/>
+                <a:cs typeface="Arial" panose="020B0604020202020204" pitchFamily="34" charset="0"/>
+              </a:rPr>
+              <a:t> </a:t>
+            </a:r>
+            <a:r>
+              <a:rPr lang="en-US" sz="1200" dirty="0" err="1">
+                <a:solidFill>
+                  <a:srgbClr val="FF0000"/>
+                </a:solidFill>
+                <a:latin typeface="Arial" panose="020B0604020202020204" pitchFamily="34" charset="0"/>
+                <a:cs typeface="Arial" panose="020B0604020202020204" pitchFamily="34" charset="0"/>
+              </a:rPr>
+              <a:t>después</a:t>
+            </a:r>
+            <a:r>
+              <a:rPr lang="en-US" sz="1200" dirty="0">
+                <a:solidFill>
+                  <a:srgbClr val="FF0000"/>
+                </a:solidFill>
+                <a:latin typeface="Arial" panose="020B0604020202020204" pitchFamily="34" charset="0"/>
+                <a:cs typeface="Arial" panose="020B0604020202020204" pitchFamily="34" charset="0"/>
+              </a:rPr>
+              <a:t> de </a:t>
+            </a:r>
+            <a:r>
+              <a:rPr lang="en-US" sz="1200" dirty="0" err="1">
+                <a:solidFill>
+                  <a:srgbClr val="FF0000"/>
+                </a:solidFill>
+                <a:latin typeface="Arial" panose="020B0604020202020204" pitchFamily="34" charset="0"/>
+                <a:cs typeface="Arial" panose="020B0604020202020204" pitchFamily="34" charset="0"/>
+              </a:rPr>
+              <a:t>esta</a:t>
+            </a:r>
+            <a:r>
+              <a:rPr lang="en-US" sz="1200" dirty="0">
+                <a:solidFill>
+                  <a:srgbClr val="FF0000"/>
+                </a:solidFill>
+                <a:latin typeface="Arial" panose="020B0604020202020204" pitchFamily="34" charset="0"/>
+                <a:cs typeface="Arial" panose="020B0604020202020204" pitchFamily="34" charset="0"/>
+              </a:rPr>
+              <a:t> y </a:t>
+            </a:r>
+            <a:r>
+              <a:rPr lang="en-US" sz="1200" dirty="0" err="1">
+                <a:solidFill>
+                  <a:srgbClr val="FF0000"/>
+                </a:solidFill>
+                <a:latin typeface="Arial" panose="020B0604020202020204" pitchFamily="34" charset="0"/>
+                <a:cs typeface="Arial" panose="020B0604020202020204" pitchFamily="34" charset="0"/>
+              </a:rPr>
+              <a:t>poner</a:t>
+            </a:r>
+            <a:r>
+              <a:rPr lang="en-US" sz="1200" dirty="0">
+                <a:solidFill>
+                  <a:srgbClr val="FF0000"/>
+                </a:solidFill>
+                <a:latin typeface="Arial" panose="020B0604020202020204" pitchFamily="34" charset="0"/>
+                <a:cs typeface="Arial" panose="020B0604020202020204" pitchFamily="34" charset="0"/>
+              </a:rPr>
+              <a:t> las </a:t>
+            </a:r>
+            <a:r>
+              <a:rPr lang="en-US" sz="1200" dirty="0" err="1">
+                <a:solidFill>
+                  <a:srgbClr val="FF0000"/>
+                </a:solidFill>
+                <a:latin typeface="Arial" panose="020B0604020202020204" pitchFamily="34" charset="0"/>
+                <a:cs typeface="Arial" panose="020B0604020202020204" pitchFamily="34" charset="0"/>
+              </a:rPr>
+              <a:t>gráficas</a:t>
+            </a:r>
+            <a:r>
+              <a:rPr lang="en-US" sz="1200" dirty="0">
+                <a:solidFill>
+                  <a:srgbClr val="FF0000"/>
+                </a:solidFill>
+                <a:latin typeface="Arial" panose="020B0604020202020204" pitchFamily="34" charset="0"/>
+                <a:cs typeface="Arial" panose="020B0604020202020204" pitchFamily="34" charset="0"/>
+              </a:rPr>
+              <a:t> y </a:t>
+            </a:r>
+            <a:r>
+              <a:rPr lang="en-US" sz="1200" dirty="0" err="1">
+                <a:solidFill>
+                  <a:srgbClr val="FF0000"/>
+                </a:solidFill>
+                <a:latin typeface="Arial" panose="020B0604020202020204" pitchFamily="34" charset="0"/>
+                <a:cs typeface="Arial" panose="020B0604020202020204" pitchFamily="34" charset="0"/>
+              </a:rPr>
+              <a:t>resultados</a:t>
+            </a:r>
+            <a:r>
+              <a:rPr lang="en-US" sz="1200" dirty="0">
+                <a:solidFill>
+                  <a:srgbClr val="FF0000"/>
+                </a:solidFill>
+                <a:latin typeface="Arial" panose="020B0604020202020204" pitchFamily="34" charset="0"/>
+                <a:cs typeface="Arial" panose="020B0604020202020204" pitchFamily="34" charset="0"/>
+              </a:rPr>
+              <a:t>, </a:t>
+            </a:r>
+            <a:r>
+              <a:rPr lang="en-US" sz="1200" dirty="0" err="1">
+                <a:solidFill>
+                  <a:srgbClr val="FF0000"/>
+                </a:solidFill>
+                <a:latin typeface="Arial" panose="020B0604020202020204" pitchFamily="34" charset="0"/>
+                <a:cs typeface="Arial" panose="020B0604020202020204" pitchFamily="34" charset="0"/>
+              </a:rPr>
+              <a:t>comentarlos</a:t>
+            </a:r>
+            <a:r>
+              <a:rPr lang="en-US" sz="1200" dirty="0">
+                <a:solidFill>
+                  <a:srgbClr val="FF0000"/>
+                </a:solidFill>
+                <a:latin typeface="Arial" panose="020B0604020202020204" pitchFamily="34" charset="0"/>
+                <a:cs typeface="Arial" panose="020B0604020202020204" pitchFamily="34" charset="0"/>
+              </a:rPr>
+              <a:t>.</a:t>
+            </a:r>
+          </a:p>
+          <a:p>
+            <a:pPr algn="just"/>
+            <a:r>
+              <a:rPr lang="en-US" sz="1200" dirty="0">
+                <a:solidFill>
+                  <a:srgbClr val="FF0000"/>
+                </a:solidFill>
+                <a:latin typeface="Arial" panose="020B0604020202020204" pitchFamily="34" charset="0"/>
+                <a:cs typeface="Arial" panose="020B0604020202020204" pitchFamily="34" charset="0"/>
+              </a:rPr>
+              <a:t>En </a:t>
+            </a:r>
+            <a:r>
+              <a:rPr lang="en-US" sz="1200" dirty="0" err="1">
+                <a:solidFill>
+                  <a:srgbClr val="FF0000"/>
+                </a:solidFill>
+                <a:latin typeface="Arial" panose="020B0604020202020204" pitchFamily="34" charset="0"/>
+                <a:cs typeface="Arial" panose="020B0604020202020204" pitchFamily="34" charset="0"/>
+              </a:rPr>
+              <a:t>función</a:t>
+            </a:r>
+            <a:r>
+              <a:rPr lang="en-US" sz="1200" dirty="0">
+                <a:solidFill>
+                  <a:srgbClr val="FF0000"/>
+                </a:solidFill>
+                <a:latin typeface="Arial" panose="020B0604020202020204" pitchFamily="34" charset="0"/>
+                <a:cs typeface="Arial" panose="020B0604020202020204" pitchFamily="34" charset="0"/>
+              </a:rPr>
+              <a:t> del gap, </a:t>
+            </a:r>
+            <a:r>
+              <a:rPr lang="en-US" sz="1200" dirty="0" err="1">
+                <a:solidFill>
+                  <a:srgbClr val="FF0000"/>
+                </a:solidFill>
+                <a:latin typeface="Arial" panose="020B0604020202020204" pitchFamily="34" charset="0"/>
+                <a:cs typeface="Arial" panose="020B0604020202020204" pitchFamily="34" charset="0"/>
+              </a:rPr>
+              <a:t>más</a:t>
+            </a:r>
+            <a:r>
+              <a:rPr lang="en-US" sz="1200" dirty="0">
+                <a:solidFill>
+                  <a:srgbClr val="FF0000"/>
+                </a:solidFill>
+                <a:latin typeface="Arial" panose="020B0604020202020204" pitchFamily="34" charset="0"/>
+                <a:cs typeface="Arial" panose="020B0604020202020204" pitchFamily="34" charset="0"/>
+              </a:rPr>
+              <a:t> </a:t>
+            </a:r>
+            <a:r>
+              <a:rPr lang="en-US" sz="1200" dirty="0" err="1">
+                <a:solidFill>
+                  <a:srgbClr val="FF0000"/>
+                </a:solidFill>
+                <a:latin typeface="Arial" panose="020B0604020202020204" pitchFamily="34" charset="0"/>
+                <a:cs typeface="Arial" panose="020B0604020202020204" pitchFamily="34" charset="0"/>
+              </a:rPr>
+              <a:t>acoplo</a:t>
+            </a:r>
+            <a:r>
+              <a:rPr lang="en-US" sz="1200" dirty="0">
+                <a:solidFill>
+                  <a:srgbClr val="FF0000"/>
+                </a:solidFill>
+                <a:latin typeface="Arial" panose="020B0604020202020204" pitchFamily="34" charset="0"/>
+                <a:cs typeface="Arial" panose="020B0604020202020204" pitchFamily="34" charset="0"/>
+              </a:rPr>
+              <a:t> o </a:t>
+            </a:r>
+            <a:r>
+              <a:rPr lang="en-US" sz="1200" dirty="0" err="1">
+                <a:solidFill>
+                  <a:srgbClr val="FF0000"/>
+                </a:solidFill>
+                <a:latin typeface="Arial" panose="020B0604020202020204" pitchFamily="34" charset="0"/>
+                <a:cs typeface="Arial" panose="020B0604020202020204" pitchFamily="34" charset="0"/>
+              </a:rPr>
+              <a:t>menos</a:t>
+            </a:r>
+            <a:r>
+              <a:rPr lang="en-US" sz="1200" dirty="0">
+                <a:solidFill>
+                  <a:srgbClr val="FF0000"/>
+                </a:solidFill>
+                <a:latin typeface="Arial" panose="020B0604020202020204" pitchFamily="34" charset="0"/>
+                <a:cs typeface="Arial" panose="020B0604020202020204" pitchFamily="34" charset="0"/>
+              </a:rPr>
+              <a:t>, van a </a:t>
+            </a:r>
+            <a:r>
+              <a:rPr lang="en-US" sz="1200" dirty="0" err="1">
+                <a:solidFill>
+                  <a:srgbClr val="FF0000"/>
+                </a:solidFill>
+                <a:latin typeface="Arial" panose="020B0604020202020204" pitchFamily="34" charset="0"/>
+                <a:cs typeface="Arial" panose="020B0604020202020204" pitchFamily="34" charset="0"/>
+              </a:rPr>
+              <a:t>hacer</a:t>
+            </a:r>
+            <a:r>
+              <a:rPr lang="en-US" sz="1200" dirty="0">
+                <a:solidFill>
+                  <a:srgbClr val="FF0000"/>
+                </a:solidFill>
+                <a:latin typeface="Arial" panose="020B0604020202020204" pitchFamily="34" charset="0"/>
+                <a:cs typeface="Arial" panose="020B0604020202020204" pitchFamily="34" charset="0"/>
+              </a:rPr>
+              <a:t> </a:t>
+            </a:r>
+            <a:r>
+              <a:rPr lang="en-US" sz="1200" dirty="0" err="1">
+                <a:solidFill>
+                  <a:srgbClr val="FF0000"/>
+                </a:solidFill>
+                <a:latin typeface="Arial" panose="020B0604020202020204" pitchFamily="34" charset="0"/>
+                <a:cs typeface="Arial" panose="020B0604020202020204" pitchFamily="34" charset="0"/>
+              </a:rPr>
+              <a:t>unos</a:t>
+            </a:r>
+            <a:r>
+              <a:rPr lang="en-US" sz="1200" dirty="0">
+                <a:solidFill>
+                  <a:srgbClr val="FF0000"/>
+                </a:solidFill>
+                <a:latin typeface="Arial" panose="020B0604020202020204" pitchFamily="34" charset="0"/>
+                <a:cs typeface="Arial" panose="020B0604020202020204" pitchFamily="34" charset="0"/>
+              </a:rPr>
+              <a:t> </a:t>
+            </a:r>
+            <a:r>
+              <a:rPr lang="en-US" sz="1200" dirty="0" err="1">
+                <a:solidFill>
+                  <a:srgbClr val="FF0000"/>
+                </a:solidFill>
+                <a:latin typeface="Arial" panose="020B0604020202020204" pitchFamily="34" charset="0"/>
+                <a:cs typeface="Arial" panose="020B0604020202020204" pitchFamily="34" charset="0"/>
+              </a:rPr>
+              <a:t>supermodos</a:t>
+            </a:r>
+            <a:r>
+              <a:rPr lang="en-US" sz="1200" dirty="0">
+                <a:solidFill>
+                  <a:srgbClr val="FF0000"/>
+                </a:solidFill>
+                <a:latin typeface="Arial" panose="020B0604020202020204" pitchFamily="34" charset="0"/>
+                <a:cs typeface="Arial" panose="020B0604020202020204" pitchFamily="34" charset="0"/>
+              </a:rPr>
+              <a:t> q se </a:t>
+            </a:r>
+            <a:r>
+              <a:rPr lang="en-US" sz="1200" dirty="0" err="1">
+                <a:solidFill>
+                  <a:srgbClr val="FF0000"/>
+                </a:solidFill>
+                <a:latin typeface="Arial" panose="020B0604020202020204" pitchFamily="34" charset="0"/>
+                <a:cs typeface="Arial" panose="020B0604020202020204" pitchFamily="34" charset="0"/>
+              </a:rPr>
+              <a:t>propagan</a:t>
+            </a:r>
+            <a:r>
+              <a:rPr lang="en-US" sz="1200" dirty="0">
+                <a:solidFill>
+                  <a:srgbClr val="FF0000"/>
+                </a:solidFill>
+                <a:latin typeface="Arial" panose="020B0604020202020204" pitchFamily="34" charset="0"/>
+                <a:cs typeface="Arial" panose="020B0604020202020204" pitchFamily="34" charset="0"/>
+              </a:rPr>
+              <a:t> x la </a:t>
+            </a:r>
+            <a:r>
+              <a:rPr lang="en-US" sz="1200" dirty="0" err="1">
+                <a:solidFill>
+                  <a:srgbClr val="FF0000"/>
+                </a:solidFill>
+                <a:latin typeface="Arial" panose="020B0604020202020204" pitchFamily="34" charset="0"/>
+                <a:cs typeface="Arial" panose="020B0604020202020204" pitchFamily="34" charset="0"/>
+              </a:rPr>
+              <a:t>estructura</a:t>
+            </a:r>
+            <a:r>
+              <a:rPr lang="en-US" sz="1200" dirty="0">
+                <a:solidFill>
+                  <a:srgbClr val="FF0000"/>
+                </a:solidFill>
+                <a:latin typeface="Arial" panose="020B0604020202020204" pitchFamily="34" charset="0"/>
+                <a:cs typeface="Arial" panose="020B0604020202020204" pitchFamily="34" charset="0"/>
+              </a:rPr>
+              <a:t>.</a:t>
+            </a:r>
+          </a:p>
+          <a:p>
+            <a:pPr algn="just"/>
             <a:endParaRPr lang="en-US" sz="1200" dirty="0">
+              <a:solidFill>
+                <a:srgbClr val="FF0000"/>
+              </a:solidFill>
+              <a:latin typeface="Arial" panose="020B0604020202020204" pitchFamily="34" charset="0"/>
+              <a:cs typeface="Arial" panose="020B0604020202020204" pitchFamily="34" charset="0"/>
+            </a:endParaRPr>
+          </a:p>
+          <a:p>
+            <a:pPr algn="just"/>
+            <a:r>
+              <a:rPr lang="en-US" sz="1200" dirty="0">
+                <a:solidFill>
+                  <a:srgbClr val="FF0000"/>
+                </a:solidFill>
+                <a:latin typeface="Arial" panose="020B0604020202020204" pitchFamily="34" charset="0"/>
+                <a:cs typeface="Arial" panose="020B0604020202020204" pitchFamily="34" charset="0"/>
+              </a:rPr>
+              <a:t>Se </a:t>
+            </a:r>
+            <a:r>
+              <a:rPr lang="en-US" sz="1200" dirty="0" err="1">
+                <a:solidFill>
+                  <a:srgbClr val="FF0000"/>
+                </a:solidFill>
+                <a:latin typeface="Arial" panose="020B0604020202020204" pitchFamily="34" charset="0"/>
+                <a:cs typeface="Arial" panose="020B0604020202020204" pitchFamily="34" charset="0"/>
+              </a:rPr>
+              <a:t>representa</a:t>
+            </a:r>
+            <a:r>
+              <a:rPr lang="en-US" sz="1200" dirty="0">
+                <a:solidFill>
+                  <a:srgbClr val="FF0000"/>
+                </a:solidFill>
+                <a:latin typeface="Arial" panose="020B0604020202020204" pitchFamily="34" charset="0"/>
+                <a:cs typeface="Arial" panose="020B0604020202020204" pitchFamily="34" charset="0"/>
+              </a:rPr>
+              <a:t> </a:t>
+            </a:r>
+            <a:r>
+              <a:rPr lang="en-US" sz="1200" dirty="0" err="1">
+                <a:solidFill>
+                  <a:srgbClr val="FF0000"/>
+                </a:solidFill>
+                <a:latin typeface="Arial" panose="020B0604020202020204" pitchFamily="34" charset="0"/>
+                <a:cs typeface="Arial" panose="020B0604020202020204" pitchFamily="34" charset="0"/>
+              </a:rPr>
+              <a:t>el</a:t>
+            </a:r>
+            <a:r>
+              <a:rPr lang="en-US" sz="1200" dirty="0">
+                <a:solidFill>
+                  <a:srgbClr val="FF0000"/>
+                </a:solidFill>
+                <a:latin typeface="Arial" panose="020B0604020202020204" pitchFamily="34" charset="0"/>
+                <a:cs typeface="Arial" panose="020B0604020202020204" pitchFamily="34" charset="0"/>
+              </a:rPr>
+              <a:t> campo Ex, </a:t>
+            </a:r>
+            <a:r>
+              <a:rPr lang="en-US" sz="1200" dirty="0" err="1">
+                <a:solidFill>
+                  <a:srgbClr val="FF0000"/>
+                </a:solidFill>
+                <a:latin typeface="Arial" panose="020B0604020202020204" pitchFamily="34" charset="0"/>
+                <a:cs typeface="Arial" panose="020B0604020202020204" pitchFamily="34" charset="0"/>
+              </a:rPr>
+              <a:t>el</a:t>
+            </a:r>
+            <a:r>
+              <a:rPr lang="en-US" sz="1200" dirty="0">
+                <a:solidFill>
+                  <a:srgbClr val="FF0000"/>
+                </a:solidFill>
+                <a:latin typeface="Arial" panose="020B0604020202020204" pitchFamily="34" charset="0"/>
+                <a:cs typeface="Arial" panose="020B0604020202020204" pitchFamily="34" charset="0"/>
+              </a:rPr>
+              <a:t> Ey </a:t>
+            </a:r>
+            <a:r>
+              <a:rPr lang="en-US" sz="1200" dirty="0" err="1">
+                <a:solidFill>
+                  <a:srgbClr val="FF0000"/>
+                </a:solidFill>
+                <a:latin typeface="Arial" panose="020B0604020202020204" pitchFamily="34" charset="0"/>
+                <a:cs typeface="Arial" panose="020B0604020202020204" pitchFamily="34" charset="0"/>
+              </a:rPr>
+              <a:t>sería</a:t>
+            </a:r>
+            <a:r>
+              <a:rPr lang="en-US" sz="1200" dirty="0">
+                <a:solidFill>
+                  <a:srgbClr val="FF0000"/>
+                </a:solidFill>
+                <a:latin typeface="Arial" panose="020B0604020202020204" pitchFamily="34" charset="0"/>
+                <a:cs typeface="Arial" panose="020B0604020202020204" pitchFamily="34" charset="0"/>
+              </a:rPr>
+              <a:t> </a:t>
+            </a:r>
+            <a:r>
+              <a:rPr lang="en-US" sz="1200" dirty="0" err="1">
+                <a:solidFill>
+                  <a:srgbClr val="FF0000"/>
+                </a:solidFill>
+                <a:latin typeface="Arial" panose="020B0604020202020204" pitchFamily="34" charset="0"/>
+                <a:cs typeface="Arial" panose="020B0604020202020204" pitchFamily="34" charset="0"/>
+              </a:rPr>
+              <a:t>prácticamente</a:t>
+            </a:r>
+            <a:r>
+              <a:rPr lang="en-US" sz="1200" dirty="0">
+                <a:solidFill>
+                  <a:srgbClr val="FF0000"/>
+                </a:solidFill>
+                <a:latin typeface="Arial" panose="020B0604020202020204" pitchFamily="34" charset="0"/>
+                <a:cs typeface="Arial" panose="020B0604020202020204" pitchFamily="34" charset="0"/>
+              </a:rPr>
+              <a:t> cero. Si </a:t>
+            </a:r>
+            <a:r>
+              <a:rPr lang="en-US" sz="1200" dirty="0" err="1">
+                <a:solidFill>
+                  <a:srgbClr val="FF0000"/>
+                </a:solidFill>
+                <a:latin typeface="Arial" panose="020B0604020202020204" pitchFamily="34" charset="0"/>
+                <a:cs typeface="Arial" panose="020B0604020202020204" pitchFamily="34" charset="0"/>
+              </a:rPr>
+              <a:t>vemos</a:t>
+            </a:r>
+            <a:r>
+              <a:rPr lang="en-US" sz="1200" dirty="0">
+                <a:solidFill>
+                  <a:srgbClr val="FF0000"/>
+                </a:solidFill>
+                <a:latin typeface="Arial" panose="020B0604020202020204" pitchFamily="34" charset="0"/>
+                <a:cs typeface="Arial" panose="020B0604020202020204" pitchFamily="34" charset="0"/>
+              </a:rPr>
+              <a:t> </a:t>
+            </a:r>
+            <a:r>
+              <a:rPr lang="en-US" sz="1200" dirty="0" err="1">
+                <a:solidFill>
+                  <a:srgbClr val="FF0000"/>
+                </a:solidFill>
+                <a:latin typeface="Arial" panose="020B0604020202020204" pitchFamily="34" charset="0"/>
+                <a:cs typeface="Arial" panose="020B0604020202020204" pitchFamily="34" charset="0"/>
+              </a:rPr>
+              <a:t>misma</a:t>
+            </a:r>
+            <a:r>
+              <a:rPr lang="en-US" sz="1200" dirty="0">
+                <a:solidFill>
+                  <a:srgbClr val="FF0000"/>
+                </a:solidFill>
+                <a:latin typeface="Arial" panose="020B0604020202020204" pitchFamily="34" charset="0"/>
+                <a:cs typeface="Arial" panose="020B0604020202020204" pitchFamily="34" charset="0"/>
+              </a:rPr>
+              <a:t> </a:t>
+            </a:r>
+            <a:r>
+              <a:rPr lang="en-US" sz="1200" dirty="0" err="1">
+                <a:solidFill>
+                  <a:srgbClr val="FF0000"/>
+                </a:solidFill>
+                <a:latin typeface="Arial" panose="020B0604020202020204" pitchFamily="34" charset="0"/>
+                <a:cs typeface="Arial" panose="020B0604020202020204" pitchFamily="34" charset="0"/>
+              </a:rPr>
+              <a:t>fase</a:t>
+            </a:r>
+            <a:r>
+              <a:rPr lang="en-US" sz="1200" dirty="0">
+                <a:solidFill>
+                  <a:srgbClr val="FF0000"/>
+                </a:solidFill>
+                <a:latin typeface="Arial" panose="020B0604020202020204" pitchFamily="34" charset="0"/>
+                <a:cs typeface="Arial" panose="020B0604020202020204" pitchFamily="34" charset="0"/>
+              </a:rPr>
+              <a:t>, modo par, </a:t>
+            </a:r>
+            <a:r>
+              <a:rPr lang="en-US" sz="1200" dirty="0" err="1">
+                <a:solidFill>
+                  <a:srgbClr val="FF0000"/>
+                </a:solidFill>
+                <a:latin typeface="Arial" panose="020B0604020202020204" pitchFamily="34" charset="0"/>
+                <a:cs typeface="Arial" panose="020B0604020202020204" pitchFamily="34" charset="0"/>
+              </a:rPr>
+              <a:t>si</a:t>
+            </a:r>
+            <a:r>
+              <a:rPr lang="en-US" sz="1200" dirty="0">
+                <a:solidFill>
+                  <a:srgbClr val="FF0000"/>
+                </a:solidFill>
+                <a:latin typeface="Arial" panose="020B0604020202020204" pitchFamily="34" charset="0"/>
+                <a:cs typeface="Arial" panose="020B0604020202020204" pitchFamily="34" charset="0"/>
+              </a:rPr>
+              <a:t> </a:t>
+            </a:r>
+            <a:r>
+              <a:rPr lang="en-US" sz="1200" dirty="0" err="1">
+                <a:solidFill>
+                  <a:srgbClr val="FF0000"/>
+                </a:solidFill>
+                <a:latin typeface="Arial" panose="020B0604020202020204" pitchFamily="34" charset="0"/>
+                <a:cs typeface="Arial" panose="020B0604020202020204" pitchFamily="34" charset="0"/>
+              </a:rPr>
+              <a:t>vemos</a:t>
+            </a:r>
+            <a:r>
+              <a:rPr lang="en-US" sz="1200" dirty="0">
+                <a:solidFill>
+                  <a:srgbClr val="FF0000"/>
+                </a:solidFill>
+                <a:latin typeface="Arial" panose="020B0604020202020204" pitchFamily="34" charset="0"/>
+                <a:cs typeface="Arial" panose="020B0604020202020204" pitchFamily="34" charset="0"/>
+              </a:rPr>
+              <a:t> </a:t>
+            </a:r>
+            <a:r>
+              <a:rPr lang="en-US" sz="1200" dirty="0" err="1">
+                <a:solidFill>
+                  <a:srgbClr val="FF0000"/>
+                </a:solidFill>
+                <a:latin typeface="Arial" panose="020B0604020202020204" pitchFamily="34" charset="0"/>
+                <a:cs typeface="Arial" panose="020B0604020202020204" pitchFamily="34" charset="0"/>
+              </a:rPr>
+              <a:t>contrafase</a:t>
+            </a:r>
+            <a:r>
+              <a:rPr lang="en-US" sz="1200" dirty="0">
+                <a:solidFill>
+                  <a:srgbClr val="FF0000"/>
+                </a:solidFill>
+                <a:latin typeface="Arial" panose="020B0604020202020204" pitchFamily="34" charset="0"/>
+                <a:cs typeface="Arial" panose="020B0604020202020204" pitchFamily="34" charset="0"/>
+              </a:rPr>
+              <a:t>, modo impar.</a:t>
+            </a:r>
+          </a:p>
+          <a:p>
+            <a:pPr algn="just"/>
+            <a:r>
+              <a:rPr lang="en-US" sz="1200" dirty="0">
+                <a:solidFill>
+                  <a:srgbClr val="FF0000"/>
+                </a:solidFill>
+                <a:latin typeface="Arial" panose="020B0604020202020204" pitchFamily="34" charset="0"/>
+                <a:cs typeface="Arial" panose="020B0604020202020204" pitchFamily="34" charset="0"/>
+              </a:rPr>
+              <a:t>Para </a:t>
+            </a:r>
+            <a:r>
+              <a:rPr lang="en-US" sz="1200" dirty="0" err="1">
+                <a:solidFill>
+                  <a:srgbClr val="FF0000"/>
+                </a:solidFill>
+                <a:latin typeface="Arial" panose="020B0604020202020204" pitchFamily="34" charset="0"/>
+                <a:cs typeface="Arial" panose="020B0604020202020204" pitchFamily="34" charset="0"/>
+              </a:rPr>
+              <a:t>los</a:t>
+            </a:r>
+            <a:r>
+              <a:rPr lang="en-US" sz="1200" dirty="0">
+                <a:solidFill>
+                  <a:srgbClr val="FF0000"/>
+                </a:solidFill>
+                <a:latin typeface="Arial" panose="020B0604020202020204" pitchFamily="34" charset="0"/>
+                <a:cs typeface="Arial" panose="020B0604020202020204" pitchFamily="34" charset="0"/>
+              </a:rPr>
+              <a:t> </a:t>
+            </a:r>
+            <a:r>
+              <a:rPr lang="en-US" sz="1200" dirty="0" err="1">
+                <a:solidFill>
+                  <a:srgbClr val="FF0000"/>
+                </a:solidFill>
+                <a:latin typeface="Arial" panose="020B0604020202020204" pitchFamily="34" charset="0"/>
+                <a:cs typeface="Arial" panose="020B0604020202020204" pitchFamily="34" charset="0"/>
+              </a:rPr>
+              <a:t>modos</a:t>
+            </a:r>
+            <a:r>
+              <a:rPr lang="en-US" sz="1200" dirty="0">
+                <a:solidFill>
+                  <a:srgbClr val="FF0000"/>
+                </a:solidFill>
+                <a:latin typeface="Arial" panose="020B0604020202020204" pitchFamily="34" charset="0"/>
+                <a:cs typeface="Arial" panose="020B0604020202020204" pitchFamily="34" charset="0"/>
+              </a:rPr>
+              <a:t> TM, Ey, la </a:t>
+            </a:r>
+            <a:r>
+              <a:rPr lang="en-US" sz="1200" dirty="0" err="1">
+                <a:solidFill>
+                  <a:srgbClr val="FF0000"/>
+                </a:solidFill>
+                <a:latin typeface="Arial" panose="020B0604020202020204" pitchFamily="34" charset="0"/>
+                <a:cs typeface="Arial" panose="020B0604020202020204" pitchFamily="34" charset="0"/>
+              </a:rPr>
+              <a:t>vbariación</a:t>
+            </a:r>
+            <a:r>
+              <a:rPr lang="en-US" sz="1200" dirty="0">
+                <a:solidFill>
+                  <a:srgbClr val="FF0000"/>
+                </a:solidFill>
+                <a:latin typeface="Arial" panose="020B0604020202020204" pitchFamily="34" charset="0"/>
+                <a:cs typeface="Arial" panose="020B0604020202020204" pitchFamily="34" charset="0"/>
+              </a:rPr>
+              <a:t> es vertical, modo par e impar, </a:t>
+            </a:r>
+            <a:r>
+              <a:rPr lang="en-US" sz="1200" dirty="0" err="1">
+                <a:solidFill>
+                  <a:srgbClr val="FF0000"/>
+                </a:solidFill>
+                <a:latin typeface="Arial" panose="020B0604020202020204" pitchFamily="34" charset="0"/>
+                <a:cs typeface="Arial" panose="020B0604020202020204" pitchFamily="34" charset="0"/>
+              </a:rPr>
+              <a:t>misma</a:t>
+            </a:r>
+            <a:r>
+              <a:rPr lang="en-US" sz="1200" dirty="0">
+                <a:solidFill>
+                  <a:srgbClr val="FF0000"/>
+                </a:solidFill>
+                <a:latin typeface="Arial" panose="020B0604020202020204" pitchFamily="34" charset="0"/>
+                <a:cs typeface="Arial" panose="020B0604020202020204" pitchFamily="34" charset="0"/>
+              </a:rPr>
+              <a:t> o </a:t>
+            </a:r>
+            <a:r>
+              <a:rPr lang="en-US" sz="1200" dirty="0" err="1">
+                <a:solidFill>
+                  <a:srgbClr val="FF0000"/>
+                </a:solidFill>
+                <a:latin typeface="Arial" panose="020B0604020202020204" pitchFamily="34" charset="0"/>
+                <a:cs typeface="Arial" panose="020B0604020202020204" pitchFamily="34" charset="0"/>
+              </a:rPr>
+              <a:t>contrafase</a:t>
+            </a:r>
+            <a:r>
+              <a:rPr lang="en-US" sz="1200" dirty="0">
+                <a:solidFill>
+                  <a:srgbClr val="FF0000"/>
+                </a:solidFill>
+                <a:latin typeface="Arial" panose="020B0604020202020204" pitchFamily="34" charset="0"/>
+                <a:cs typeface="Arial" panose="020B0604020202020204" pitchFamily="34" charset="0"/>
+              </a:rPr>
+              <a:t>.</a:t>
+            </a:r>
+          </a:p>
+          <a:p>
+            <a:pPr algn="just"/>
+            <a:r>
+              <a:rPr lang="en-US" sz="1200" dirty="0">
+                <a:solidFill>
+                  <a:srgbClr val="FF0000"/>
+                </a:solidFill>
+                <a:latin typeface="Arial" panose="020B0604020202020204" pitchFamily="34" charset="0"/>
+                <a:cs typeface="Arial" panose="020B0604020202020204" pitchFamily="34" charset="0"/>
+              </a:rPr>
+              <a:t>Estamos </a:t>
+            </a:r>
+            <a:r>
+              <a:rPr lang="en-US" sz="1200" dirty="0" err="1">
+                <a:solidFill>
+                  <a:srgbClr val="FF0000"/>
+                </a:solidFill>
+                <a:latin typeface="Arial" panose="020B0604020202020204" pitchFamily="34" charset="0"/>
+                <a:cs typeface="Arial" panose="020B0604020202020204" pitchFamily="34" charset="0"/>
+              </a:rPr>
+              <a:t>viendo</a:t>
+            </a:r>
+            <a:r>
+              <a:rPr lang="en-US" sz="1200" dirty="0">
+                <a:solidFill>
+                  <a:srgbClr val="FF0000"/>
+                </a:solidFill>
+                <a:latin typeface="Arial" panose="020B0604020202020204" pitchFamily="34" charset="0"/>
+                <a:cs typeface="Arial" panose="020B0604020202020204" pitchFamily="34" charset="0"/>
+              </a:rPr>
+              <a:t> </a:t>
+            </a:r>
+            <a:r>
+              <a:rPr lang="en-US" sz="1200" dirty="0" err="1">
+                <a:solidFill>
+                  <a:srgbClr val="FF0000"/>
+                </a:solidFill>
+                <a:latin typeface="Arial" panose="020B0604020202020204" pitchFamily="34" charset="0"/>
+                <a:cs typeface="Arial" panose="020B0604020202020204" pitchFamily="34" charset="0"/>
+              </a:rPr>
+              <a:t>los</a:t>
+            </a:r>
+            <a:r>
+              <a:rPr lang="en-US" sz="1200" dirty="0">
+                <a:solidFill>
+                  <a:srgbClr val="FF0000"/>
+                </a:solidFill>
+                <a:latin typeface="Arial" panose="020B0604020202020204" pitchFamily="34" charset="0"/>
+                <a:cs typeface="Arial" panose="020B0604020202020204" pitchFamily="34" charset="0"/>
+              </a:rPr>
+              <a:t> </a:t>
+            </a:r>
+            <a:r>
+              <a:rPr lang="en-US" sz="1200" dirty="0" err="1">
+                <a:solidFill>
+                  <a:srgbClr val="FF0000"/>
+                </a:solidFill>
+                <a:latin typeface="Arial" panose="020B0604020202020204" pitchFamily="34" charset="0"/>
+                <a:cs typeface="Arial" panose="020B0604020202020204" pitchFamily="34" charset="0"/>
+              </a:rPr>
+              <a:t>supermodos</a:t>
+            </a:r>
+            <a:r>
+              <a:rPr lang="en-US" sz="1200" dirty="0">
+                <a:solidFill>
+                  <a:srgbClr val="FF0000"/>
+                </a:solidFill>
+                <a:latin typeface="Arial" panose="020B0604020202020204" pitchFamily="34" charset="0"/>
+                <a:cs typeface="Arial" panose="020B0604020202020204" pitchFamily="34" charset="0"/>
+              </a:rPr>
+              <a:t> q se </a:t>
+            </a:r>
+            <a:r>
+              <a:rPr lang="en-US" sz="1200" dirty="0" err="1">
+                <a:solidFill>
+                  <a:srgbClr val="FF0000"/>
+                </a:solidFill>
+                <a:latin typeface="Arial" panose="020B0604020202020204" pitchFamily="34" charset="0"/>
+                <a:cs typeface="Arial" panose="020B0604020202020204" pitchFamily="34" charset="0"/>
+              </a:rPr>
+              <a:t>propagan</a:t>
+            </a:r>
+            <a:r>
+              <a:rPr lang="en-US" sz="1200" dirty="0">
+                <a:solidFill>
+                  <a:srgbClr val="FF0000"/>
+                </a:solidFill>
+                <a:latin typeface="Arial" panose="020B0604020202020204" pitchFamily="34" charset="0"/>
+                <a:cs typeface="Arial" panose="020B0604020202020204" pitchFamily="34" charset="0"/>
+              </a:rPr>
+              <a:t> x la </a:t>
+            </a:r>
+            <a:r>
+              <a:rPr lang="en-US" sz="1200" dirty="0" err="1">
+                <a:solidFill>
+                  <a:srgbClr val="FF0000"/>
+                </a:solidFill>
+                <a:latin typeface="Arial" panose="020B0604020202020204" pitchFamily="34" charset="0"/>
+                <a:cs typeface="Arial" panose="020B0604020202020204" pitchFamily="34" charset="0"/>
+              </a:rPr>
+              <a:t>estructyra</a:t>
+            </a:r>
+            <a:r>
+              <a:rPr lang="en-US" sz="1200" dirty="0">
+                <a:solidFill>
+                  <a:srgbClr val="FF0000"/>
+                </a:solidFill>
+                <a:latin typeface="Arial" panose="020B0604020202020204" pitchFamily="34" charset="0"/>
+                <a:cs typeface="Arial" panose="020B0604020202020204" pitchFamily="34" charset="0"/>
+              </a:rPr>
+              <a:t>.</a:t>
+            </a:r>
+          </a:p>
+          <a:p>
+            <a:pPr algn="just"/>
+            <a:endParaRPr lang="en-US" sz="1200" dirty="0">
+              <a:solidFill>
+                <a:srgbClr val="FF0000"/>
+              </a:solidFill>
+              <a:latin typeface="Arial" panose="020B0604020202020204" pitchFamily="34" charset="0"/>
+              <a:cs typeface="Arial" panose="020B0604020202020204" pitchFamily="34" charset="0"/>
+            </a:endParaRPr>
+          </a:p>
+          <a:p>
+            <a:pPr algn="just"/>
+            <a:r>
+              <a:rPr lang="en-US" sz="1200" dirty="0">
+                <a:solidFill>
+                  <a:srgbClr val="FF0000"/>
+                </a:solidFill>
+                <a:latin typeface="Arial" panose="020B0604020202020204" pitchFamily="34" charset="0"/>
+                <a:cs typeface="Arial" panose="020B0604020202020204" pitchFamily="34" charset="0"/>
+              </a:rPr>
+              <a:t>La longitude de </a:t>
+            </a:r>
+            <a:r>
+              <a:rPr lang="en-US" sz="1200" dirty="0" err="1">
+                <a:solidFill>
+                  <a:srgbClr val="FF0000"/>
+                </a:solidFill>
+                <a:latin typeface="Arial" panose="020B0604020202020204" pitchFamily="34" charset="0"/>
+                <a:cs typeface="Arial" panose="020B0604020202020204" pitchFamily="34" charset="0"/>
+              </a:rPr>
+              <a:t>acoplo</a:t>
+            </a:r>
+            <a:r>
+              <a:rPr lang="en-US" sz="1200" dirty="0">
+                <a:solidFill>
+                  <a:srgbClr val="FF0000"/>
+                </a:solidFill>
+                <a:latin typeface="Arial" panose="020B0604020202020204" pitchFamily="34" charset="0"/>
+                <a:cs typeface="Arial" panose="020B0604020202020204" pitchFamily="34" charset="0"/>
+              </a:rPr>
+              <a:t> es la q a </a:t>
+            </a:r>
+            <a:r>
+              <a:rPr lang="en-US" sz="1200" dirty="0" err="1">
+                <a:solidFill>
+                  <a:srgbClr val="FF0000"/>
+                </a:solidFill>
+                <a:latin typeface="Arial" panose="020B0604020202020204" pitchFamily="34" charset="0"/>
+                <a:cs typeface="Arial" panose="020B0604020202020204" pitchFamily="34" charset="0"/>
+              </a:rPr>
+              <a:t>partir</a:t>
+            </a:r>
+            <a:r>
+              <a:rPr lang="en-US" sz="1200" dirty="0">
+                <a:solidFill>
+                  <a:srgbClr val="FF0000"/>
+                </a:solidFill>
+                <a:latin typeface="Arial" panose="020B0604020202020204" pitchFamily="34" charset="0"/>
+                <a:cs typeface="Arial" panose="020B0604020202020204" pitchFamily="34" charset="0"/>
+              </a:rPr>
+              <a:t> de la </a:t>
+            </a:r>
+            <a:r>
+              <a:rPr lang="en-US" sz="1200" dirty="0" err="1">
+                <a:solidFill>
+                  <a:srgbClr val="FF0000"/>
+                </a:solidFill>
+                <a:latin typeface="Arial" panose="020B0604020202020204" pitchFamily="34" charset="0"/>
+                <a:cs typeface="Arial" panose="020B0604020202020204" pitchFamily="34" charset="0"/>
+              </a:rPr>
+              <a:t>cual</a:t>
+            </a:r>
+            <a:r>
+              <a:rPr lang="en-US" sz="1200" dirty="0">
+                <a:solidFill>
+                  <a:srgbClr val="FF0000"/>
+                </a:solidFill>
+                <a:latin typeface="Arial" panose="020B0604020202020204" pitchFamily="34" charset="0"/>
+                <a:cs typeface="Arial" panose="020B0604020202020204" pitchFamily="34" charset="0"/>
+              </a:rPr>
+              <a:t> se van a </a:t>
+            </a:r>
+            <a:r>
+              <a:rPr lang="en-US" sz="1200" dirty="0" err="1">
+                <a:solidFill>
+                  <a:srgbClr val="FF0000"/>
+                </a:solidFill>
+                <a:latin typeface="Arial" panose="020B0604020202020204" pitchFamily="34" charset="0"/>
+                <a:cs typeface="Arial" panose="020B0604020202020204" pitchFamily="34" charset="0"/>
+              </a:rPr>
+              <a:t>acoplar</a:t>
+            </a:r>
+            <a:r>
+              <a:rPr lang="en-US" sz="1200" dirty="0">
+                <a:solidFill>
+                  <a:srgbClr val="FF0000"/>
+                </a:solidFill>
+                <a:latin typeface="Arial" panose="020B0604020202020204" pitchFamily="34" charset="0"/>
+                <a:cs typeface="Arial" panose="020B0604020202020204" pitchFamily="34" charset="0"/>
+              </a:rPr>
+              <a:t> ambas </a:t>
+            </a:r>
+            <a:r>
+              <a:rPr lang="en-US" sz="1200" dirty="0" err="1">
+                <a:solidFill>
+                  <a:srgbClr val="FF0000"/>
+                </a:solidFill>
+                <a:latin typeface="Arial" panose="020B0604020202020204" pitchFamily="34" charset="0"/>
+                <a:cs typeface="Arial" panose="020B0604020202020204" pitchFamily="34" charset="0"/>
+              </a:rPr>
+              <a:t>guias</a:t>
+            </a:r>
+            <a:r>
+              <a:rPr lang="en-US" sz="1200" dirty="0">
+                <a:solidFill>
+                  <a:srgbClr val="FF0000"/>
+                </a:solidFill>
+                <a:latin typeface="Arial" panose="020B0604020202020204" pitchFamily="34" charset="0"/>
+                <a:cs typeface="Arial" panose="020B0604020202020204" pitchFamily="34" charset="0"/>
+              </a:rPr>
+              <a:t>.</a:t>
+            </a:r>
+          </a:p>
+          <a:p>
+            <a:pPr algn="just"/>
+            <a:r>
+              <a:rPr lang="en-US" sz="1200" dirty="0" err="1">
+                <a:solidFill>
+                  <a:srgbClr val="FF0000"/>
+                </a:solidFill>
+                <a:latin typeface="Arial" panose="020B0604020202020204" pitchFamily="34" charset="0"/>
+                <a:cs typeface="Arial" panose="020B0604020202020204" pitchFamily="34" charset="0"/>
+              </a:rPr>
+              <a:t>Lpi</a:t>
+            </a:r>
+            <a:r>
+              <a:rPr lang="en-US" sz="1200" dirty="0">
+                <a:solidFill>
+                  <a:srgbClr val="FF0000"/>
+                </a:solidFill>
+                <a:latin typeface="Arial" panose="020B0604020202020204" pitchFamily="34" charset="0"/>
+                <a:cs typeface="Arial" panose="020B0604020202020204" pitchFamily="34" charset="0"/>
+              </a:rPr>
+              <a:t> es la longitude </a:t>
+            </a:r>
+            <a:r>
+              <a:rPr lang="en-US" sz="1200" dirty="0" err="1">
+                <a:solidFill>
+                  <a:srgbClr val="FF0000"/>
+                </a:solidFill>
+                <a:latin typeface="Arial" panose="020B0604020202020204" pitchFamily="34" charset="0"/>
+                <a:cs typeface="Arial" panose="020B0604020202020204" pitchFamily="34" charset="0"/>
+              </a:rPr>
+              <a:t>en</a:t>
+            </a:r>
+            <a:r>
+              <a:rPr lang="en-US" sz="1200" dirty="0">
+                <a:solidFill>
+                  <a:srgbClr val="FF0000"/>
+                </a:solidFill>
+                <a:latin typeface="Arial" panose="020B0604020202020204" pitchFamily="34" charset="0"/>
+                <a:cs typeface="Arial" panose="020B0604020202020204" pitchFamily="34" charset="0"/>
+              </a:rPr>
+              <a:t> la q se </a:t>
+            </a:r>
+            <a:r>
+              <a:rPr lang="en-US" sz="1200" dirty="0" err="1">
+                <a:solidFill>
+                  <a:srgbClr val="FF0000"/>
+                </a:solidFill>
+                <a:latin typeface="Arial" panose="020B0604020202020204" pitchFamily="34" charset="0"/>
+                <a:cs typeface="Arial" panose="020B0604020202020204" pitchFamily="34" charset="0"/>
+              </a:rPr>
+              <a:t>tranfiere</a:t>
+            </a:r>
+            <a:r>
+              <a:rPr lang="en-US" sz="1200" dirty="0">
+                <a:solidFill>
+                  <a:srgbClr val="FF0000"/>
+                </a:solidFill>
+                <a:latin typeface="Arial" panose="020B0604020202020204" pitchFamily="34" charset="0"/>
+                <a:cs typeface="Arial" panose="020B0604020202020204" pitchFamily="34" charset="0"/>
+              </a:rPr>
+              <a:t> </a:t>
+            </a:r>
+            <a:r>
+              <a:rPr lang="en-US" sz="1200" dirty="0" err="1">
+                <a:solidFill>
+                  <a:srgbClr val="FF0000"/>
+                </a:solidFill>
+                <a:latin typeface="Arial" panose="020B0604020202020204" pitchFamily="34" charset="0"/>
+                <a:cs typeface="Arial" panose="020B0604020202020204" pitchFamily="34" charset="0"/>
+              </a:rPr>
+              <a:t>toda</a:t>
+            </a:r>
+            <a:r>
+              <a:rPr lang="en-US" sz="1200" dirty="0">
+                <a:solidFill>
+                  <a:srgbClr val="FF0000"/>
+                </a:solidFill>
+                <a:latin typeface="Arial" panose="020B0604020202020204" pitchFamily="34" charset="0"/>
+                <a:cs typeface="Arial" panose="020B0604020202020204" pitchFamily="34" charset="0"/>
+              </a:rPr>
+              <a:t> la </a:t>
+            </a:r>
+            <a:r>
+              <a:rPr lang="en-US" sz="1200" dirty="0" err="1">
+                <a:solidFill>
+                  <a:srgbClr val="FF0000"/>
+                </a:solidFill>
+                <a:latin typeface="Arial" panose="020B0604020202020204" pitchFamily="34" charset="0"/>
+                <a:cs typeface="Arial" panose="020B0604020202020204" pitchFamily="34" charset="0"/>
+              </a:rPr>
+              <a:t>energía</a:t>
+            </a:r>
+            <a:r>
+              <a:rPr lang="en-US" sz="1200" dirty="0">
+                <a:solidFill>
+                  <a:srgbClr val="FF0000"/>
+                </a:solidFill>
+                <a:latin typeface="Arial" panose="020B0604020202020204" pitchFamily="34" charset="0"/>
+                <a:cs typeface="Arial" panose="020B0604020202020204" pitchFamily="34" charset="0"/>
+              </a:rPr>
+              <a:t> d </a:t>
+            </a:r>
+            <a:r>
+              <a:rPr lang="en-US" sz="1200" dirty="0" err="1">
+                <a:solidFill>
+                  <a:srgbClr val="FF0000"/>
+                </a:solidFill>
+                <a:latin typeface="Arial" panose="020B0604020202020204" pitchFamily="34" charset="0"/>
+                <a:cs typeface="Arial" panose="020B0604020202020204" pitchFamily="34" charset="0"/>
+              </a:rPr>
+              <a:t>euna</a:t>
+            </a:r>
+            <a:r>
+              <a:rPr lang="en-US" sz="1200" dirty="0">
+                <a:solidFill>
+                  <a:srgbClr val="FF0000"/>
+                </a:solidFill>
+                <a:latin typeface="Arial" panose="020B0604020202020204" pitchFamily="34" charset="0"/>
+                <a:cs typeface="Arial" panose="020B0604020202020204" pitchFamily="34" charset="0"/>
+              </a:rPr>
+              <a:t> a </a:t>
+            </a:r>
+            <a:r>
+              <a:rPr lang="en-US" sz="1200" dirty="0" err="1">
+                <a:solidFill>
+                  <a:srgbClr val="FF0000"/>
+                </a:solidFill>
+                <a:latin typeface="Arial" panose="020B0604020202020204" pitchFamily="34" charset="0"/>
+                <a:cs typeface="Arial" panose="020B0604020202020204" pitchFamily="34" charset="0"/>
+              </a:rPr>
+              <a:t>otra</a:t>
+            </a:r>
+            <a:r>
+              <a:rPr lang="en-US" sz="1200" dirty="0">
+                <a:solidFill>
+                  <a:srgbClr val="FF0000"/>
+                </a:solidFill>
+                <a:latin typeface="Arial" panose="020B0604020202020204" pitchFamily="34" charset="0"/>
+                <a:cs typeface="Arial" panose="020B0604020202020204" pitchFamily="34" charset="0"/>
+              </a:rPr>
+              <a:t>. = </a:t>
+            </a:r>
+            <a:r>
+              <a:rPr lang="en-US" sz="1200" dirty="0" err="1">
+                <a:solidFill>
+                  <a:srgbClr val="FF0000"/>
+                </a:solidFill>
+                <a:latin typeface="Arial" panose="020B0604020202020204" pitchFamily="34" charset="0"/>
+                <a:cs typeface="Arial" panose="020B0604020202020204" pitchFamily="34" charset="0"/>
+              </a:rPr>
+              <a:t>Logitud</a:t>
+            </a:r>
+            <a:r>
+              <a:rPr lang="en-US" sz="1200" dirty="0">
+                <a:solidFill>
+                  <a:srgbClr val="FF0000"/>
+                </a:solidFill>
+                <a:latin typeface="Arial" panose="020B0604020202020204" pitchFamily="34" charset="0"/>
+                <a:cs typeface="Arial" panose="020B0604020202020204" pitchFamily="34" charset="0"/>
+              </a:rPr>
+              <a:t> de </a:t>
+            </a:r>
+            <a:r>
+              <a:rPr lang="en-US" sz="1200" dirty="0" err="1">
+                <a:solidFill>
+                  <a:srgbClr val="FF0000"/>
+                </a:solidFill>
+                <a:latin typeface="Arial" panose="020B0604020202020204" pitchFamily="34" charset="0"/>
+                <a:cs typeface="Arial" panose="020B0604020202020204" pitchFamily="34" charset="0"/>
+              </a:rPr>
+              <a:t>acoplo</a:t>
+            </a:r>
+            <a:endParaRPr lang="en-US" sz="1200" dirty="0">
+              <a:solidFill>
+                <a:srgbClr val="FF0000"/>
+              </a:solidFill>
+              <a:latin typeface="Arial" panose="020B0604020202020204" pitchFamily="34" charset="0"/>
+              <a:cs typeface="Arial" panose="020B0604020202020204" pitchFamily="34" charset="0"/>
+            </a:endParaRPr>
+          </a:p>
+          <a:p>
+            <a:pPr algn="just"/>
+            <a:endParaRPr lang="en-US" sz="1200" dirty="0">
+              <a:solidFill>
+                <a:srgbClr val="FF0000"/>
+              </a:solidFill>
+              <a:latin typeface="Arial" panose="020B0604020202020204" pitchFamily="34" charset="0"/>
+              <a:cs typeface="Arial" panose="020B0604020202020204" pitchFamily="34" charset="0"/>
+            </a:endParaRPr>
+          </a:p>
+          <a:p>
+            <a:pPr algn="just"/>
+            <a:endParaRPr lang="en-US" sz="1200" dirty="0">
+              <a:solidFill>
+                <a:srgbClr val="FF0000"/>
+              </a:solidFill>
               <a:latin typeface="Arial" panose="020B0604020202020204" pitchFamily="34" charset="0"/>
               <a:cs typeface="Arial" panose="020B0604020202020204" pitchFamily="34" charset="0"/>
             </a:endParaRPr>
@@ -11811,7 +13018,7 @@
         <p:spPr>
           <a:xfrm>
             <a:off x="609441" y="4860334"/>
-            <a:ext cx="11199971" cy="1200329"/>
+            <a:ext cx="11199971" cy="1569660"/>
           </a:xfrm>
           <a:prstGeom prst="rect">
             <a:avLst/>
@@ -11848,6 +13055,199 @@
               <a:latin typeface="Arial" panose="020B0604020202020204" pitchFamily="34" charset="0"/>
               <a:cs typeface="Arial" panose="020B0604020202020204" pitchFamily="34" charset="0"/>
             </a:endParaRPr>
+          </a:p>
+          <a:p>
+            <a:pPr algn="just"/>
+            <a:r>
+              <a:rPr lang="en-US" sz="1200" dirty="0">
+                <a:solidFill>
+                  <a:srgbClr val="FF0000"/>
+                </a:solidFill>
+                <a:latin typeface="Arial" panose="020B0604020202020204" pitchFamily="34" charset="0"/>
+                <a:cs typeface="Arial" panose="020B0604020202020204" pitchFamily="34" charset="0"/>
+              </a:rPr>
+              <a:t>Hacer </a:t>
+            </a:r>
+            <a:r>
+              <a:rPr lang="en-US" sz="1200" dirty="0" err="1">
+                <a:solidFill>
+                  <a:srgbClr val="FF0000"/>
+                </a:solidFill>
+                <a:latin typeface="Arial" panose="020B0604020202020204" pitchFamily="34" charset="0"/>
+                <a:cs typeface="Arial" panose="020B0604020202020204" pitchFamily="34" charset="0"/>
+              </a:rPr>
+              <a:t>los</a:t>
+            </a:r>
+            <a:r>
+              <a:rPr lang="en-US" sz="1200" dirty="0">
+                <a:solidFill>
+                  <a:srgbClr val="FF0000"/>
+                </a:solidFill>
+                <a:latin typeface="Arial" panose="020B0604020202020204" pitchFamily="34" charset="0"/>
+                <a:cs typeface="Arial" panose="020B0604020202020204" pitchFamily="34" charset="0"/>
+              </a:rPr>
+              <a:t> </a:t>
+            </a:r>
+            <a:r>
+              <a:rPr lang="en-US" sz="1200" dirty="0" err="1">
+                <a:solidFill>
+                  <a:srgbClr val="FF0000"/>
+                </a:solidFill>
+                <a:latin typeface="Arial" panose="020B0604020202020204" pitchFamily="34" charset="0"/>
+                <a:cs typeface="Arial" panose="020B0604020202020204" pitchFamily="34" charset="0"/>
+              </a:rPr>
+              <a:t>cálculos</a:t>
+            </a:r>
+            <a:r>
+              <a:rPr lang="en-US" sz="1200" dirty="0">
+                <a:solidFill>
+                  <a:srgbClr val="FF0000"/>
+                </a:solidFill>
+                <a:latin typeface="Arial" panose="020B0604020202020204" pitchFamily="34" charset="0"/>
+                <a:cs typeface="Arial" panose="020B0604020202020204" pitchFamily="34" charset="0"/>
+              </a:rPr>
+              <a:t> q se </a:t>
+            </a:r>
+            <a:r>
+              <a:rPr lang="en-US" sz="1200" dirty="0" err="1">
+                <a:solidFill>
+                  <a:srgbClr val="FF0000"/>
+                </a:solidFill>
+                <a:latin typeface="Arial" panose="020B0604020202020204" pitchFamily="34" charset="0"/>
+                <a:cs typeface="Arial" panose="020B0604020202020204" pitchFamily="34" charset="0"/>
+              </a:rPr>
+              <a:t>piden</a:t>
+            </a:r>
+            <a:r>
+              <a:rPr lang="en-US" sz="1200" dirty="0">
+                <a:solidFill>
+                  <a:srgbClr val="FF0000"/>
+                </a:solidFill>
+                <a:latin typeface="Arial" panose="020B0604020202020204" pitchFamily="34" charset="0"/>
+                <a:cs typeface="Arial" panose="020B0604020202020204" pitchFamily="34" charset="0"/>
+              </a:rPr>
+              <a:t>, </a:t>
+            </a:r>
+            <a:r>
+              <a:rPr lang="en-US" sz="1200" dirty="0" err="1">
+                <a:solidFill>
+                  <a:srgbClr val="FF0000"/>
+                </a:solidFill>
+                <a:latin typeface="Arial" panose="020B0604020202020204" pitchFamily="34" charset="0"/>
+                <a:cs typeface="Arial" panose="020B0604020202020204" pitchFamily="34" charset="0"/>
+              </a:rPr>
+              <a:t>gráficas</a:t>
+            </a:r>
+            <a:r>
+              <a:rPr lang="en-US" sz="1200" dirty="0">
+                <a:solidFill>
+                  <a:srgbClr val="FF0000"/>
+                </a:solidFill>
+                <a:latin typeface="Arial" panose="020B0604020202020204" pitchFamily="34" charset="0"/>
+                <a:cs typeface="Arial" panose="020B0604020202020204" pitchFamily="34" charset="0"/>
+              </a:rPr>
+              <a:t> y </a:t>
+            </a:r>
+            <a:r>
+              <a:rPr lang="en-US" sz="1200" dirty="0" err="1">
+                <a:solidFill>
+                  <a:srgbClr val="FF0000"/>
+                </a:solidFill>
+                <a:latin typeface="Arial" panose="020B0604020202020204" pitchFamily="34" charset="0"/>
+                <a:cs typeface="Arial" panose="020B0604020202020204" pitchFamily="34" charset="0"/>
+              </a:rPr>
+              <a:t>comentar</a:t>
+            </a:r>
+            <a:endParaRPr lang="en-US" sz="1200" dirty="0">
+              <a:solidFill>
+                <a:srgbClr val="FF0000"/>
+              </a:solidFill>
+              <a:latin typeface="Arial" panose="020B0604020202020204" pitchFamily="34" charset="0"/>
+              <a:cs typeface="Arial" panose="020B0604020202020204" pitchFamily="34" charset="0"/>
+            </a:endParaRPr>
+          </a:p>
+          <a:p>
+            <a:pPr algn="just"/>
+            <a:r>
+              <a:rPr lang="en-US" sz="1200" dirty="0" err="1">
+                <a:solidFill>
+                  <a:srgbClr val="FF0000"/>
+                </a:solidFill>
+                <a:latin typeface="Arial" panose="020B0604020202020204" pitchFamily="34" charset="0"/>
+                <a:cs typeface="Arial" panose="020B0604020202020204" pitchFamily="34" charset="0"/>
+              </a:rPr>
+              <a:t>Relacionar</a:t>
+            </a:r>
+            <a:r>
+              <a:rPr lang="en-US" sz="1200" dirty="0">
+                <a:solidFill>
+                  <a:srgbClr val="FF0000"/>
+                </a:solidFill>
+                <a:latin typeface="Arial" panose="020B0604020202020204" pitchFamily="34" charset="0"/>
+                <a:cs typeface="Arial" panose="020B0604020202020204" pitchFamily="34" charset="0"/>
+              </a:rPr>
+              <a:t> la </a:t>
+            </a:r>
+            <a:r>
+              <a:rPr lang="en-US" sz="1200" dirty="0" err="1">
+                <a:solidFill>
+                  <a:srgbClr val="FF0000"/>
+                </a:solidFill>
+                <a:latin typeface="Arial" panose="020B0604020202020204" pitchFamily="34" charset="0"/>
+                <a:cs typeface="Arial" panose="020B0604020202020204" pitchFamily="34" charset="0"/>
+              </a:rPr>
+              <a:t>Lpi</a:t>
+            </a:r>
+            <a:r>
+              <a:rPr lang="en-US" sz="1200" dirty="0">
+                <a:solidFill>
+                  <a:srgbClr val="FF0000"/>
+                </a:solidFill>
+                <a:latin typeface="Arial" panose="020B0604020202020204" pitchFamily="34" charset="0"/>
+                <a:cs typeface="Arial" panose="020B0604020202020204" pitchFamily="34" charset="0"/>
+              </a:rPr>
+              <a:t> con la </a:t>
+            </a:r>
+            <a:r>
+              <a:rPr lang="en-US" sz="1200" dirty="0" err="1">
+                <a:solidFill>
+                  <a:srgbClr val="FF0000"/>
+                </a:solidFill>
+                <a:latin typeface="Arial" panose="020B0604020202020204" pitchFamily="34" charset="0"/>
+                <a:cs typeface="Arial" panose="020B0604020202020204" pitchFamily="34" charset="0"/>
+              </a:rPr>
+              <a:t>contante</a:t>
+            </a:r>
+            <a:r>
+              <a:rPr lang="en-US" sz="1200" dirty="0">
+                <a:solidFill>
+                  <a:srgbClr val="FF0000"/>
+                </a:solidFill>
+                <a:latin typeface="Arial" panose="020B0604020202020204" pitchFamily="34" charset="0"/>
+                <a:cs typeface="Arial" panose="020B0604020202020204" pitchFamily="34" charset="0"/>
+              </a:rPr>
+              <a:t> de </a:t>
+            </a:r>
+            <a:r>
+              <a:rPr lang="en-US" sz="1200" dirty="0" err="1">
+                <a:solidFill>
+                  <a:srgbClr val="FF0000"/>
+                </a:solidFill>
+                <a:latin typeface="Arial" panose="020B0604020202020204" pitchFamily="34" charset="0"/>
+                <a:cs typeface="Arial" panose="020B0604020202020204" pitchFamily="34" charset="0"/>
+              </a:rPr>
+              <a:t>acoplo</a:t>
+            </a:r>
+            <a:r>
+              <a:rPr lang="en-US" sz="1200" dirty="0">
+                <a:solidFill>
+                  <a:srgbClr val="FF0000"/>
+                </a:solidFill>
+                <a:latin typeface="Arial" panose="020B0604020202020204" pitchFamily="34" charset="0"/>
+                <a:cs typeface="Arial" panose="020B0604020202020204" pitchFamily="34" charset="0"/>
+              </a:rPr>
+              <a:t> K</a:t>
+            </a:r>
           </a:p>
           <a:p>
             <a:pPr algn="just"/>
@@ -12236,7 +13636,7 @@
         <p:spPr>
           <a:xfrm>
             <a:off x="609441" y="4860334"/>
-            <a:ext cx="11199971" cy="1200329"/>
+            <a:ext cx="11199971" cy="1569660"/>
           </a:xfrm>
           <a:prstGeom prst="rect">
             <a:avLst/>
@@ -12290,7 +13690,346 @@
           </a:p>
           <a:p>
             <a:pPr algn="just"/>
+            <a:r>
+              <a:rPr lang="en-US" sz="1200" dirty="0">
+                <a:solidFill>
+                  <a:srgbClr val="FF0000"/>
+                </a:solidFill>
+                <a:latin typeface="Arial" panose="020B0604020202020204" pitchFamily="34" charset="0"/>
+                <a:cs typeface="Arial" panose="020B0604020202020204" pitchFamily="34" charset="0"/>
+              </a:rPr>
+              <a:t>Ver </a:t>
+            </a:r>
+            <a:r>
+              <a:rPr lang="en-US" sz="1200" dirty="0" err="1">
+                <a:solidFill>
+                  <a:srgbClr val="FF0000"/>
+                </a:solidFill>
+                <a:latin typeface="Arial" panose="020B0604020202020204" pitchFamily="34" charset="0"/>
+                <a:cs typeface="Arial" panose="020B0604020202020204" pitchFamily="34" charset="0"/>
+              </a:rPr>
+              <a:t>como</a:t>
+            </a:r>
+            <a:r>
+              <a:rPr lang="en-US" sz="1200" dirty="0">
+                <a:solidFill>
+                  <a:srgbClr val="FF0000"/>
+                </a:solidFill>
+                <a:latin typeface="Arial" panose="020B0604020202020204" pitchFamily="34" charset="0"/>
+                <a:cs typeface="Arial" panose="020B0604020202020204" pitchFamily="34" charset="0"/>
+              </a:rPr>
+              <a:t> se </a:t>
+            </a:r>
+            <a:r>
+              <a:rPr lang="en-US" sz="1200" dirty="0" err="1">
+                <a:solidFill>
+                  <a:srgbClr val="FF0000"/>
+                </a:solidFill>
+                <a:latin typeface="Arial" panose="020B0604020202020204" pitchFamily="34" charset="0"/>
+                <a:cs typeface="Arial" panose="020B0604020202020204" pitchFamily="34" charset="0"/>
+              </a:rPr>
+              <a:t>acopla</a:t>
+            </a:r>
+            <a:r>
+              <a:rPr lang="en-US" sz="1200" dirty="0">
+                <a:solidFill>
+                  <a:srgbClr val="FF0000"/>
+                </a:solidFill>
+                <a:latin typeface="Arial" panose="020B0604020202020204" pitchFamily="34" charset="0"/>
+                <a:cs typeface="Arial" panose="020B0604020202020204" pitchFamily="34" charset="0"/>
+              </a:rPr>
+              <a:t> la luz de </a:t>
+            </a:r>
+            <a:r>
+              <a:rPr lang="en-US" sz="1200" dirty="0" err="1">
+                <a:solidFill>
+                  <a:srgbClr val="FF0000"/>
+                </a:solidFill>
+                <a:latin typeface="Arial" panose="020B0604020202020204" pitchFamily="34" charset="0"/>
+                <a:cs typeface="Arial" panose="020B0604020202020204" pitchFamily="34" charset="0"/>
+              </a:rPr>
+              <a:t>una</a:t>
+            </a:r>
+            <a:r>
+              <a:rPr lang="en-US" sz="1200" dirty="0">
+                <a:solidFill>
+                  <a:srgbClr val="FF0000"/>
+                </a:solidFill>
+                <a:latin typeface="Arial" panose="020B0604020202020204" pitchFamily="34" charset="0"/>
+                <a:cs typeface="Arial" panose="020B0604020202020204" pitchFamily="34" charset="0"/>
+              </a:rPr>
+              <a:t> </a:t>
+            </a:r>
+            <a:r>
+              <a:rPr lang="en-US" sz="1200" dirty="0" err="1">
+                <a:solidFill>
+                  <a:srgbClr val="FF0000"/>
+                </a:solidFill>
+                <a:latin typeface="Arial" panose="020B0604020202020204" pitchFamily="34" charset="0"/>
+                <a:cs typeface="Arial" panose="020B0604020202020204" pitchFamily="34" charset="0"/>
+              </a:rPr>
+              <a:t>guía</a:t>
+            </a:r>
+            <a:r>
+              <a:rPr lang="en-US" sz="1200" dirty="0">
+                <a:solidFill>
+                  <a:srgbClr val="FF0000"/>
+                </a:solidFill>
+                <a:latin typeface="Arial" panose="020B0604020202020204" pitchFamily="34" charset="0"/>
+                <a:cs typeface="Arial" panose="020B0604020202020204" pitchFamily="34" charset="0"/>
+              </a:rPr>
+              <a:t> a la </a:t>
+            </a:r>
+            <a:r>
+              <a:rPr lang="en-US" sz="1200" dirty="0" err="1">
+                <a:solidFill>
+                  <a:srgbClr val="FF0000"/>
+                </a:solidFill>
+                <a:latin typeface="Arial" panose="020B0604020202020204" pitchFamily="34" charset="0"/>
+                <a:cs typeface="Arial" panose="020B0604020202020204" pitchFamily="34" charset="0"/>
+              </a:rPr>
+              <a:t>otra</a:t>
+            </a:r>
+            <a:r>
+              <a:rPr lang="en-US" sz="1200" dirty="0">
+                <a:solidFill>
+                  <a:srgbClr val="FF0000"/>
+                </a:solidFill>
+                <a:latin typeface="Arial" panose="020B0604020202020204" pitchFamily="34" charset="0"/>
+                <a:cs typeface="Arial" panose="020B0604020202020204" pitchFamily="34" charset="0"/>
+              </a:rPr>
+              <a:t>. SOLAMENTE HAY QUE TOCAR LOS PARÁMETROS QUE PONE # Student, NADA MÁS.</a:t>
+            </a:r>
+          </a:p>
+          <a:p>
+            <a:pPr algn="just"/>
+            <a:r>
+              <a:rPr lang="en-US" sz="1200" dirty="0" err="1">
+                <a:solidFill>
+                  <a:srgbClr val="FF0000"/>
+                </a:solidFill>
+                <a:latin typeface="Arial" panose="020B0604020202020204" pitchFamily="34" charset="0"/>
+                <a:cs typeface="Arial" panose="020B0604020202020204" pitchFamily="34" charset="0"/>
+              </a:rPr>
+              <a:t>Ir</a:t>
+            </a:r>
+            <a:r>
+              <a:rPr lang="en-US" sz="1200" dirty="0">
+                <a:solidFill>
+                  <a:srgbClr val="FF0000"/>
+                </a:solidFill>
+                <a:latin typeface="Arial" panose="020B0604020202020204" pitchFamily="34" charset="0"/>
+                <a:cs typeface="Arial" panose="020B0604020202020204" pitchFamily="34" charset="0"/>
+              </a:rPr>
+              <a:t> </a:t>
+            </a:r>
+            <a:r>
+              <a:rPr lang="en-US" sz="1200" dirty="0" err="1">
+                <a:solidFill>
+                  <a:srgbClr val="FF0000"/>
+                </a:solidFill>
+                <a:latin typeface="Arial" panose="020B0604020202020204" pitchFamily="34" charset="0"/>
+                <a:cs typeface="Arial" panose="020B0604020202020204" pitchFamily="34" charset="0"/>
+              </a:rPr>
+              <a:t>cambiando</a:t>
+            </a:r>
+            <a:r>
+              <a:rPr lang="en-US" sz="1200" dirty="0">
+                <a:solidFill>
+                  <a:srgbClr val="FF0000"/>
+                </a:solidFill>
+                <a:latin typeface="Arial" panose="020B0604020202020204" pitchFamily="34" charset="0"/>
+                <a:cs typeface="Arial" panose="020B0604020202020204" pitchFamily="34" charset="0"/>
+              </a:rPr>
+              <a:t> </a:t>
+            </a:r>
+            <a:r>
+              <a:rPr lang="en-US" sz="1200" dirty="0" err="1">
+                <a:solidFill>
+                  <a:srgbClr val="FF0000"/>
+                </a:solidFill>
+                <a:latin typeface="Arial" panose="020B0604020202020204" pitchFamily="34" charset="0"/>
+                <a:cs typeface="Arial" panose="020B0604020202020204" pitchFamily="34" charset="0"/>
+              </a:rPr>
+              <a:t>el</a:t>
+            </a:r>
+            <a:r>
+              <a:rPr lang="en-US" sz="1200" dirty="0">
+                <a:solidFill>
+                  <a:srgbClr val="FF0000"/>
+                </a:solidFill>
+                <a:latin typeface="Arial" panose="020B0604020202020204" pitchFamily="34" charset="0"/>
+                <a:cs typeface="Arial" panose="020B0604020202020204" pitchFamily="34" charset="0"/>
+              </a:rPr>
+              <a:t> gap </a:t>
+            </a:r>
+            <a:r>
+              <a:rPr lang="en-US" sz="1200" dirty="0" err="1">
+                <a:solidFill>
+                  <a:srgbClr val="FF0000"/>
+                </a:solidFill>
+                <a:latin typeface="Arial" panose="020B0604020202020204" pitchFamily="34" charset="0"/>
+                <a:cs typeface="Arial" panose="020B0604020202020204" pitchFamily="34" charset="0"/>
+              </a:rPr>
+              <a:t>en</a:t>
+            </a:r>
+            <a:r>
+              <a:rPr lang="en-US" sz="1200" dirty="0">
+                <a:solidFill>
+                  <a:srgbClr val="FF0000"/>
+                </a:solidFill>
+                <a:latin typeface="Arial" panose="020B0604020202020204" pitchFamily="34" charset="0"/>
+                <a:cs typeface="Arial" panose="020B0604020202020204" pitchFamily="34" charset="0"/>
+              </a:rPr>
+              <a:t> pasos de 0,2, </a:t>
+            </a:r>
+            <a:r>
+              <a:rPr lang="en-US" sz="1200" dirty="0" err="1">
+                <a:solidFill>
+                  <a:srgbClr val="FF0000"/>
+                </a:solidFill>
+                <a:latin typeface="Arial" panose="020B0604020202020204" pitchFamily="34" charset="0"/>
+                <a:cs typeface="Arial" panose="020B0604020202020204" pitchFamily="34" charset="0"/>
+              </a:rPr>
+              <a:t>manualmente</a:t>
+            </a:r>
+            <a:r>
+              <a:rPr lang="en-US" sz="1200" dirty="0">
+                <a:solidFill>
+                  <a:srgbClr val="FF0000"/>
+                </a:solidFill>
+                <a:latin typeface="Arial" panose="020B0604020202020204" pitchFamily="34" charset="0"/>
+                <a:cs typeface="Arial" panose="020B0604020202020204" pitchFamily="34" charset="0"/>
+              </a:rPr>
+              <a:t> sin for y </a:t>
+            </a:r>
+            <a:r>
+              <a:rPr lang="en-US" sz="1200" dirty="0" err="1">
+                <a:solidFill>
+                  <a:srgbClr val="FF0000"/>
+                </a:solidFill>
+                <a:latin typeface="Arial" panose="020B0604020202020204" pitchFamily="34" charset="0"/>
+                <a:cs typeface="Arial" panose="020B0604020202020204" pitchFamily="34" charset="0"/>
+              </a:rPr>
+              <a:t>vamos</a:t>
+            </a:r>
+            <a:r>
+              <a:rPr lang="en-US" sz="1200" dirty="0">
+                <a:solidFill>
+                  <a:srgbClr val="FF0000"/>
+                </a:solidFill>
+                <a:latin typeface="Arial" panose="020B0604020202020204" pitchFamily="34" charset="0"/>
+                <a:cs typeface="Arial" panose="020B0604020202020204" pitchFamily="34" charset="0"/>
+              </a:rPr>
+              <a:t> </a:t>
+            </a:r>
+            <a:r>
+              <a:rPr lang="en-US" sz="1200" dirty="0" err="1">
+                <a:solidFill>
+                  <a:srgbClr val="FF0000"/>
+                </a:solidFill>
+                <a:latin typeface="Arial" panose="020B0604020202020204" pitchFamily="34" charset="0"/>
+                <a:cs typeface="Arial" panose="020B0604020202020204" pitchFamily="34" charset="0"/>
+              </a:rPr>
+              <a:t>viendo</a:t>
+            </a:r>
+            <a:r>
+              <a:rPr lang="en-US" sz="1200" dirty="0">
+                <a:solidFill>
+                  <a:srgbClr val="FF0000"/>
+                </a:solidFill>
+                <a:latin typeface="Arial" panose="020B0604020202020204" pitchFamily="34" charset="0"/>
+                <a:cs typeface="Arial" panose="020B0604020202020204" pitchFamily="34" charset="0"/>
+              </a:rPr>
+              <a:t> y </a:t>
+            </a:r>
+            <a:r>
+              <a:rPr lang="en-US" sz="1200" dirty="0" err="1">
+                <a:solidFill>
+                  <a:srgbClr val="FF0000"/>
+                </a:solidFill>
+                <a:latin typeface="Arial" panose="020B0604020202020204" pitchFamily="34" charset="0"/>
+                <a:cs typeface="Arial" panose="020B0604020202020204" pitchFamily="34" charset="0"/>
+              </a:rPr>
+              <a:t>capturando</a:t>
+            </a:r>
+            <a:r>
+              <a:rPr lang="en-US" sz="1200" dirty="0">
+                <a:solidFill>
+                  <a:srgbClr val="FF0000"/>
+                </a:solidFill>
+                <a:latin typeface="Arial" panose="020B0604020202020204" pitchFamily="34" charset="0"/>
+                <a:cs typeface="Arial" panose="020B0604020202020204" pitchFamily="34" charset="0"/>
+              </a:rPr>
+              <a:t> </a:t>
+            </a:r>
+            <a:r>
+              <a:rPr lang="en-US" sz="1200" dirty="0" err="1">
+                <a:solidFill>
+                  <a:srgbClr val="FF0000"/>
+                </a:solidFill>
+                <a:latin typeface="Arial" panose="020B0604020202020204" pitchFamily="34" charset="0"/>
+                <a:cs typeface="Arial" panose="020B0604020202020204" pitchFamily="34" charset="0"/>
+              </a:rPr>
+              <a:t>los</a:t>
+            </a:r>
+            <a:r>
+              <a:rPr lang="en-US" sz="1200" dirty="0">
+                <a:solidFill>
+                  <a:srgbClr val="FF0000"/>
+                </a:solidFill>
+                <a:latin typeface="Arial" panose="020B0604020202020204" pitchFamily="34" charset="0"/>
+                <a:cs typeface="Arial" panose="020B0604020202020204" pitchFamily="34" charset="0"/>
+              </a:rPr>
+              <a:t> </a:t>
+            </a:r>
+            <a:r>
+              <a:rPr lang="en-US" sz="1200" dirty="0" err="1">
+                <a:solidFill>
+                  <a:srgbClr val="FF0000"/>
+                </a:solidFill>
+                <a:latin typeface="Arial" panose="020B0604020202020204" pitchFamily="34" charset="0"/>
+                <a:cs typeface="Arial" panose="020B0604020202020204" pitchFamily="34" charset="0"/>
+              </a:rPr>
+              <a:t>resultados</a:t>
+            </a:r>
+            <a:r>
+              <a:rPr lang="en-US" sz="1200" dirty="0">
+                <a:solidFill>
+                  <a:srgbClr val="FF0000"/>
+                </a:solidFill>
+                <a:latin typeface="Arial" panose="020B0604020202020204" pitchFamily="34" charset="0"/>
+                <a:cs typeface="Arial" panose="020B0604020202020204" pitchFamily="34" charset="0"/>
+              </a:rPr>
+              <a:t> y </a:t>
+            </a:r>
+            <a:r>
+              <a:rPr lang="en-US" sz="1200" dirty="0" err="1">
+                <a:solidFill>
+                  <a:srgbClr val="FF0000"/>
+                </a:solidFill>
+                <a:latin typeface="Arial" panose="020B0604020202020204" pitchFamily="34" charset="0"/>
+                <a:cs typeface="Arial" panose="020B0604020202020204" pitchFamily="34" charset="0"/>
+              </a:rPr>
+              <a:t>comentando</a:t>
+            </a:r>
+            <a:r>
+              <a:rPr lang="en-US" sz="1200" dirty="0">
+                <a:solidFill>
+                  <a:srgbClr val="FF0000"/>
+                </a:solidFill>
+                <a:latin typeface="Arial" panose="020B0604020202020204" pitchFamily="34" charset="0"/>
+                <a:cs typeface="Arial" panose="020B0604020202020204" pitchFamily="34" charset="0"/>
+              </a:rPr>
+              <a:t>.</a:t>
+            </a:r>
+          </a:p>
+          <a:p>
+            <a:pPr algn="just"/>
             <a:endParaRPr lang="en-US" sz="1200" dirty="0">
+              <a:solidFill>
+                <a:srgbClr val="FF0000"/>
+              </a:solidFill>
               <a:latin typeface="Arial" panose="020B0604020202020204" pitchFamily="34" charset="0"/>
               <a:cs typeface="Arial" panose="020B0604020202020204" pitchFamily="34" charset="0"/>
             </a:endParaRPr>
@@ -12332,8 +14071,8 @@
         </p:nvSpPr>
         <p:spPr>
           <a:xfrm>
-            <a:off x="609441" y="1418373"/>
-            <a:ext cx="11199971" cy="3306028"/>
+            <a:off x="228601" y="1418373"/>
+            <a:ext cx="11734800" cy="3171821"/>
           </a:xfrm>
           <a:prstGeom prst="rect">
             <a:avLst/>
@@ -12372,10 +14111,109 @@
       </p:sp>
       <p:sp>
         <p:nvSpPr>
-          <p:cNvPr id="8" name="CuadroTexto 7">
+          <p:cNvPr id="4" name="Rectángulo 3">
             <a:extLst>
               <a:ext uri="{FF2B5EF4-FFF2-40B4-BE49-F238E27FC236}">
-                <a16:creationId xmlns:a16="http://schemas.microsoft.com/office/drawing/2014/main" id="{1EF5BFDA-8EC1-8C73-A932-F36C4DB93C73}"/>
+                <a16:creationId xmlns:a16="http://schemas.microsoft.com/office/drawing/2014/main" id="{E79CB579-8A40-521B-C5FD-7C236A05F796}"/>
+              </a:ext>
+            </a:extLst>
+          </p:cNvPr>
+          <p:cNvSpPr/>
+          <p:nvPr/>
+        </p:nvSpPr>
+        <p:spPr>
+          <a:xfrm>
+            <a:off x="228600" y="1418372"/>
+            <a:ext cx="1950981" cy="3151116"/>
+          </a:xfrm>
+          <a:prstGeom prst="rect">
+            <a:avLst/>
+          </a:prstGeom>
+          <a:noFill/>
+          <a:ln w="28575">
+            <a:solidFill>
+              <a:srgbClr val="E0700D"/>
+            </a:solidFill>
+          </a:ln>
+        </p:spPr>
+        <p:style>
+          <a:lnRef idx="2">
+            <a:schemeClr val="accent1">
+              <a:shade val="15000"/>
+            </a:schemeClr>
+          </a:lnRef>
+          <a:fillRef idx="1">
+            <a:schemeClr val="accent1"/>
+          </a:fillRef>
+          <a:effectRef idx="0">
+            <a:schemeClr val="accent1"/>
+          </a:effectRef>
+          <a:fontRef idx="minor">
+            <a:schemeClr val="lt1"/>
+          </a:fontRef>
+        </p:style>
+        <p:txBody>
+          <a:bodyPr rtlCol="0" anchor="ctr"/>
+          <a:lstStyle/>
+          <a:p>
+            <a:pPr algn="ctr"/>
+            <a:endParaRPr lang="en-US"/>
+          </a:p>
+        </p:txBody>
+      </p:sp>
+      <p:pic>
+        <p:nvPicPr>
+          <p:cNvPr id="1026" name="Picture 2">
+            <a:extLst>
+              <a:ext uri="{FF2B5EF4-FFF2-40B4-BE49-F238E27FC236}">
+                <a16:creationId xmlns:a16="http://schemas.microsoft.com/office/drawing/2014/main" id="{70A4D896-5397-A7AD-510D-75DFEE87FDCE}"/>
+              </a:ext>
+            </a:extLst>
+          </p:cNvPr>
+          <p:cNvPicPr>
+            <a:picLocks noChangeAspect="1" noChangeArrowheads="1"/>
+          </p:cNvPicPr>
+          <p:nvPr/>
+        </p:nvPicPr>
+        <p:blipFill>
+          <a:blip r:embed="rId5">
+            <a:extLst>
+              <a:ext uri="{28A0092B-C50C-407E-A947-70E740481C1C}">
+                <a14:useLocalDpi xmlns:a14="http://schemas.microsoft.com/office/drawing/2010/main" val="0"/>
+              </a:ext>
+            </a:extLst>
+          </a:blip>
+          <a:srcRect/>
+          <a:stretch>
+            <a:fillRect/>
+          </a:stretch>
+        </p:blipFill>
+        <p:spPr bwMode="auto">
+          <a:xfrm>
+            <a:off x="391968" y="1531811"/>
+            <a:ext cx="1624243" cy="664072"/>
+          </a:xfrm>
+          <a:prstGeom prst="rect">
+            <a:avLst/>
+          </a:prstGeom>
+          <a:noFill/>
+          <a:extLst>
+            <a:ext uri="{909E8E84-426E-40DD-AFC4-6F175D3DCCD1}">
+              <a14:hiddenFill xmlns:a14="http://schemas.microsoft.com/office/drawing/2010/main">
+                <a:solidFill>
+                  <a:srgbClr val="FFFFFF"/>
+                </a:solidFill>
+              </a14:hiddenFill>
+            </a:ext>
+          </a:extLst>
+        </p:spPr>
+      </p:pic>
+      <p:sp>
+        <p:nvSpPr>
+          <p:cNvPr id="9" name="CuadroTexto 8">
+            <a:extLst>
+              <a:ext uri="{FF2B5EF4-FFF2-40B4-BE49-F238E27FC236}">
+                <a16:creationId xmlns:a16="http://schemas.microsoft.com/office/drawing/2014/main" id="{FCD04733-37F7-66EE-D004-56A635AF78D8}"/>
               </a:ext>
             </a:extLst>
           </p:cNvPr>
@@ -12384,8 +14222,8 @@
         </p:nvSpPr>
         <p:spPr>
           <a:xfrm>
-            <a:off x="2286000" y="2671278"/>
-            <a:ext cx="7718580" cy="923330"/>
+            <a:off x="285420" y="2389978"/>
+            <a:ext cx="1837338" cy="1754326"/>
           </a:xfrm>
           <a:prstGeom prst="rect">
             <a:avLst/>
@@ -12393,30 +14231,1555 @@
           <a:noFill/>
         </p:spPr>
         <p:txBody>
-          <a:bodyPr wrap="square" rtlCol="0">
+          <a:bodyPr wrap="square">
             <a:spAutoFit/>
           </a:bodyPr>
           <a:lstStyle/>
           <a:p>
+            <a:pPr>
+              <a:buNone/>
+            </a:pPr>
+            <a:r>
+              <a:rPr lang="en-US" sz="900" dirty="0">
+                <a:effectLst/>
+              </a:rPr>
+              <a:t>------- </a:t>
+            </a:r>
+            <a:r>
+              <a:rPr lang="en-US" sz="900" dirty="0" err="1">
+                <a:effectLst/>
+              </a:rPr>
+              <a:t>Pameters</a:t>
+            </a:r>
+            <a:r>
+              <a:rPr lang="en-US" sz="900" dirty="0">
+                <a:effectLst/>
+              </a:rPr>
+              <a:t> -------</a:t>
+            </a:r>
+          </a:p>
+          <a:p>
+            <a:pPr>
+              <a:buNone/>
+            </a:pPr>
+            <a:r>
+              <a:rPr lang="en-US" sz="900" dirty="0">
+                <a:effectLst/>
+              </a:rPr>
+              <a:t>MMI length 12.9071</a:t>
+            </a:r>
+          </a:p>
+          <a:p>
+            <a:pPr>
+              <a:buNone/>
+            </a:pPr>
+            <a:r>
+              <a:rPr lang="en-US" sz="900" dirty="0">
+                <a:effectLst/>
+              </a:rPr>
+              <a:t>MMI length increment 0.0000</a:t>
+            </a:r>
+          </a:p>
+          <a:p>
+            <a:pPr>
+              <a:buNone/>
+            </a:pPr>
+            <a:r>
+              <a:rPr lang="en-US" sz="900" dirty="0">
+                <a:effectLst/>
+              </a:rPr>
+              <a:t>IO </a:t>
+            </a:r>
+            <a:r>
+              <a:rPr lang="en-US" sz="900" dirty="0" err="1">
+                <a:effectLst/>
+              </a:rPr>
+              <a:t>wg</a:t>
+            </a:r>
+            <a:r>
+              <a:rPr lang="en-US" sz="900" dirty="0">
+                <a:effectLst/>
+              </a:rPr>
+              <a:t> width 1.0000</a:t>
+            </a:r>
+          </a:p>
+          <a:p>
+            <a:pPr>
+              <a:buNone/>
+            </a:pPr>
+            <a:r>
+              <a:rPr lang="en-US" sz="900" dirty="0">
+                <a:effectLst/>
+              </a:rPr>
+              <a:t>IO </a:t>
+            </a:r>
+            <a:r>
+              <a:rPr lang="en-US" sz="900" dirty="0" err="1">
+                <a:effectLst/>
+              </a:rPr>
+              <a:t>wg</a:t>
+            </a:r>
+            <a:r>
+              <a:rPr lang="en-US" sz="900" dirty="0">
+                <a:effectLst/>
+              </a:rPr>
+              <a:t> width increment 0.0000</a:t>
+            </a:r>
+          </a:p>
+          <a:p>
+            <a:pPr>
+              <a:buNone/>
+            </a:pPr>
+            <a:r>
+              <a:rPr lang="en-US" sz="900" dirty="0">
+                <a:effectLst/>
+              </a:rPr>
+              <a:t>------------------------</a:t>
+            </a:r>
+          </a:p>
+          <a:p>
+            <a:pPr>
+              <a:buNone/>
+            </a:pPr>
+            <a:r>
+              <a:rPr lang="en-US" sz="900" dirty="0">
+                <a:effectLst/>
+              </a:rPr>
+              <a:t>Total power IN coupled 0.7802</a:t>
+            </a:r>
+          </a:p>
+          <a:p>
+            <a:pPr>
+              <a:buNone/>
+            </a:pPr>
+            <a:r>
+              <a:rPr lang="en-US" sz="900" dirty="0">
+                <a:effectLst/>
+              </a:rPr>
+              <a:t>Total OUT power: 0.7586</a:t>
+            </a:r>
+          </a:p>
+          <a:p>
+            <a:pPr>
+              <a:buNone/>
+            </a:pPr>
+            <a:r>
+              <a:rPr lang="en-US" sz="900" dirty="0">
+                <a:effectLst/>
+              </a:rPr>
+              <a:t>Excess loss [dB] =  1.2000</a:t>
+            </a:r>
+          </a:p>
+          <a:p>
+            <a:pPr>
+              <a:buNone/>
+            </a:pPr>
+            <a:r>
+              <a:rPr lang="en-US" sz="900" dirty="0">
+                <a:effectLst/>
+              </a:rPr>
+              <a:t>------------------------</a:t>
+            </a:r>
+          </a:p>
+          <a:p>
+            <a:pPr>
+              <a:buNone/>
+            </a:pPr>
+            <a:r>
+              <a:rPr lang="en-US" sz="900" dirty="0">
+                <a:effectLst/>
+              </a:rPr>
+              <a:t>Power over OUTs:  ['0.3792', '0.3794’]</a:t>
+            </a:r>
+          </a:p>
+          <a:p>
+            <a:pPr>
+              <a:buNone/>
+            </a:pPr>
+            <a:r>
+              <a:rPr lang="en-US" sz="900" dirty="0">
+                <a:effectLst/>
+              </a:rPr>
+              <a:t>Ratio over OUTs ['0.4999', '0.5001']</a:t>
+            </a:r>
+            <a:endParaRPr lang="en-US" sz="900" dirty="0"/>
+          </a:p>
+        </p:txBody>
+      </p:sp>
+      <p:sp>
+        <p:nvSpPr>
+          <p:cNvPr id="10" name="CuadroTexto 9">
+            <a:extLst>
+              <a:ext uri="{FF2B5EF4-FFF2-40B4-BE49-F238E27FC236}">
+                <a16:creationId xmlns:a16="http://schemas.microsoft.com/office/drawing/2014/main" id="{7676FA06-7892-4EB0-347C-1CF2C7C01ED3}"/>
+              </a:ext>
+            </a:extLst>
+          </p:cNvPr>
+          <p:cNvSpPr txBox="1"/>
+          <p:nvPr/>
+        </p:nvSpPr>
+        <p:spPr>
+          <a:xfrm>
+            <a:off x="285420" y="4307292"/>
+            <a:ext cx="1837338" cy="246221"/>
+          </a:xfrm>
+          <a:prstGeom prst="rect">
+            <a:avLst/>
+          </a:prstGeom>
+          <a:noFill/>
+        </p:spPr>
+        <p:txBody>
+          <a:bodyPr wrap="square">
+            <a:spAutoFit/>
+          </a:bodyPr>
+          <a:lstStyle/>
+          <a:p>
+            <a:pPr algn="ctr">
+              <a:buNone/>
+            </a:pPr>
+            <a:r>
+              <a:rPr lang="en-US" sz="1000" dirty="0"/>
+              <a:t>Gap = 0,2</a:t>
+            </a:r>
+          </a:p>
+        </p:txBody>
+      </p:sp>
+      <p:sp>
+        <p:nvSpPr>
+          <p:cNvPr id="11" name="Rectángulo 10">
+            <a:extLst>
+              <a:ext uri="{FF2B5EF4-FFF2-40B4-BE49-F238E27FC236}">
+                <a16:creationId xmlns:a16="http://schemas.microsoft.com/office/drawing/2014/main" id="{6E9D1AB3-A93D-46F8-E7F4-997685FDE2C8}"/>
+              </a:ext>
+            </a:extLst>
+          </p:cNvPr>
+          <p:cNvSpPr/>
+          <p:nvPr/>
+        </p:nvSpPr>
+        <p:spPr>
+          <a:xfrm>
+            <a:off x="2184718" y="1417195"/>
+            <a:ext cx="1950981" cy="3151116"/>
+          </a:xfrm>
+          <a:prstGeom prst="rect">
+            <a:avLst/>
+          </a:prstGeom>
+          <a:noFill/>
+          <a:ln w="28575">
+            <a:solidFill>
+              <a:srgbClr val="E0700D"/>
+            </a:solidFill>
+          </a:ln>
+        </p:spPr>
+        <p:style>
+          <a:lnRef idx="2">
+            <a:schemeClr val="accent1">
+              <a:shade val="15000"/>
+            </a:schemeClr>
+          </a:lnRef>
+          <a:fillRef idx="1">
+            <a:schemeClr val="accent1"/>
+          </a:fillRef>
+          <a:effectRef idx="0">
+            <a:schemeClr val="accent1"/>
+          </a:effectRef>
+          <a:fontRef idx="minor">
+            <a:schemeClr val="lt1"/>
+          </a:fontRef>
+        </p:style>
+        <p:txBody>
+          <a:bodyPr rtlCol="0" anchor="ctr"/>
+          <a:lstStyle/>
+          <a:p>
             <a:pPr algn="ctr"/>
-            <a:r>
-              <a:rPr lang="en-US" b="1" dirty="0"/>
-              <a:t>deep</a:t>
-            </a:r>
-            <a:r>
-              <a:rPr lang="en-US" dirty="0"/>
-              <a:t> waveguide</a:t>
-            </a:r>
-          </a:p>
+            <a:endParaRPr lang="en-US"/>
+          </a:p>
+        </p:txBody>
+      </p:sp>
+      <p:pic>
+        <p:nvPicPr>
+          <p:cNvPr id="12" name="Picture 2">
+            <a:extLst>
+              <a:ext uri="{FF2B5EF4-FFF2-40B4-BE49-F238E27FC236}">
+                <a16:creationId xmlns:a16="http://schemas.microsoft.com/office/drawing/2014/main" id="{DA25A72A-79BF-9806-109F-AC49325C99FE}"/>
+              </a:ext>
+            </a:extLst>
+          </p:cNvPr>
+          <p:cNvPicPr>
+            <a:picLocks noChangeAspect="1" noChangeArrowheads="1"/>
+          </p:cNvPicPr>
+          <p:nvPr/>
+        </p:nvPicPr>
+        <p:blipFill>
+          <a:blip r:embed="rId6"/>
+          <a:srcRect/>
+          <a:stretch/>
+        </p:blipFill>
+        <p:spPr bwMode="auto">
+          <a:xfrm>
+            <a:off x="2348086" y="1605545"/>
+            <a:ext cx="1624243" cy="514249"/>
+          </a:xfrm>
+          <a:prstGeom prst="rect">
+            <a:avLst/>
+          </a:prstGeom>
+          <a:noFill/>
+          <a:extLst>
+            <a:ext uri="{909E8E84-426E-40DD-AFC4-6F175D3DCCD1}">
+              <a14:hiddenFill xmlns:a14="http://schemas.microsoft.com/office/drawing/2010/main">
+                <a:solidFill>
+                  <a:srgbClr val="FFFFFF"/>
+                </a:solidFill>
+              </a14:hiddenFill>
+            </a:ext>
+          </a:extLst>
+        </p:spPr>
+      </p:pic>
+      <p:sp>
+        <p:nvSpPr>
+          <p:cNvPr id="13" name="CuadroTexto 12">
+            <a:extLst>
+              <a:ext uri="{FF2B5EF4-FFF2-40B4-BE49-F238E27FC236}">
+                <a16:creationId xmlns:a16="http://schemas.microsoft.com/office/drawing/2014/main" id="{A817E037-D47E-AC52-394C-12635B048FAA}"/>
+              </a:ext>
+            </a:extLst>
+          </p:cNvPr>
+          <p:cNvSpPr txBox="1"/>
+          <p:nvPr/>
+        </p:nvSpPr>
+        <p:spPr>
+          <a:xfrm>
+            <a:off x="2241538" y="2388801"/>
+            <a:ext cx="1837338" cy="1892826"/>
+          </a:xfrm>
+          <a:prstGeom prst="rect">
+            <a:avLst/>
+          </a:prstGeom>
+          <a:noFill/>
+        </p:spPr>
+        <p:txBody>
+          <a:bodyPr wrap="square">
+            <a:spAutoFit/>
+          </a:bodyPr>
+          <a:lstStyle/>
+          <a:p>
+            <a:pPr>
+              <a:buNone/>
+            </a:pPr>
+            <a:r>
+              <a:rPr lang="en-US" sz="900" dirty="0"/>
+              <a:t>------- </a:t>
+            </a:r>
+            <a:r>
+              <a:rPr lang="en-US" sz="900" dirty="0" err="1"/>
+              <a:t>Pameters</a:t>
+            </a:r>
+            <a:r>
+              <a:rPr lang="en-US" sz="900" dirty="0"/>
+              <a:t> -------</a:t>
+            </a:r>
+            <a:br>
+              <a:rPr lang="en-US" sz="900" dirty="0"/>
+            </a:br>
+            <a:r>
+              <a:rPr lang="en-US" sz="900" dirty="0"/>
+              <a:t>MMI length 25.0550</a:t>
+            </a:r>
+            <a:br>
+              <a:rPr lang="en-US" sz="900" dirty="0"/>
+            </a:br>
+            <a:r>
+              <a:rPr lang="en-US" sz="900" dirty="0"/>
+              <a:t>MMI length increment 0.0000</a:t>
+            </a:r>
+            <a:br>
+              <a:rPr lang="en-US" sz="900" dirty="0"/>
+            </a:br>
+            <a:r>
+              <a:rPr lang="en-US" sz="900" dirty="0"/>
+              <a:t>IO </a:t>
+            </a:r>
+            <a:r>
+              <a:rPr lang="en-US" sz="900" dirty="0" err="1"/>
+              <a:t>wg</a:t>
+            </a:r>
+            <a:r>
+              <a:rPr lang="en-US" sz="900" dirty="0"/>
+              <a:t> width 1.0000</a:t>
+            </a:r>
+            <a:br>
+              <a:rPr lang="en-US" sz="900" dirty="0"/>
+            </a:br>
+            <a:r>
+              <a:rPr lang="en-US" sz="900" dirty="0"/>
+              <a:t>IO </a:t>
+            </a:r>
+            <a:r>
+              <a:rPr lang="en-US" sz="900" dirty="0" err="1"/>
+              <a:t>wg</a:t>
+            </a:r>
+            <a:r>
+              <a:rPr lang="en-US" sz="900" dirty="0"/>
+              <a:t> width increment 0.0000</a:t>
+            </a:r>
+            <a:br>
+              <a:rPr lang="en-US" sz="900" dirty="0"/>
+            </a:br>
+            <a:r>
+              <a:rPr lang="en-US" sz="900" dirty="0"/>
+              <a:t>------------------------</a:t>
+            </a:r>
+            <a:br>
+              <a:rPr lang="en-US" sz="900" dirty="0"/>
+            </a:br>
+            <a:r>
+              <a:rPr lang="en-US" sz="900" dirty="0"/>
+              <a:t>Total power IN coupled 0.8983</a:t>
+            </a:r>
+            <a:br>
+              <a:rPr lang="en-US" sz="900" dirty="0"/>
+            </a:br>
+            <a:r>
+              <a:rPr lang="en-US" sz="900" dirty="0"/>
+              <a:t>Total OUT power: 0.8863</a:t>
+            </a:r>
+            <a:br>
+              <a:rPr lang="en-US" sz="900" dirty="0"/>
+            </a:br>
+            <a:r>
+              <a:rPr lang="en-US" sz="900" dirty="0"/>
+              <a:t>Excess loss [dB] =  0.5243</a:t>
+            </a:r>
+            <a:br>
+              <a:rPr lang="en-US" sz="900" dirty="0"/>
+            </a:br>
+            <a:r>
+              <a:rPr lang="en-US" sz="900" dirty="0"/>
+              <a:t>------------------------</a:t>
+            </a:r>
+            <a:br>
+              <a:rPr lang="en-US" sz="900" dirty="0"/>
+            </a:br>
+            <a:r>
+              <a:rPr lang="en-US" sz="900" dirty="0"/>
+              <a:t>Power over OUTs:  ['0.4433', '0.4430']</a:t>
+            </a:r>
+            <a:br>
+              <a:rPr lang="en-US" sz="900" dirty="0"/>
+            </a:br>
+            <a:r>
+              <a:rPr lang="en-US" sz="900" dirty="0"/>
+              <a:t>Ratio over OUTs ['0.5001', '0.4999']</a:t>
+            </a:r>
+          </a:p>
+        </p:txBody>
+      </p:sp>
+      <p:sp>
+        <p:nvSpPr>
+          <p:cNvPr id="14" name="CuadroTexto 13">
+            <a:extLst>
+              <a:ext uri="{FF2B5EF4-FFF2-40B4-BE49-F238E27FC236}">
+                <a16:creationId xmlns:a16="http://schemas.microsoft.com/office/drawing/2014/main" id="{8D6A9C22-541A-0262-5DE6-373F890DE8D7}"/>
+              </a:ext>
+            </a:extLst>
+          </p:cNvPr>
+          <p:cNvSpPr txBox="1"/>
+          <p:nvPr/>
+        </p:nvSpPr>
+        <p:spPr>
+          <a:xfrm>
+            <a:off x="2241538" y="4306115"/>
+            <a:ext cx="1837338" cy="246221"/>
+          </a:xfrm>
+          <a:prstGeom prst="rect">
+            <a:avLst/>
+          </a:prstGeom>
+          <a:noFill/>
+        </p:spPr>
+        <p:txBody>
+          <a:bodyPr wrap="square">
+            <a:spAutoFit/>
+          </a:bodyPr>
+          <a:lstStyle/>
+          <a:p>
+            <a:pPr algn="ctr">
+              <a:buNone/>
+            </a:pPr>
+            <a:r>
+              <a:rPr lang="en-US" sz="1000" dirty="0"/>
+              <a:t>Gap = 0,4</a:t>
+            </a:r>
+          </a:p>
+        </p:txBody>
+      </p:sp>
+      <p:sp>
+        <p:nvSpPr>
+          <p:cNvPr id="15" name="Rectángulo 14">
+            <a:extLst>
+              <a:ext uri="{FF2B5EF4-FFF2-40B4-BE49-F238E27FC236}">
+                <a16:creationId xmlns:a16="http://schemas.microsoft.com/office/drawing/2014/main" id="{69345945-3F04-8EF7-4B59-FF2AF19B58EC}"/>
+              </a:ext>
+            </a:extLst>
+          </p:cNvPr>
+          <p:cNvSpPr/>
+          <p:nvPr/>
+        </p:nvSpPr>
+        <p:spPr>
+          <a:xfrm>
+            <a:off x="4155096" y="1430349"/>
+            <a:ext cx="1950981" cy="3151116"/>
+          </a:xfrm>
+          <a:prstGeom prst="rect">
+            <a:avLst/>
+          </a:prstGeom>
+          <a:noFill/>
+          <a:ln w="28575">
+            <a:solidFill>
+              <a:srgbClr val="E0700D"/>
+            </a:solidFill>
+          </a:ln>
+        </p:spPr>
+        <p:style>
+          <a:lnRef idx="2">
+            <a:schemeClr val="accent1">
+              <a:shade val="15000"/>
+            </a:schemeClr>
+          </a:lnRef>
+          <a:fillRef idx="1">
+            <a:schemeClr val="accent1"/>
+          </a:fillRef>
+          <a:effectRef idx="0">
+            <a:schemeClr val="accent1"/>
+          </a:effectRef>
+          <a:fontRef idx="minor">
+            <a:schemeClr val="lt1"/>
+          </a:fontRef>
+        </p:style>
+        <p:txBody>
+          <a:bodyPr rtlCol="0" anchor="ctr"/>
+          <a:lstStyle/>
           <a:p>
             <a:pPr algn="ctr"/>
-            <a:endParaRPr lang="en-US" dirty="0"/>
-          </a:p>
+            <a:endParaRPr lang="en-US"/>
+          </a:p>
+        </p:txBody>
+      </p:sp>
+      <p:pic>
+        <p:nvPicPr>
+          <p:cNvPr id="17" name="Picture 2">
+            <a:extLst>
+              <a:ext uri="{FF2B5EF4-FFF2-40B4-BE49-F238E27FC236}">
+                <a16:creationId xmlns:a16="http://schemas.microsoft.com/office/drawing/2014/main" id="{47351C2B-31F5-065B-E11C-7FF085844DB5}"/>
+              </a:ext>
+            </a:extLst>
+          </p:cNvPr>
+          <p:cNvPicPr>
+            <a:picLocks noChangeAspect="1" noChangeArrowheads="1"/>
+          </p:cNvPicPr>
+          <p:nvPr/>
+        </p:nvPicPr>
+        <p:blipFill>
+          <a:blip r:embed="rId7"/>
+          <a:srcRect/>
+          <a:stretch/>
+        </p:blipFill>
+        <p:spPr bwMode="auto">
+          <a:xfrm>
+            <a:off x="4318464" y="1669281"/>
+            <a:ext cx="1624243" cy="413086"/>
+          </a:xfrm>
+          <a:prstGeom prst="rect">
+            <a:avLst/>
+          </a:prstGeom>
+          <a:noFill/>
+          <a:extLst>
+            <a:ext uri="{909E8E84-426E-40DD-AFC4-6F175D3DCCD1}">
+              <a14:hiddenFill xmlns:a14="http://schemas.microsoft.com/office/drawing/2010/main">
+                <a:solidFill>
+                  <a:srgbClr val="FFFFFF"/>
+                </a:solidFill>
+              </a14:hiddenFill>
+            </a:ext>
+          </a:extLst>
+        </p:spPr>
+      </p:pic>
+      <p:sp>
+        <p:nvSpPr>
+          <p:cNvPr id="18" name="CuadroTexto 17">
+            <a:extLst>
+              <a:ext uri="{FF2B5EF4-FFF2-40B4-BE49-F238E27FC236}">
+                <a16:creationId xmlns:a16="http://schemas.microsoft.com/office/drawing/2014/main" id="{7AC66D83-F2E1-4983-8926-E4FE372A648B}"/>
+              </a:ext>
+            </a:extLst>
+          </p:cNvPr>
+          <p:cNvSpPr txBox="1"/>
+          <p:nvPr/>
+        </p:nvSpPr>
+        <p:spPr>
+          <a:xfrm>
+            <a:off x="4211916" y="2401955"/>
+            <a:ext cx="1837338" cy="1892826"/>
+          </a:xfrm>
+          <a:prstGeom prst="rect">
+            <a:avLst/>
+          </a:prstGeom>
+          <a:noFill/>
+        </p:spPr>
+        <p:txBody>
+          <a:bodyPr wrap="square">
+            <a:spAutoFit/>
+          </a:bodyPr>
+          <a:lstStyle/>
+          <a:p>
+            <a:pPr>
+              <a:buNone/>
+            </a:pPr>
+            <a:r>
+              <a:rPr lang="en-US" sz="900" dirty="0"/>
+              <a:t>------- </a:t>
+            </a:r>
+            <a:r>
+              <a:rPr lang="en-US" sz="900" dirty="0" err="1"/>
+              <a:t>Pameters</a:t>
+            </a:r>
+            <a:r>
+              <a:rPr lang="en-US" sz="900" dirty="0"/>
+              <a:t> -------</a:t>
+            </a:r>
+            <a:br>
+              <a:rPr lang="en-US" sz="900" dirty="0"/>
+            </a:br>
+            <a:r>
+              <a:rPr lang="en-US" sz="900" dirty="0"/>
+              <a:t>MMI length 47.0137</a:t>
+            </a:r>
+            <a:br>
+              <a:rPr lang="en-US" sz="900" dirty="0"/>
+            </a:br>
+            <a:r>
+              <a:rPr lang="en-US" sz="900" dirty="0"/>
+              <a:t>MMI length increment 0.0000</a:t>
+            </a:r>
+            <a:br>
+              <a:rPr lang="en-US" sz="900" dirty="0"/>
+            </a:br>
+            <a:r>
+              <a:rPr lang="en-US" sz="900" dirty="0"/>
+              <a:t>IO </a:t>
+            </a:r>
+            <a:r>
+              <a:rPr lang="en-US" sz="900" dirty="0" err="1"/>
+              <a:t>wg</a:t>
+            </a:r>
+            <a:r>
+              <a:rPr lang="en-US" sz="900" dirty="0"/>
+              <a:t> width 1.0000</a:t>
+            </a:r>
+            <a:br>
+              <a:rPr lang="en-US" sz="900" dirty="0"/>
+            </a:br>
+            <a:r>
+              <a:rPr lang="en-US" sz="900" dirty="0"/>
+              <a:t>IO </a:t>
+            </a:r>
+            <a:r>
+              <a:rPr lang="en-US" sz="900" dirty="0" err="1"/>
+              <a:t>wg</a:t>
+            </a:r>
+            <a:r>
+              <a:rPr lang="en-US" sz="900" dirty="0"/>
+              <a:t> width increment 0.0000</a:t>
+            </a:r>
+            <a:br>
+              <a:rPr lang="en-US" sz="900" dirty="0"/>
+            </a:br>
+            <a:r>
+              <a:rPr lang="en-US" sz="900" dirty="0"/>
+              <a:t>------------------------</a:t>
+            </a:r>
+            <a:br>
+              <a:rPr lang="en-US" sz="900" dirty="0"/>
+            </a:br>
+            <a:r>
+              <a:rPr lang="en-US" sz="900" dirty="0"/>
+              <a:t>Total power IN coupled 0.9688</a:t>
+            </a:r>
+            <a:br>
+              <a:rPr lang="en-US" sz="900" dirty="0"/>
+            </a:br>
+            <a:r>
+              <a:rPr lang="en-US" sz="900" dirty="0"/>
+              <a:t>Total OUT power: 0.9583</a:t>
+            </a:r>
+            <a:br>
+              <a:rPr lang="en-US" sz="900" dirty="0"/>
+            </a:br>
+            <a:r>
+              <a:rPr lang="en-US" sz="900" dirty="0"/>
+              <a:t>Excess loss [dB] =  0.1851</a:t>
+            </a:r>
+            <a:br>
+              <a:rPr lang="en-US" sz="900" dirty="0"/>
+            </a:br>
+            <a:r>
+              <a:rPr lang="en-US" sz="900" dirty="0"/>
+              <a:t>------------------------</a:t>
+            </a:r>
+            <a:br>
+              <a:rPr lang="en-US" sz="900" dirty="0"/>
+            </a:br>
+            <a:r>
+              <a:rPr lang="en-US" sz="900" dirty="0"/>
+              <a:t>Power over OUTs:  ['0.4791', '0.4791']</a:t>
+            </a:r>
+            <a:br>
+              <a:rPr lang="en-US" sz="900" dirty="0"/>
+            </a:br>
+            <a:r>
+              <a:rPr lang="en-US" sz="900" dirty="0"/>
+              <a:t>Ratio over OUTs ['0.5000', '0.5000']</a:t>
+            </a:r>
+          </a:p>
+        </p:txBody>
+      </p:sp>
+      <p:sp>
+        <p:nvSpPr>
+          <p:cNvPr id="19" name="CuadroTexto 18">
+            <a:extLst>
+              <a:ext uri="{FF2B5EF4-FFF2-40B4-BE49-F238E27FC236}">
+                <a16:creationId xmlns:a16="http://schemas.microsoft.com/office/drawing/2014/main" id="{1EE1672C-D49B-6E74-253B-D94775444269}"/>
+              </a:ext>
+            </a:extLst>
+          </p:cNvPr>
+          <p:cNvSpPr txBox="1"/>
+          <p:nvPr/>
+        </p:nvSpPr>
+        <p:spPr>
+          <a:xfrm>
+            <a:off x="4211916" y="4319269"/>
+            <a:ext cx="1837338" cy="246221"/>
+          </a:xfrm>
+          <a:prstGeom prst="rect">
+            <a:avLst/>
+          </a:prstGeom>
+          <a:noFill/>
+        </p:spPr>
+        <p:txBody>
+          <a:bodyPr wrap="square">
+            <a:spAutoFit/>
+          </a:bodyPr>
+          <a:lstStyle/>
+          <a:p>
+            <a:pPr algn="ctr">
+              <a:buNone/>
+            </a:pPr>
+            <a:r>
+              <a:rPr lang="en-US" sz="1000" dirty="0"/>
+              <a:t>Gap = 0,6</a:t>
+            </a:r>
+          </a:p>
+        </p:txBody>
+      </p:sp>
+      <p:sp>
+        <p:nvSpPr>
+          <p:cNvPr id="20" name="Rectángulo 19">
+            <a:extLst>
+              <a:ext uri="{FF2B5EF4-FFF2-40B4-BE49-F238E27FC236}">
+                <a16:creationId xmlns:a16="http://schemas.microsoft.com/office/drawing/2014/main" id="{44C01FA7-6D56-8B6C-1A4F-71FB45C3BEDF}"/>
+              </a:ext>
+            </a:extLst>
+          </p:cNvPr>
+          <p:cNvSpPr/>
+          <p:nvPr/>
+        </p:nvSpPr>
+        <p:spPr>
+          <a:xfrm>
+            <a:off x="6106077" y="1430483"/>
+            <a:ext cx="1950981" cy="3151116"/>
+          </a:xfrm>
+          <a:prstGeom prst="rect">
+            <a:avLst/>
+          </a:prstGeom>
+          <a:noFill/>
+          <a:ln w="28575">
+            <a:solidFill>
+              <a:srgbClr val="E0700D"/>
+            </a:solidFill>
+          </a:ln>
+        </p:spPr>
+        <p:style>
+          <a:lnRef idx="2">
+            <a:schemeClr val="accent1">
+              <a:shade val="15000"/>
+            </a:schemeClr>
+          </a:lnRef>
+          <a:fillRef idx="1">
+            <a:schemeClr val="accent1"/>
+          </a:fillRef>
+          <a:effectRef idx="0">
+            <a:schemeClr val="accent1"/>
+          </a:effectRef>
+          <a:fontRef idx="minor">
+            <a:schemeClr val="lt1"/>
+          </a:fontRef>
+        </p:style>
+        <p:txBody>
+          <a:bodyPr rtlCol="0" anchor="ctr"/>
+          <a:lstStyle/>
           <a:p>
             <a:pPr algn="ctr"/>
-            <a:r>
-              <a:rPr lang="en-US" dirty="0"/>
-              <a:t>Paste propagation plots and output text here</a:t>
+            <a:endParaRPr lang="en-US"/>
+          </a:p>
+        </p:txBody>
+      </p:sp>
+      <p:pic>
+        <p:nvPicPr>
+          <p:cNvPr id="21" name="Picture 2">
+            <a:extLst>
+              <a:ext uri="{FF2B5EF4-FFF2-40B4-BE49-F238E27FC236}">
+                <a16:creationId xmlns:a16="http://schemas.microsoft.com/office/drawing/2014/main" id="{677234DE-6E70-A48D-E0A8-5D816B89722B}"/>
+              </a:ext>
+            </a:extLst>
+          </p:cNvPr>
+          <p:cNvPicPr>
+            <a:picLocks noChangeAspect="1" noChangeArrowheads="1"/>
+          </p:cNvPicPr>
+          <p:nvPr/>
+        </p:nvPicPr>
+        <p:blipFill>
+          <a:blip r:embed="rId8"/>
+          <a:srcRect/>
+          <a:stretch/>
+        </p:blipFill>
+        <p:spPr bwMode="auto">
+          <a:xfrm>
+            <a:off x="6269445" y="1704541"/>
+            <a:ext cx="1624243" cy="342833"/>
+          </a:xfrm>
+          <a:prstGeom prst="rect">
+            <a:avLst/>
+          </a:prstGeom>
+          <a:noFill/>
+          <a:extLst>
+            <a:ext uri="{909E8E84-426E-40DD-AFC4-6F175D3DCCD1}">
+              <a14:hiddenFill xmlns:a14="http://schemas.microsoft.com/office/drawing/2010/main">
+                <a:solidFill>
+                  <a:srgbClr val="FFFFFF"/>
+                </a:solidFill>
+              </a14:hiddenFill>
+            </a:ext>
+          </a:extLst>
+        </p:spPr>
+      </p:pic>
+      <p:sp>
+        <p:nvSpPr>
+          <p:cNvPr id="22" name="CuadroTexto 21">
+            <a:extLst>
+              <a:ext uri="{FF2B5EF4-FFF2-40B4-BE49-F238E27FC236}">
+                <a16:creationId xmlns:a16="http://schemas.microsoft.com/office/drawing/2014/main" id="{BCC789A3-A3A5-AD98-0C00-952077643F00}"/>
+              </a:ext>
+            </a:extLst>
+          </p:cNvPr>
+          <p:cNvSpPr txBox="1"/>
+          <p:nvPr/>
+        </p:nvSpPr>
+        <p:spPr>
+          <a:xfrm>
+            <a:off x="6162897" y="2402089"/>
+            <a:ext cx="1837338" cy="1892826"/>
+          </a:xfrm>
+          <a:prstGeom prst="rect">
+            <a:avLst/>
+          </a:prstGeom>
+          <a:noFill/>
+        </p:spPr>
+        <p:txBody>
+          <a:bodyPr wrap="square">
+            <a:spAutoFit/>
+          </a:bodyPr>
+          <a:lstStyle/>
+          <a:p>
+            <a:pPr>
+              <a:buNone/>
+            </a:pPr>
+            <a:r>
+              <a:rPr lang="en-US" sz="900" dirty="0"/>
+              <a:t>------- </a:t>
+            </a:r>
+            <a:r>
+              <a:rPr lang="en-US" sz="900" dirty="0" err="1"/>
+              <a:t>Pameters</a:t>
+            </a:r>
+            <a:r>
+              <a:rPr lang="en-US" sz="900" dirty="0"/>
+              <a:t> -------</a:t>
+            </a:r>
+            <a:br>
+              <a:rPr lang="en-US" sz="900" dirty="0"/>
+            </a:br>
+            <a:r>
+              <a:rPr lang="en-US" sz="900" dirty="0"/>
+              <a:t>MMI length 86.9819</a:t>
+            </a:r>
+            <a:br>
+              <a:rPr lang="en-US" sz="900" dirty="0"/>
+            </a:br>
+            <a:r>
+              <a:rPr lang="en-US" sz="900" dirty="0"/>
+              <a:t>MMI length increment 0.0000</a:t>
+            </a:r>
+            <a:br>
+              <a:rPr lang="en-US" sz="900" dirty="0"/>
+            </a:br>
+            <a:r>
+              <a:rPr lang="en-US" sz="900" dirty="0"/>
+              <a:t>IO </a:t>
+            </a:r>
+            <a:r>
+              <a:rPr lang="en-US" sz="900" dirty="0" err="1"/>
+              <a:t>wg</a:t>
+            </a:r>
+            <a:r>
+              <a:rPr lang="en-US" sz="900" dirty="0"/>
+              <a:t> width 1.0000</a:t>
+            </a:r>
+            <a:br>
+              <a:rPr lang="en-US" sz="900" dirty="0"/>
+            </a:br>
+            <a:r>
+              <a:rPr lang="en-US" sz="900" dirty="0"/>
+              <a:t>IO </a:t>
+            </a:r>
+            <a:r>
+              <a:rPr lang="en-US" sz="900" dirty="0" err="1"/>
+              <a:t>wg</a:t>
+            </a:r>
+            <a:r>
+              <a:rPr lang="en-US" sz="900" dirty="0"/>
+              <a:t> width increment 0.0000</a:t>
+            </a:r>
+            <a:br>
+              <a:rPr lang="en-US" sz="900" dirty="0"/>
+            </a:br>
+            <a:r>
+              <a:rPr lang="en-US" sz="900" dirty="0"/>
+              <a:t>------------------------</a:t>
+            </a:r>
+            <a:br>
+              <a:rPr lang="en-US" sz="900" dirty="0"/>
+            </a:br>
+            <a:r>
+              <a:rPr lang="en-US" sz="900" dirty="0"/>
+              <a:t>Total power IN coupled 0.9882</a:t>
+            </a:r>
+            <a:br>
+              <a:rPr lang="en-US" sz="900" dirty="0"/>
+            </a:br>
+            <a:r>
+              <a:rPr lang="en-US" sz="900" dirty="0"/>
+              <a:t>Total OUT power: 0.9778</a:t>
+            </a:r>
+            <a:br>
+              <a:rPr lang="en-US" sz="900" dirty="0"/>
+            </a:br>
+            <a:r>
+              <a:rPr lang="en-US" sz="900" dirty="0"/>
+              <a:t>Excess loss [dB] =  0.0976</a:t>
+            </a:r>
+            <a:br>
+              <a:rPr lang="en-US" sz="900" dirty="0"/>
+            </a:br>
+            <a:r>
+              <a:rPr lang="en-US" sz="900" dirty="0"/>
+              <a:t>------------------------</a:t>
+            </a:r>
+            <a:br>
+              <a:rPr lang="en-US" sz="900" dirty="0"/>
+            </a:br>
+            <a:r>
+              <a:rPr lang="en-US" sz="900" dirty="0"/>
+              <a:t>Power over OUTs:  ['0.4888', '0.4890']</a:t>
+            </a:r>
+            <a:br>
+              <a:rPr lang="en-US" sz="900" dirty="0"/>
+            </a:br>
+            <a:r>
+              <a:rPr lang="en-US" sz="900" dirty="0"/>
+              <a:t>Ratio over OUTs ['0.4999', '0.5001']</a:t>
+            </a:r>
+          </a:p>
+        </p:txBody>
+      </p:sp>
+      <p:sp>
+        <p:nvSpPr>
+          <p:cNvPr id="23" name="CuadroTexto 22">
+            <a:extLst>
+              <a:ext uri="{FF2B5EF4-FFF2-40B4-BE49-F238E27FC236}">
+                <a16:creationId xmlns:a16="http://schemas.microsoft.com/office/drawing/2014/main" id="{93D7B3FA-A830-4241-3B92-95DA9EBB4619}"/>
+              </a:ext>
+            </a:extLst>
+          </p:cNvPr>
+          <p:cNvSpPr txBox="1"/>
+          <p:nvPr/>
+        </p:nvSpPr>
+        <p:spPr>
+          <a:xfrm>
+            <a:off x="6162897" y="4319403"/>
+            <a:ext cx="1837338" cy="246221"/>
+          </a:xfrm>
+          <a:prstGeom prst="rect">
+            <a:avLst/>
+          </a:prstGeom>
+          <a:noFill/>
+        </p:spPr>
+        <p:txBody>
+          <a:bodyPr wrap="square">
+            <a:spAutoFit/>
+          </a:bodyPr>
+          <a:lstStyle/>
+          <a:p>
+            <a:pPr algn="ctr">
+              <a:buNone/>
+            </a:pPr>
+            <a:r>
+              <a:rPr lang="en-US" sz="1000" dirty="0"/>
+              <a:t>Gap = 0,8</a:t>
+            </a:r>
+          </a:p>
+        </p:txBody>
+      </p:sp>
+      <p:sp>
+        <p:nvSpPr>
+          <p:cNvPr id="24" name="Rectángulo 23">
+            <a:extLst>
+              <a:ext uri="{FF2B5EF4-FFF2-40B4-BE49-F238E27FC236}">
+                <a16:creationId xmlns:a16="http://schemas.microsoft.com/office/drawing/2014/main" id="{161FDF41-FBF0-327D-EC75-C7A6E842C0EF}"/>
+              </a:ext>
+            </a:extLst>
+          </p:cNvPr>
+          <p:cNvSpPr/>
+          <p:nvPr/>
+        </p:nvSpPr>
+        <p:spPr>
+          <a:xfrm>
+            <a:off x="8063278" y="1430349"/>
+            <a:ext cx="1950981" cy="3151116"/>
+          </a:xfrm>
+          <a:prstGeom prst="rect">
+            <a:avLst/>
+          </a:prstGeom>
+          <a:noFill/>
+          <a:ln w="28575">
+            <a:solidFill>
+              <a:srgbClr val="E0700D"/>
+            </a:solidFill>
+          </a:ln>
+        </p:spPr>
+        <p:style>
+          <a:lnRef idx="2">
+            <a:schemeClr val="accent1">
+              <a:shade val="15000"/>
+            </a:schemeClr>
+          </a:lnRef>
+          <a:fillRef idx="1">
+            <a:schemeClr val="accent1"/>
+          </a:fillRef>
+          <a:effectRef idx="0">
+            <a:schemeClr val="accent1"/>
+          </a:effectRef>
+          <a:fontRef idx="minor">
+            <a:schemeClr val="lt1"/>
+          </a:fontRef>
+        </p:style>
+        <p:txBody>
+          <a:bodyPr rtlCol="0" anchor="ctr"/>
+          <a:lstStyle/>
+          <a:p>
+            <a:pPr algn="ctr"/>
+            <a:endParaRPr lang="en-US"/>
+          </a:p>
+        </p:txBody>
+      </p:sp>
+      <p:pic>
+        <p:nvPicPr>
+          <p:cNvPr id="25" name="Picture 2">
+            <a:extLst>
+              <a:ext uri="{FF2B5EF4-FFF2-40B4-BE49-F238E27FC236}">
+                <a16:creationId xmlns:a16="http://schemas.microsoft.com/office/drawing/2014/main" id="{2CFD097F-E5F9-5105-509E-5CD7F0407004}"/>
+              </a:ext>
+            </a:extLst>
+          </p:cNvPr>
+          <p:cNvPicPr>
+            <a:picLocks noChangeAspect="1" noChangeArrowheads="1"/>
+          </p:cNvPicPr>
+          <p:nvPr/>
+        </p:nvPicPr>
+        <p:blipFill>
+          <a:blip r:embed="rId9"/>
+          <a:srcRect/>
+          <a:stretch/>
+        </p:blipFill>
+        <p:spPr bwMode="auto">
+          <a:xfrm>
+            <a:off x="8226646" y="1725483"/>
+            <a:ext cx="1624243" cy="300681"/>
+          </a:xfrm>
+          <a:prstGeom prst="rect">
+            <a:avLst/>
+          </a:prstGeom>
+          <a:noFill/>
+          <a:extLst>
+            <a:ext uri="{909E8E84-426E-40DD-AFC4-6F175D3DCCD1}">
+              <a14:hiddenFill xmlns:a14="http://schemas.microsoft.com/office/drawing/2010/main">
+                <a:solidFill>
+                  <a:srgbClr val="FFFFFF"/>
+                </a:solidFill>
+              </a14:hiddenFill>
+            </a:ext>
+          </a:extLst>
+        </p:spPr>
+      </p:pic>
+      <p:sp>
+        <p:nvSpPr>
+          <p:cNvPr id="26" name="CuadroTexto 25">
+            <a:extLst>
+              <a:ext uri="{FF2B5EF4-FFF2-40B4-BE49-F238E27FC236}">
+                <a16:creationId xmlns:a16="http://schemas.microsoft.com/office/drawing/2014/main" id="{0DB823DE-B21E-A73A-D38B-2CD5CD4221B6}"/>
+              </a:ext>
+            </a:extLst>
+          </p:cNvPr>
+          <p:cNvSpPr txBox="1"/>
+          <p:nvPr/>
+        </p:nvSpPr>
+        <p:spPr>
+          <a:xfrm>
+            <a:off x="8120098" y="2401955"/>
+            <a:ext cx="1837338" cy="1892826"/>
+          </a:xfrm>
+          <a:prstGeom prst="rect">
+            <a:avLst/>
+          </a:prstGeom>
+          <a:noFill/>
+        </p:spPr>
+        <p:txBody>
+          <a:bodyPr wrap="square">
+            <a:spAutoFit/>
+          </a:bodyPr>
+          <a:lstStyle/>
+          <a:p>
+            <a:pPr>
+              <a:buNone/>
+            </a:pPr>
+            <a:r>
+              <a:rPr lang="en-US" sz="900" dirty="0"/>
+              <a:t>------- </a:t>
+            </a:r>
+            <a:r>
+              <a:rPr lang="en-US" sz="900" dirty="0" err="1"/>
+              <a:t>Pameters</a:t>
+            </a:r>
+            <a:r>
+              <a:rPr lang="en-US" sz="900" dirty="0"/>
+              <a:t> -------</a:t>
+            </a:r>
+            <a:br>
+              <a:rPr lang="en-US" sz="900" dirty="0"/>
+            </a:br>
+            <a:r>
+              <a:rPr lang="en-US" sz="900" dirty="0"/>
+              <a:t>MMI length 159.4421</a:t>
+            </a:r>
+            <a:br>
+              <a:rPr lang="en-US" sz="900" dirty="0"/>
+            </a:br>
+            <a:r>
+              <a:rPr lang="en-US" sz="900" dirty="0"/>
+              <a:t>MMI length increment 0.0000</a:t>
+            </a:r>
+            <a:br>
+              <a:rPr lang="en-US" sz="900" dirty="0"/>
+            </a:br>
+            <a:r>
+              <a:rPr lang="en-US" sz="900" dirty="0"/>
+              <a:t>IO </a:t>
+            </a:r>
+            <a:r>
+              <a:rPr lang="en-US" sz="900" dirty="0" err="1"/>
+              <a:t>wg</a:t>
+            </a:r>
+            <a:r>
+              <a:rPr lang="en-US" sz="900" dirty="0"/>
+              <a:t> width 1.0000</a:t>
+            </a:r>
+            <a:br>
+              <a:rPr lang="en-US" sz="900" dirty="0"/>
+            </a:br>
+            <a:r>
+              <a:rPr lang="en-US" sz="900" dirty="0"/>
+              <a:t>IO </a:t>
+            </a:r>
+            <a:r>
+              <a:rPr lang="en-US" sz="900" dirty="0" err="1"/>
+              <a:t>wg</a:t>
+            </a:r>
+            <a:r>
+              <a:rPr lang="en-US" sz="900" dirty="0"/>
+              <a:t> width increment 0.0000</a:t>
+            </a:r>
+            <a:br>
+              <a:rPr lang="en-US" sz="900" dirty="0"/>
+            </a:br>
+            <a:r>
+              <a:rPr lang="en-US" sz="900" dirty="0"/>
+              <a:t>------------------------</a:t>
+            </a:r>
+            <a:br>
+              <a:rPr lang="en-US" sz="900" dirty="0"/>
+            </a:br>
+            <a:r>
+              <a:rPr lang="en-US" sz="900" dirty="0"/>
+              <a:t>Total power IN coupled 0.9663</a:t>
+            </a:r>
+            <a:br>
+              <a:rPr lang="en-US" sz="900" dirty="0"/>
+            </a:br>
+            <a:r>
+              <a:rPr lang="en-US" sz="900" dirty="0"/>
+              <a:t>Total OUT power: 0.9560</a:t>
+            </a:r>
+            <a:br>
+              <a:rPr lang="en-US" sz="900" dirty="0"/>
+            </a:br>
+            <a:r>
+              <a:rPr lang="en-US" sz="900" dirty="0"/>
+              <a:t>Excess loss [dB] =  0.1955</a:t>
+            </a:r>
+            <a:br>
+              <a:rPr lang="en-US" sz="900" dirty="0"/>
+            </a:br>
+            <a:r>
+              <a:rPr lang="en-US" sz="900" dirty="0"/>
+              <a:t>------------------------</a:t>
+            </a:r>
+            <a:br>
+              <a:rPr lang="en-US" sz="900" dirty="0"/>
+            </a:br>
+            <a:r>
+              <a:rPr lang="en-US" sz="900" dirty="0"/>
+              <a:t>Power over OUTs:  ['0.4778', '0.4782']</a:t>
+            </a:r>
+            <a:br>
+              <a:rPr lang="en-US" sz="900" dirty="0"/>
+            </a:br>
+            <a:r>
+              <a:rPr lang="en-US" sz="900" dirty="0"/>
+              <a:t>Ratio over OUTs ['0.4998', '0.5002']</a:t>
+            </a:r>
+          </a:p>
+        </p:txBody>
+      </p:sp>
+      <p:sp>
+        <p:nvSpPr>
+          <p:cNvPr id="27" name="CuadroTexto 26">
+            <a:extLst>
+              <a:ext uri="{FF2B5EF4-FFF2-40B4-BE49-F238E27FC236}">
+                <a16:creationId xmlns:a16="http://schemas.microsoft.com/office/drawing/2014/main" id="{F9D0C682-7F6D-CFA4-421B-2F33E556A104}"/>
+              </a:ext>
+            </a:extLst>
+          </p:cNvPr>
+          <p:cNvSpPr txBox="1"/>
+          <p:nvPr/>
+        </p:nvSpPr>
+        <p:spPr>
+          <a:xfrm>
+            <a:off x="8120098" y="4319269"/>
+            <a:ext cx="1837338" cy="246221"/>
+          </a:xfrm>
+          <a:prstGeom prst="rect">
+            <a:avLst/>
+          </a:prstGeom>
+          <a:noFill/>
+        </p:spPr>
+        <p:txBody>
+          <a:bodyPr wrap="square">
+            <a:spAutoFit/>
+          </a:bodyPr>
+          <a:lstStyle/>
+          <a:p>
+            <a:pPr algn="ctr">
+              <a:buNone/>
+            </a:pPr>
+            <a:r>
+              <a:rPr lang="en-US" sz="1000" dirty="0"/>
+              <a:t>Gap = 1</a:t>
+            </a:r>
+          </a:p>
+        </p:txBody>
+      </p:sp>
+      <p:sp>
+        <p:nvSpPr>
+          <p:cNvPr id="28" name="Rectángulo 27">
+            <a:extLst>
+              <a:ext uri="{FF2B5EF4-FFF2-40B4-BE49-F238E27FC236}">
+                <a16:creationId xmlns:a16="http://schemas.microsoft.com/office/drawing/2014/main" id="{2A5973EC-23F9-E22D-E3B9-6EE556CB2158}"/>
+              </a:ext>
+            </a:extLst>
+          </p:cNvPr>
+          <p:cNvSpPr/>
+          <p:nvPr/>
+        </p:nvSpPr>
+        <p:spPr>
+          <a:xfrm>
+            <a:off x="10020479" y="1426774"/>
+            <a:ext cx="1950981" cy="3151116"/>
+          </a:xfrm>
+          <a:prstGeom prst="rect">
+            <a:avLst/>
+          </a:prstGeom>
+          <a:noFill/>
+          <a:ln w="28575">
+            <a:solidFill>
+              <a:srgbClr val="E0700D"/>
+            </a:solidFill>
+          </a:ln>
+        </p:spPr>
+        <p:style>
+          <a:lnRef idx="2">
+            <a:schemeClr val="accent1">
+              <a:shade val="15000"/>
+            </a:schemeClr>
+          </a:lnRef>
+          <a:fillRef idx="1">
+            <a:schemeClr val="accent1"/>
+          </a:fillRef>
+          <a:effectRef idx="0">
+            <a:schemeClr val="accent1"/>
+          </a:effectRef>
+          <a:fontRef idx="minor">
+            <a:schemeClr val="lt1"/>
+          </a:fontRef>
+        </p:style>
+        <p:txBody>
+          <a:bodyPr rtlCol="0" anchor="ctr"/>
+          <a:lstStyle/>
+          <a:p>
+            <a:pPr algn="ctr"/>
+            <a:endParaRPr lang="en-US"/>
+          </a:p>
+        </p:txBody>
+      </p:sp>
+      <p:pic>
+        <p:nvPicPr>
+          <p:cNvPr id="29" name="Picture 2">
+            <a:extLst>
+              <a:ext uri="{FF2B5EF4-FFF2-40B4-BE49-F238E27FC236}">
+                <a16:creationId xmlns:a16="http://schemas.microsoft.com/office/drawing/2014/main" id="{53250557-7F3E-AA6C-6951-A7B69D21C507}"/>
+              </a:ext>
+            </a:extLst>
+          </p:cNvPr>
+          <p:cNvPicPr>
+            <a:picLocks noChangeAspect="1" noChangeArrowheads="1"/>
+          </p:cNvPicPr>
+          <p:nvPr/>
+        </p:nvPicPr>
+        <p:blipFill>
+          <a:blip r:embed="rId10"/>
+          <a:srcRect/>
+          <a:stretch/>
+        </p:blipFill>
+        <p:spPr bwMode="auto">
+          <a:xfrm>
+            <a:off x="10183847" y="1734554"/>
+            <a:ext cx="1624243" cy="275390"/>
+          </a:xfrm>
+          <a:prstGeom prst="rect">
+            <a:avLst/>
+          </a:prstGeom>
+          <a:noFill/>
+          <a:extLst>
+            <a:ext uri="{909E8E84-426E-40DD-AFC4-6F175D3DCCD1}">
+              <a14:hiddenFill xmlns:a14="http://schemas.microsoft.com/office/drawing/2010/main">
+                <a:solidFill>
+                  <a:srgbClr val="FFFFFF"/>
+                </a:solidFill>
+              </a14:hiddenFill>
+            </a:ext>
+          </a:extLst>
+        </p:spPr>
+      </p:pic>
+      <p:sp>
+        <p:nvSpPr>
+          <p:cNvPr id="30" name="CuadroTexto 29">
+            <a:extLst>
+              <a:ext uri="{FF2B5EF4-FFF2-40B4-BE49-F238E27FC236}">
+                <a16:creationId xmlns:a16="http://schemas.microsoft.com/office/drawing/2014/main" id="{AF9633A7-64C7-3ADB-CA6F-B77AD2DD1474}"/>
+              </a:ext>
+            </a:extLst>
+          </p:cNvPr>
+          <p:cNvSpPr txBox="1"/>
+          <p:nvPr/>
+        </p:nvSpPr>
+        <p:spPr>
+          <a:xfrm>
+            <a:off x="10077299" y="2398380"/>
+            <a:ext cx="1837338" cy="1892826"/>
+          </a:xfrm>
+          <a:prstGeom prst="rect">
+            <a:avLst/>
+          </a:prstGeom>
+          <a:noFill/>
+        </p:spPr>
+        <p:txBody>
+          <a:bodyPr wrap="square">
+            <a:spAutoFit/>
+          </a:bodyPr>
+          <a:lstStyle/>
+          <a:p>
+            <a:pPr>
+              <a:buNone/>
+            </a:pPr>
+            <a:r>
+              <a:rPr lang="en-US" sz="900" dirty="0"/>
+              <a:t>------- </a:t>
+            </a:r>
+            <a:r>
+              <a:rPr lang="en-US" sz="900" dirty="0" err="1"/>
+              <a:t>Pameters</a:t>
+            </a:r>
+            <a:r>
+              <a:rPr lang="en-US" sz="900" dirty="0"/>
+              <a:t> -------</a:t>
+            </a:r>
+            <a:br>
+              <a:rPr lang="en-US" sz="900" dirty="0"/>
+            </a:br>
+            <a:r>
+              <a:rPr lang="en-US" sz="900" dirty="0"/>
+              <a:t>MMI length 290.2147</a:t>
+            </a:r>
+            <a:br>
+              <a:rPr lang="en-US" sz="900" dirty="0"/>
+            </a:br>
+            <a:r>
+              <a:rPr lang="en-US" sz="900" dirty="0"/>
+              <a:t>MMI length increment 0.0000</a:t>
+            </a:r>
+            <a:br>
+              <a:rPr lang="en-US" sz="900" dirty="0"/>
+            </a:br>
+            <a:r>
+              <a:rPr lang="en-US" sz="900" dirty="0"/>
+              <a:t>IO </a:t>
+            </a:r>
+            <a:r>
+              <a:rPr lang="en-US" sz="900" dirty="0" err="1"/>
+              <a:t>wg</a:t>
+            </a:r>
+            <a:r>
+              <a:rPr lang="en-US" sz="900" dirty="0"/>
+              <a:t> width 1.0000</a:t>
+            </a:r>
+            <a:br>
+              <a:rPr lang="en-US" sz="900" dirty="0"/>
+            </a:br>
+            <a:r>
+              <a:rPr lang="en-US" sz="900" dirty="0"/>
+              <a:t>IO </a:t>
+            </a:r>
+            <a:r>
+              <a:rPr lang="en-US" sz="900" dirty="0" err="1"/>
+              <a:t>wg</a:t>
+            </a:r>
+            <a:r>
+              <a:rPr lang="en-US" sz="900" dirty="0"/>
+              <a:t> width increment 0.0000</a:t>
+            </a:r>
+            <a:br>
+              <a:rPr lang="en-US" sz="900" dirty="0"/>
+            </a:br>
+            <a:r>
+              <a:rPr lang="en-US" sz="900" dirty="0"/>
+              <a:t>------------------------</a:t>
+            </a:r>
+            <a:br>
+              <a:rPr lang="en-US" sz="900" dirty="0"/>
+            </a:br>
+            <a:r>
+              <a:rPr lang="en-US" sz="900" dirty="0"/>
+              <a:t>Total power IN coupled 0.8916</a:t>
+            </a:r>
+            <a:br>
+              <a:rPr lang="en-US" sz="900" dirty="0"/>
+            </a:br>
+            <a:r>
+              <a:rPr lang="en-US" sz="900" dirty="0"/>
+              <a:t>Total OUT power: 0.8818</a:t>
+            </a:r>
+            <a:br>
+              <a:rPr lang="en-US" sz="900" dirty="0"/>
+            </a:br>
+            <a:r>
+              <a:rPr lang="en-US" sz="900" dirty="0"/>
+              <a:t>Excess loss [dB] =  0.5464</a:t>
+            </a:r>
+            <a:br>
+              <a:rPr lang="en-US" sz="900" dirty="0"/>
+            </a:br>
+            <a:r>
+              <a:rPr lang="en-US" sz="900" dirty="0"/>
+              <a:t>------------------------</a:t>
+            </a:r>
+            <a:br>
+              <a:rPr lang="en-US" sz="900" dirty="0"/>
+            </a:br>
+            <a:r>
+              <a:rPr lang="en-US" sz="900" dirty="0"/>
+              <a:t>Power over OUTs:  ['0.4407', '0.4410']</a:t>
+            </a:r>
+            <a:br>
+              <a:rPr lang="en-US" sz="900" dirty="0"/>
+            </a:br>
+            <a:r>
+              <a:rPr lang="en-US" sz="900" dirty="0"/>
+              <a:t>Ratio over OUTs ['0.4998', '0.5002']</a:t>
+            </a:r>
+          </a:p>
+        </p:txBody>
+      </p:sp>
+      <p:sp>
+        <p:nvSpPr>
+          <p:cNvPr id="31" name="CuadroTexto 30">
+            <a:extLst>
+              <a:ext uri="{FF2B5EF4-FFF2-40B4-BE49-F238E27FC236}">
+                <a16:creationId xmlns:a16="http://schemas.microsoft.com/office/drawing/2014/main" id="{D81769C6-1D0B-FB20-83FF-48665185920B}"/>
+              </a:ext>
+            </a:extLst>
+          </p:cNvPr>
+          <p:cNvSpPr txBox="1"/>
+          <p:nvPr/>
+        </p:nvSpPr>
+        <p:spPr>
+          <a:xfrm>
+            <a:off x="10077299" y="4315694"/>
+            <a:ext cx="1837338" cy="246221"/>
+          </a:xfrm>
+          <a:prstGeom prst="rect">
+            <a:avLst/>
+          </a:prstGeom>
+          <a:noFill/>
+        </p:spPr>
+        <p:txBody>
+          <a:bodyPr wrap="square">
+            <a:spAutoFit/>
+          </a:bodyPr>
+          <a:lstStyle/>
+          <a:p>
+            <a:pPr algn="ctr">
+              <a:buNone/>
+            </a:pPr>
+            <a:r>
+              <a:rPr lang="en-US" sz="1000" dirty="0"/>
+              <a:t>Gap = 1,2</a:t>
             </a:r>
           </a:p>
         </p:txBody>
@@ -12635,7 +15998,7 @@
         <p:spPr>
           <a:xfrm>
             <a:off x="609441" y="4627196"/>
-            <a:ext cx="11199971" cy="2123658"/>
+            <a:ext cx="11199971" cy="3046988"/>
           </a:xfrm>
           <a:prstGeom prst="rect">
             <a:avLst/>
@@ -12699,10 +16062,525 @@
           </a:p>
           <a:p>
             <a:pPr algn="just"/>
+            <a:r>
+              <a:rPr lang="en-US" sz="1200" dirty="0" err="1">
+                <a:solidFill>
+                  <a:srgbClr val="FF0000"/>
+                </a:solidFill>
+                <a:latin typeface="Arial" panose="020B0604020202020204" pitchFamily="34" charset="0"/>
+                <a:cs typeface="Arial" panose="020B0604020202020204" pitchFamily="34" charset="0"/>
+              </a:rPr>
+              <a:t>Ahora</a:t>
+            </a:r>
+            <a:r>
+              <a:rPr lang="en-US" sz="1200" dirty="0">
+                <a:solidFill>
+                  <a:srgbClr val="FF0000"/>
+                </a:solidFill>
+                <a:latin typeface="Arial" panose="020B0604020202020204" pitchFamily="34" charset="0"/>
+                <a:cs typeface="Arial" panose="020B0604020202020204" pitchFamily="34" charset="0"/>
+              </a:rPr>
+              <a:t> </a:t>
+            </a:r>
+            <a:r>
+              <a:rPr lang="en-US" sz="1200" dirty="0" err="1">
+                <a:solidFill>
+                  <a:srgbClr val="FF0000"/>
+                </a:solidFill>
+                <a:latin typeface="Arial" panose="020B0604020202020204" pitchFamily="34" charset="0"/>
+                <a:cs typeface="Arial" panose="020B0604020202020204" pitchFamily="34" charset="0"/>
+              </a:rPr>
+              <a:t>queremos</a:t>
+            </a:r>
+            <a:r>
+              <a:rPr lang="en-US" sz="1200" dirty="0">
+                <a:solidFill>
+                  <a:srgbClr val="FF0000"/>
+                </a:solidFill>
+                <a:latin typeface="Arial" panose="020B0604020202020204" pitchFamily="34" charset="0"/>
+                <a:cs typeface="Arial" panose="020B0604020202020204" pitchFamily="34" charset="0"/>
+              </a:rPr>
+              <a:t> </a:t>
+            </a:r>
+            <a:r>
+              <a:rPr lang="en-US" sz="1200" dirty="0" err="1">
+                <a:solidFill>
+                  <a:srgbClr val="FF0000"/>
+                </a:solidFill>
+                <a:latin typeface="Arial" panose="020B0604020202020204" pitchFamily="34" charset="0"/>
+                <a:cs typeface="Arial" panose="020B0604020202020204" pitchFamily="34" charset="0"/>
+              </a:rPr>
+              <a:t>que</a:t>
+            </a:r>
+            <a:r>
+              <a:rPr lang="en-US" sz="1200" dirty="0">
+                <a:solidFill>
+                  <a:srgbClr val="FF0000"/>
+                </a:solidFill>
+                <a:latin typeface="Arial" panose="020B0604020202020204" pitchFamily="34" charset="0"/>
+                <a:cs typeface="Arial" panose="020B0604020202020204" pitchFamily="34" charset="0"/>
+              </a:rPr>
+              <a:t> las </a:t>
+            </a:r>
+            <a:r>
+              <a:rPr lang="en-US" sz="1200" dirty="0" err="1">
+                <a:solidFill>
+                  <a:srgbClr val="FF0000"/>
+                </a:solidFill>
+                <a:latin typeface="Arial" panose="020B0604020202020204" pitchFamily="34" charset="0"/>
+                <a:cs typeface="Arial" panose="020B0604020202020204" pitchFamily="34" charset="0"/>
+              </a:rPr>
+              <a:t>guías</a:t>
+            </a:r>
+            <a:r>
+              <a:rPr lang="en-US" sz="1200" dirty="0">
+                <a:solidFill>
+                  <a:srgbClr val="FF0000"/>
+                </a:solidFill>
+                <a:latin typeface="Arial" panose="020B0604020202020204" pitchFamily="34" charset="0"/>
+                <a:cs typeface="Arial" panose="020B0604020202020204" pitchFamily="34" charset="0"/>
+              </a:rPr>
+              <a:t> no se </a:t>
+            </a:r>
+            <a:r>
+              <a:rPr lang="en-US" sz="1200" dirty="0" err="1">
+                <a:solidFill>
+                  <a:srgbClr val="FF0000"/>
+                </a:solidFill>
+                <a:latin typeface="Arial" panose="020B0604020202020204" pitchFamily="34" charset="0"/>
+                <a:cs typeface="Arial" panose="020B0604020202020204" pitchFamily="34" charset="0"/>
+              </a:rPr>
+              <a:t>acoplen</a:t>
+            </a:r>
+            <a:r>
+              <a:rPr lang="en-US" sz="1200" dirty="0">
+                <a:solidFill>
+                  <a:srgbClr val="FF0000"/>
+                </a:solidFill>
+                <a:latin typeface="Arial" panose="020B0604020202020204" pitchFamily="34" charset="0"/>
+                <a:cs typeface="Arial" panose="020B0604020202020204" pitchFamily="34" charset="0"/>
+              </a:rPr>
+              <a:t>, </a:t>
+            </a:r>
+            <a:r>
+              <a:rPr lang="en-US" sz="1200" dirty="0" err="1">
+                <a:solidFill>
+                  <a:srgbClr val="FF0000"/>
+                </a:solidFill>
+                <a:latin typeface="Arial" panose="020B0604020202020204" pitchFamily="34" charset="0"/>
+                <a:cs typeface="Arial" panose="020B0604020202020204" pitchFamily="34" charset="0"/>
+              </a:rPr>
+              <a:t>evaluar</a:t>
+            </a:r>
+            <a:r>
+              <a:rPr lang="en-US" sz="1200" dirty="0">
+                <a:solidFill>
+                  <a:srgbClr val="FF0000"/>
+                </a:solidFill>
+                <a:latin typeface="Arial" panose="020B0604020202020204" pitchFamily="34" charset="0"/>
+                <a:cs typeface="Arial" panose="020B0604020202020204" pitchFamily="34" charset="0"/>
+              </a:rPr>
+              <a:t> </a:t>
+            </a:r>
+            <a:r>
+              <a:rPr lang="en-US" sz="1200" dirty="0" err="1">
+                <a:solidFill>
+                  <a:srgbClr val="FF0000"/>
+                </a:solidFill>
+                <a:latin typeface="Arial" panose="020B0604020202020204" pitchFamily="34" charset="0"/>
+                <a:cs typeface="Arial" panose="020B0604020202020204" pitchFamily="34" charset="0"/>
+              </a:rPr>
+              <a:t>cual</a:t>
+            </a:r>
+            <a:r>
+              <a:rPr lang="en-US" sz="1200" dirty="0">
+                <a:solidFill>
+                  <a:srgbClr val="FF0000"/>
+                </a:solidFill>
+                <a:latin typeface="Arial" panose="020B0604020202020204" pitchFamily="34" charset="0"/>
+                <a:cs typeface="Arial" panose="020B0604020202020204" pitchFamily="34" charset="0"/>
+              </a:rPr>
+              <a:t> es la K y </a:t>
+            </a:r>
+            <a:r>
+              <a:rPr lang="en-US" sz="1200" dirty="0" err="1">
+                <a:solidFill>
+                  <a:srgbClr val="FF0000"/>
+                </a:solidFill>
+                <a:latin typeface="Arial" panose="020B0604020202020204" pitchFamily="34" charset="0"/>
+                <a:cs typeface="Arial" panose="020B0604020202020204" pitchFamily="34" charset="0"/>
+              </a:rPr>
+              <a:t>ver</a:t>
+            </a:r>
+            <a:r>
+              <a:rPr lang="en-US" sz="1200" dirty="0">
+                <a:solidFill>
+                  <a:srgbClr val="FF0000"/>
+                </a:solidFill>
+                <a:latin typeface="Arial" panose="020B0604020202020204" pitchFamily="34" charset="0"/>
+                <a:cs typeface="Arial" panose="020B0604020202020204" pitchFamily="34" charset="0"/>
+              </a:rPr>
+              <a:t> </a:t>
+            </a:r>
+            <a:r>
+              <a:rPr lang="en-US" sz="1200" dirty="0" err="1">
+                <a:solidFill>
+                  <a:srgbClr val="FF0000"/>
+                </a:solidFill>
+                <a:latin typeface="Arial" panose="020B0604020202020204" pitchFamily="34" charset="0"/>
+                <a:cs typeface="Arial" panose="020B0604020202020204" pitchFamily="34" charset="0"/>
+              </a:rPr>
+              <a:t>que</a:t>
+            </a:r>
+            <a:r>
+              <a:rPr lang="en-US" sz="1200" dirty="0">
+                <a:solidFill>
+                  <a:srgbClr val="FF0000"/>
+                </a:solidFill>
+                <a:latin typeface="Arial" panose="020B0604020202020204" pitchFamily="34" charset="0"/>
+                <a:cs typeface="Arial" panose="020B0604020202020204" pitchFamily="34" charset="0"/>
+              </a:rPr>
+              <a:t> se </a:t>
+            </a:r>
+            <a:r>
+              <a:rPr lang="en-US" sz="1200" dirty="0" err="1">
+                <a:solidFill>
+                  <a:srgbClr val="FF0000"/>
+                </a:solidFill>
+                <a:latin typeface="Arial" panose="020B0604020202020204" pitchFamily="34" charset="0"/>
+                <a:cs typeface="Arial" panose="020B0604020202020204" pitchFamily="34" charset="0"/>
+              </a:rPr>
+              <a:t>mantenga</a:t>
+            </a:r>
+            <a:r>
+              <a:rPr lang="en-US" sz="1200" dirty="0">
+                <a:solidFill>
+                  <a:srgbClr val="FF0000"/>
+                </a:solidFill>
+                <a:latin typeface="Arial" panose="020B0604020202020204" pitchFamily="34" charset="0"/>
+                <a:cs typeface="Arial" panose="020B0604020202020204" pitchFamily="34" charset="0"/>
+              </a:rPr>
+              <a:t> </a:t>
+            </a:r>
+            <a:r>
+              <a:rPr lang="en-US" sz="1200" dirty="0" err="1">
+                <a:solidFill>
+                  <a:srgbClr val="FF0000"/>
+                </a:solidFill>
+                <a:latin typeface="Arial" panose="020B0604020202020204" pitchFamily="34" charset="0"/>
+                <a:cs typeface="Arial" panose="020B0604020202020204" pitchFamily="34" charset="0"/>
+              </a:rPr>
+              <a:t>bajita</a:t>
+            </a:r>
+            <a:r>
+              <a:rPr lang="en-US" sz="1200" dirty="0">
+                <a:solidFill>
+                  <a:srgbClr val="FF0000"/>
+                </a:solidFill>
+                <a:latin typeface="Arial" panose="020B0604020202020204" pitchFamily="34" charset="0"/>
+                <a:cs typeface="Arial" panose="020B0604020202020204" pitchFamily="34" charset="0"/>
+              </a:rPr>
+              <a:t>, con dos </a:t>
+            </a:r>
+            <a:r>
+              <a:rPr lang="en-US" sz="1200" dirty="0" err="1">
+                <a:solidFill>
+                  <a:srgbClr val="FF0000"/>
+                </a:solidFill>
+                <a:latin typeface="Arial" panose="020B0604020202020204" pitchFamily="34" charset="0"/>
+                <a:cs typeface="Arial" panose="020B0604020202020204" pitchFamily="34" charset="0"/>
+              </a:rPr>
+              <a:t>guías</a:t>
+            </a:r>
+            <a:r>
+              <a:rPr lang="en-US" sz="1200" dirty="0">
+                <a:solidFill>
+                  <a:srgbClr val="FF0000"/>
+                </a:solidFill>
+                <a:latin typeface="Arial" panose="020B0604020202020204" pitchFamily="34" charset="0"/>
+                <a:cs typeface="Arial" panose="020B0604020202020204" pitchFamily="34" charset="0"/>
+              </a:rPr>
+              <a:t> </a:t>
+            </a:r>
+            <a:r>
+              <a:rPr lang="en-US" sz="1200" dirty="0" err="1">
+                <a:solidFill>
+                  <a:srgbClr val="FF0000"/>
+                </a:solidFill>
+                <a:latin typeface="Arial" panose="020B0604020202020204" pitchFamily="34" charset="0"/>
+                <a:cs typeface="Arial" panose="020B0604020202020204" pitchFamily="34" charset="0"/>
+              </a:rPr>
+              <a:t>paralelas</a:t>
+            </a:r>
+            <a:r>
+              <a:rPr lang="en-US" sz="1200" dirty="0">
+                <a:solidFill>
+                  <a:srgbClr val="FF0000"/>
+                </a:solidFill>
+                <a:latin typeface="Arial" panose="020B0604020202020204" pitchFamily="34" charset="0"/>
+                <a:cs typeface="Arial" panose="020B0604020202020204" pitchFamily="34" charset="0"/>
+              </a:rPr>
+              <a:t>.</a:t>
+            </a:r>
+          </a:p>
+          <a:p>
+            <a:pPr algn="just"/>
             <a:endParaRPr lang="en-US" sz="1200" dirty="0">
+              <a:solidFill>
+                <a:srgbClr val="FF0000"/>
+              </a:solidFill>
               <a:latin typeface="Arial" panose="020B0604020202020204" pitchFamily="34" charset="0"/>
               <a:cs typeface="Arial" panose="020B0604020202020204" pitchFamily="34" charset="0"/>
             </a:endParaRPr>
+          </a:p>
+          <a:p>
+            <a:pPr algn="just"/>
+            <a:r>
+              <a:rPr lang="en-US" sz="1200" dirty="0" err="1">
+                <a:solidFill>
+                  <a:srgbClr val="FF0000"/>
+                </a:solidFill>
+                <a:latin typeface="Arial" panose="020B0604020202020204" pitchFamily="34" charset="0"/>
+                <a:cs typeface="Arial" panose="020B0604020202020204" pitchFamily="34" charset="0"/>
+              </a:rPr>
+              <a:t>Calcular</a:t>
+            </a:r>
+            <a:r>
+              <a:rPr lang="en-US" sz="1200" dirty="0">
+                <a:solidFill>
+                  <a:srgbClr val="FF0000"/>
+                </a:solidFill>
+                <a:latin typeface="Arial" panose="020B0604020202020204" pitchFamily="34" charset="0"/>
+                <a:cs typeface="Arial" panose="020B0604020202020204" pitchFamily="34" charset="0"/>
+              </a:rPr>
+              <a:t> la </a:t>
+            </a:r>
+            <a:r>
+              <a:rPr lang="en-US" sz="1200" dirty="0" err="1">
+                <a:solidFill>
+                  <a:srgbClr val="FF0000"/>
+                </a:solidFill>
+                <a:latin typeface="Arial" panose="020B0604020202020204" pitchFamily="34" charset="0"/>
+                <a:cs typeface="Arial" panose="020B0604020202020204" pitchFamily="34" charset="0"/>
+              </a:rPr>
+              <a:t>Lpi</a:t>
+            </a:r>
+            <a:r>
+              <a:rPr lang="en-US" sz="1200" dirty="0">
+                <a:solidFill>
+                  <a:srgbClr val="FF0000"/>
+                </a:solidFill>
+                <a:latin typeface="Arial" panose="020B0604020202020204" pitchFamily="34" charset="0"/>
+                <a:cs typeface="Arial" panose="020B0604020202020204" pitchFamily="34" charset="0"/>
+              </a:rPr>
+              <a:t> 1º, 2º </a:t>
+            </a:r>
+            <a:r>
+              <a:rPr lang="en-US" sz="1200" dirty="0" err="1">
+                <a:solidFill>
+                  <a:srgbClr val="FF0000"/>
+                </a:solidFill>
+                <a:latin typeface="Arial" panose="020B0604020202020204" pitchFamily="34" charset="0"/>
+                <a:cs typeface="Arial" panose="020B0604020202020204" pitchFamily="34" charset="0"/>
+              </a:rPr>
+              <a:t>ver</a:t>
+            </a:r>
+            <a:r>
+              <a:rPr lang="en-US" sz="1200" dirty="0">
+                <a:solidFill>
+                  <a:srgbClr val="FF0000"/>
+                </a:solidFill>
+                <a:latin typeface="Arial" panose="020B0604020202020204" pitchFamily="34" charset="0"/>
+                <a:cs typeface="Arial" panose="020B0604020202020204" pitchFamily="34" charset="0"/>
+              </a:rPr>
+              <a:t> </a:t>
+            </a:r>
+            <a:r>
+              <a:rPr lang="en-US" sz="1200" dirty="0" err="1">
+                <a:solidFill>
+                  <a:srgbClr val="FF0000"/>
+                </a:solidFill>
+                <a:latin typeface="Arial" panose="020B0604020202020204" pitchFamily="34" charset="0"/>
+                <a:cs typeface="Arial" panose="020B0604020202020204" pitchFamily="34" charset="0"/>
+              </a:rPr>
+              <a:t>cuando</a:t>
+            </a:r>
+            <a:r>
+              <a:rPr lang="en-US" sz="1200" dirty="0">
+                <a:solidFill>
+                  <a:srgbClr val="FF0000"/>
+                </a:solidFill>
+                <a:latin typeface="Arial" panose="020B0604020202020204" pitchFamily="34" charset="0"/>
+                <a:cs typeface="Arial" panose="020B0604020202020204" pitchFamily="34" charset="0"/>
+              </a:rPr>
+              <a:t> se satisfice la </a:t>
+            </a:r>
+            <a:r>
+              <a:rPr lang="en-US" sz="1200" dirty="0" err="1">
+                <a:solidFill>
+                  <a:srgbClr val="FF0000"/>
+                </a:solidFill>
+                <a:latin typeface="Arial" panose="020B0604020202020204" pitchFamily="34" charset="0"/>
+                <a:cs typeface="Arial" panose="020B0604020202020204" pitchFamily="34" charset="0"/>
+              </a:rPr>
+              <a:t>condición</a:t>
+            </a:r>
+            <a:r>
+              <a:rPr lang="en-US" sz="1200" dirty="0">
+                <a:solidFill>
+                  <a:srgbClr val="FF0000"/>
+                </a:solidFill>
+                <a:latin typeface="Arial" panose="020B0604020202020204" pitchFamily="34" charset="0"/>
+                <a:cs typeface="Arial" panose="020B0604020202020204" pitchFamily="34" charset="0"/>
+              </a:rPr>
+              <a:t> del K</a:t>
+            </a:r>
+          </a:p>
+          <a:p>
+            <a:pPr algn="just"/>
+            <a:r>
+              <a:rPr lang="en-US" sz="1200" dirty="0" err="1">
+                <a:solidFill>
+                  <a:srgbClr val="FF0000"/>
+                </a:solidFill>
+                <a:latin typeface="Arial" panose="020B0604020202020204" pitchFamily="34" charset="0"/>
+                <a:cs typeface="Arial" panose="020B0604020202020204" pitchFamily="34" charset="0"/>
+              </a:rPr>
+              <a:t>Ir</a:t>
+            </a:r>
+            <a:r>
+              <a:rPr lang="en-US" sz="1200" dirty="0">
+                <a:solidFill>
+                  <a:srgbClr val="FF0000"/>
+                </a:solidFill>
+                <a:latin typeface="Arial" panose="020B0604020202020204" pitchFamily="34" charset="0"/>
+                <a:cs typeface="Arial" panose="020B0604020202020204" pitchFamily="34" charset="0"/>
+              </a:rPr>
+              <a:t> probando, </a:t>
+            </a:r>
+            <a:r>
+              <a:rPr lang="en-US" sz="1200" dirty="0" err="1">
+                <a:solidFill>
+                  <a:srgbClr val="FF0000"/>
+                </a:solidFill>
+                <a:latin typeface="Arial" panose="020B0604020202020204" pitchFamily="34" charset="0"/>
+                <a:cs typeface="Arial" panose="020B0604020202020204" pitchFamily="34" charset="0"/>
+              </a:rPr>
+              <a:t>cuando</a:t>
+            </a:r>
+            <a:r>
+              <a:rPr lang="en-US" sz="1200" dirty="0">
+                <a:solidFill>
+                  <a:srgbClr val="FF0000"/>
+                </a:solidFill>
+                <a:latin typeface="Arial" panose="020B0604020202020204" pitchFamily="34" charset="0"/>
+                <a:cs typeface="Arial" panose="020B0604020202020204" pitchFamily="34" charset="0"/>
+              </a:rPr>
+              <a:t> se </a:t>
+            </a:r>
+            <a:r>
+              <a:rPr lang="en-US" sz="1200" dirty="0" err="1">
+                <a:solidFill>
+                  <a:srgbClr val="FF0000"/>
+                </a:solidFill>
+                <a:latin typeface="Arial" panose="020B0604020202020204" pitchFamily="34" charset="0"/>
+                <a:cs typeface="Arial" panose="020B0604020202020204" pitchFamily="34" charset="0"/>
+              </a:rPr>
+              <a:t>tenga</a:t>
+            </a:r>
+            <a:r>
+              <a:rPr lang="en-US" sz="1200" dirty="0">
+                <a:solidFill>
+                  <a:srgbClr val="FF0000"/>
+                </a:solidFill>
+                <a:latin typeface="Arial" panose="020B0604020202020204" pitchFamily="34" charset="0"/>
+                <a:cs typeface="Arial" panose="020B0604020202020204" pitchFamily="34" charset="0"/>
+              </a:rPr>
+              <a:t> </a:t>
+            </a:r>
+            <a:r>
+              <a:rPr lang="en-US" sz="1200" dirty="0" err="1">
+                <a:solidFill>
+                  <a:srgbClr val="FF0000"/>
+                </a:solidFill>
+                <a:latin typeface="Arial" panose="020B0604020202020204" pitchFamily="34" charset="0"/>
+                <a:cs typeface="Arial" panose="020B0604020202020204" pitchFamily="34" charset="0"/>
+              </a:rPr>
+              <a:t>cerca</a:t>
+            </a:r>
+            <a:r>
+              <a:rPr lang="en-US" sz="1200" dirty="0">
+                <a:solidFill>
+                  <a:srgbClr val="FF0000"/>
+                </a:solidFill>
+                <a:latin typeface="Arial" panose="020B0604020202020204" pitchFamily="34" charset="0"/>
+                <a:cs typeface="Arial" panose="020B0604020202020204" pitchFamily="34" charset="0"/>
+              </a:rPr>
+              <a:t>, se </a:t>
+            </a:r>
+            <a:r>
+              <a:rPr lang="en-US" sz="1200" dirty="0" err="1">
+                <a:solidFill>
+                  <a:srgbClr val="FF0000"/>
+                </a:solidFill>
+                <a:latin typeface="Arial" panose="020B0604020202020204" pitchFamily="34" charset="0"/>
+                <a:cs typeface="Arial" panose="020B0604020202020204" pitchFamily="34" charset="0"/>
+              </a:rPr>
+              <a:t>hace</a:t>
+            </a:r>
+            <a:r>
+              <a:rPr lang="en-US" sz="1200" dirty="0">
+                <a:solidFill>
+                  <a:srgbClr val="FF0000"/>
+                </a:solidFill>
+                <a:latin typeface="Arial" panose="020B0604020202020204" pitchFamily="34" charset="0"/>
+                <a:cs typeface="Arial" panose="020B0604020202020204" pitchFamily="34" charset="0"/>
+              </a:rPr>
+              <a:t> </a:t>
+            </a:r>
+            <a:r>
+              <a:rPr lang="en-US" sz="1200" dirty="0" err="1">
+                <a:solidFill>
+                  <a:srgbClr val="FF0000"/>
+                </a:solidFill>
+                <a:latin typeface="Arial" panose="020B0604020202020204" pitchFamily="34" charset="0"/>
+                <a:cs typeface="Arial" panose="020B0604020202020204" pitchFamily="34" charset="0"/>
+              </a:rPr>
+              <a:t>barrido</a:t>
+            </a:r>
+            <a:r>
+              <a:rPr lang="en-US" sz="1200" dirty="0">
+                <a:solidFill>
+                  <a:srgbClr val="FF0000"/>
+                </a:solidFill>
+                <a:latin typeface="Arial" panose="020B0604020202020204" pitchFamily="34" charset="0"/>
+                <a:cs typeface="Arial" panose="020B0604020202020204" pitchFamily="34" charset="0"/>
+              </a:rPr>
+              <a:t> con mas precision.</a:t>
+            </a:r>
+          </a:p>
+          <a:p>
+            <a:pPr algn="just"/>
+            <a:endParaRPr lang="en-US" sz="1200" dirty="0">
+              <a:solidFill>
+                <a:srgbClr val="FF0000"/>
+              </a:solidFill>
+              <a:latin typeface="Arial" panose="020B0604020202020204" pitchFamily="34" charset="0"/>
+              <a:cs typeface="Arial" panose="020B0604020202020204" pitchFamily="34" charset="0"/>
+            </a:endParaRPr>
+          </a:p>
+          <a:p>
+            <a:pPr algn="just"/>
+            <a:r>
+              <a:rPr lang="en-US" sz="1200" dirty="0">
+                <a:solidFill>
+                  <a:srgbClr val="FF0000"/>
+                </a:solidFill>
+                <a:latin typeface="Arial" panose="020B0604020202020204" pitchFamily="34" charset="0"/>
+                <a:cs typeface="Arial" panose="020B0604020202020204" pitchFamily="34" charset="0"/>
+              </a:rPr>
+              <a:t>HASTA AQUÍ HOY 10/03/2026.</a:t>
+            </a:r>
           </a:p>
           <a:p>
             <a:pPr algn="just"/>
@@ -12970,8 +16848,8 @@
           </p:sp>
         </mc:Fallback>
       </mc:AlternateContent>
-      <mc:AlternateContent xmlns:mc="http://schemas.openxmlformats.org/markup-compatibility/2006">
-        <mc:Choice xmlns:a14="http://schemas.microsoft.com/office/drawing/2010/main" Requires="a14">
+      <mc:AlternateContent xmlns:mc="http://schemas.openxmlformats.org/markup-compatibility/2006" xmlns:a14="http://schemas.microsoft.com/office/drawing/2010/main">
+        <mc:Choice Requires="a14">
           <p:sp>
             <p:nvSpPr>
               <p:cNvPr id="10" name="CuadroTexto 9">
@@ -13057,7 +16935,7 @@
             </p:txBody>
           </p:sp>
         </mc:Choice>
-        <mc:Fallback>
+        <mc:Fallback xmlns="">
           <p:sp>
             <p:nvSpPr>
               <p:cNvPr id="10" name="CuadroTexto 9">
@@ -13428,8 +17306,8 @@
           </a:p>
         </p:txBody>
       </p:sp>
-      <mc:AlternateContent xmlns:mc="http://schemas.openxmlformats.org/markup-compatibility/2006">
-        <mc:Choice xmlns:a14="http://schemas.microsoft.com/office/drawing/2010/main" Requires="a14">
+      <mc:AlternateContent xmlns:mc="http://schemas.openxmlformats.org/markup-compatibility/2006" xmlns:a14="http://schemas.microsoft.com/office/drawing/2010/main">
+        <mc:Choice Requires="a14">
           <p:sp>
             <p:nvSpPr>
               <p:cNvPr id="4" name="Marcador de texto 2">
@@ -13663,7 +17541,7 @@
             </p:txBody>
           </p:sp>
         </mc:Choice>
-        <mc:Fallback>
+        <mc:Fallback xmlns="">
           <p:sp>
             <p:nvSpPr>
               <p:cNvPr id="4" name="Marcador de texto 2">

</xml_diff>

<commit_message>
practica 24/03, planteado apartado 4,5,6,7
</commit_message>
<xml_diff>
--- a/LabBook_20.pptx
+++ b/LabBook_20.pptx
@@ -819,7 +819,7 @@
           <a:p>
             <a:fld id="{8438F8DC-35B0-48E6-A86E-42F1F08DD00F}" type="datetimeFigureOut">
               <a:rPr lang="es-ES" smtClean="0"/>
-              <a:t>10/03/2026</a:t>
+              <a:t>24/03/2026</a:t>
             </a:fld>
             <a:endParaRPr lang="es-ES"/>
           </a:p>
@@ -996,7 +996,7 @@
           <a:p>
             <a:fld id="{FACBDC12-F39B-4B97-8F4D-6734F9D366FF}" type="datetimeFigureOut">
               <a:rPr lang="es-ES" smtClean="0"/>
-              <a:t>10/03/2026</a:t>
+              <a:t>24/03/2026</a:t>
             </a:fld>
             <a:endParaRPr lang="es-ES"/>
           </a:p>
@@ -4598,6 +4598,234 @@
           </a:p>
         </p:txBody>
       </p:sp>
+      <p:pic>
+        <p:nvPicPr>
+          <p:cNvPr id="9" name="Imagen 8">
+            <a:extLst>
+              <a:ext uri="{FF2B5EF4-FFF2-40B4-BE49-F238E27FC236}">
+                <a16:creationId xmlns:a16="http://schemas.microsoft.com/office/drawing/2014/main" id="{60918316-77DF-688B-D7C5-6E5DF89C2CE5}"/>
+              </a:ext>
+            </a:extLst>
+          </p:cNvPr>
+          <p:cNvPicPr>
+            <a:picLocks noChangeAspect="1"/>
+          </p:cNvPicPr>
+          <p:nvPr/>
+        </p:nvPicPr>
+        <p:blipFill>
+          <a:blip r:embed="rId5"/>
+          <a:stretch>
+            <a:fillRect/>
+          </a:stretch>
+        </p:blipFill>
+        <p:spPr>
+          <a:xfrm>
+            <a:off x="827801" y="1927491"/>
+            <a:ext cx="5381625" cy="2219325"/>
+          </a:xfrm>
+          <a:prstGeom prst="rect">
+            <a:avLst/>
+          </a:prstGeom>
+        </p:spPr>
+      </p:pic>
+      <p:sp>
+        <p:nvSpPr>
+          <p:cNvPr id="12" name="CuadroTexto 11">
+            <a:extLst>
+              <a:ext uri="{FF2B5EF4-FFF2-40B4-BE49-F238E27FC236}">
+                <a16:creationId xmlns:a16="http://schemas.microsoft.com/office/drawing/2014/main" id="{0E458332-7984-E6B4-69D5-975E8F4A2EAA}"/>
+              </a:ext>
+            </a:extLst>
+          </p:cNvPr>
+          <p:cNvSpPr txBox="1"/>
+          <p:nvPr/>
+        </p:nvSpPr>
+        <p:spPr>
+          <a:xfrm>
+            <a:off x="8876382" y="1927491"/>
+            <a:ext cx="1837338" cy="1892826"/>
+          </a:xfrm>
+          <a:prstGeom prst="rect">
+            <a:avLst/>
+          </a:prstGeom>
+          <a:noFill/>
+        </p:spPr>
+        <p:txBody>
+          <a:bodyPr wrap="square">
+            <a:spAutoFit/>
+          </a:bodyPr>
+          <a:lstStyle/>
+          <a:p>
+            <a:pPr algn="ctr">
+              <a:buNone/>
+            </a:pPr>
+            <a:r>
+              <a:rPr lang="en-US" sz="900" dirty="0">
+                <a:effectLst/>
+              </a:rPr>
+              <a:t>------- </a:t>
+            </a:r>
+            <a:r>
+              <a:rPr lang="en-US" sz="900" dirty="0" err="1">
+                <a:effectLst/>
+              </a:rPr>
+              <a:t>Pameters</a:t>
+            </a:r>
+            <a:r>
+              <a:rPr lang="en-US" sz="900" dirty="0">
+                <a:effectLst/>
+              </a:rPr>
+              <a:t> -------</a:t>
+            </a:r>
+          </a:p>
+          <a:p>
+            <a:pPr algn="ctr">
+              <a:buNone/>
+            </a:pPr>
+            <a:r>
+              <a:rPr lang="en-US" sz="900" dirty="0">
+                <a:effectLst/>
+              </a:rPr>
+              <a:t>MMI length 34.5180</a:t>
+            </a:r>
+          </a:p>
+          <a:p>
+            <a:pPr algn="ctr">
+              <a:buNone/>
+            </a:pPr>
+            <a:r>
+              <a:rPr lang="en-US" sz="900" dirty="0">
+                <a:effectLst/>
+              </a:rPr>
+              <a:t>MMI length increment 0.0000</a:t>
+            </a:r>
+          </a:p>
+          <a:p>
+            <a:pPr algn="ctr">
+              <a:buNone/>
+            </a:pPr>
+            <a:r>
+              <a:rPr lang="en-US" sz="900" dirty="0">
+                <a:effectLst/>
+              </a:rPr>
+              <a:t>IO </a:t>
+            </a:r>
+            <a:r>
+              <a:rPr lang="en-US" sz="900" dirty="0" err="1">
+                <a:effectLst/>
+              </a:rPr>
+              <a:t>wg</a:t>
+            </a:r>
+            <a:r>
+              <a:rPr lang="en-US" sz="900" dirty="0">
+                <a:effectLst/>
+              </a:rPr>
+              <a:t> width 1.0000</a:t>
+            </a:r>
+          </a:p>
+          <a:p>
+            <a:pPr algn="ctr">
+              <a:buNone/>
+            </a:pPr>
+            <a:r>
+              <a:rPr lang="en-US" sz="900" dirty="0">
+                <a:effectLst/>
+              </a:rPr>
+              <a:t>IO </a:t>
+            </a:r>
+            <a:r>
+              <a:rPr lang="en-US" sz="900" dirty="0" err="1">
+                <a:effectLst/>
+              </a:rPr>
+              <a:t>wg</a:t>
+            </a:r>
+            <a:r>
+              <a:rPr lang="en-US" sz="900" dirty="0">
+                <a:effectLst/>
+              </a:rPr>
+              <a:t> width increment 0.0000</a:t>
+            </a:r>
+          </a:p>
+          <a:p>
+            <a:pPr algn="ctr">
+              <a:buNone/>
+            </a:pPr>
+            <a:r>
+              <a:rPr lang="en-US" sz="900" dirty="0">
+                <a:effectLst/>
+              </a:rPr>
+              <a:t>------------------------</a:t>
+            </a:r>
+          </a:p>
+          <a:p>
+            <a:pPr algn="ctr">
+              <a:buNone/>
+            </a:pPr>
+            <a:r>
+              <a:rPr lang="en-US" sz="900" dirty="0">
+                <a:effectLst/>
+              </a:rPr>
+              <a:t>Total power IN coupled 0.9604</a:t>
+            </a:r>
+          </a:p>
+          <a:p>
+            <a:pPr algn="ctr">
+              <a:buNone/>
+            </a:pPr>
+            <a:r>
+              <a:rPr lang="en-US" sz="900" dirty="0">
+                <a:effectLst/>
+              </a:rPr>
+              <a:t>Total OUT power: 0.9075</a:t>
+            </a:r>
+          </a:p>
+          <a:p>
+            <a:pPr algn="ctr">
+              <a:buNone/>
+            </a:pPr>
+            <a:r>
+              <a:rPr lang="en-US" sz="900" dirty="0">
+                <a:effectLst/>
+              </a:rPr>
+              <a:t>Excess loss [dB] =  0.4217</a:t>
+            </a:r>
+          </a:p>
+          <a:p>
+            <a:pPr algn="ctr">
+              <a:buNone/>
+            </a:pPr>
+            <a:r>
+              <a:rPr lang="en-US" sz="900" dirty="0">
+                <a:effectLst/>
+              </a:rPr>
+              <a:t>------------------------</a:t>
+            </a:r>
+          </a:p>
+          <a:p>
+            <a:pPr algn="ctr">
+              <a:buNone/>
+            </a:pPr>
+            <a:r>
+              <a:rPr lang="en-US" sz="900" dirty="0">
+                <a:effectLst/>
+              </a:rPr>
+              <a:t>Power over OUTs:  ['0.4675', '0.4399']</a:t>
+            </a:r>
+          </a:p>
+          <a:p>
+            <a:pPr algn="ctr">
+              <a:buNone/>
+            </a:pPr>
+            <a:r>
+              <a:rPr lang="en-US" sz="900" dirty="0">
+                <a:effectLst/>
+              </a:rPr>
+              <a:t>Ratio over OUTs ['0.5152', '0.4848']</a:t>
+            </a:r>
+            <a:endParaRPr lang="en-US" sz="900" dirty="0"/>
+          </a:p>
+        </p:txBody>
+      </p:sp>
     </p:spTree>
     <p:extLst>
       <p:ext uri="{BB962C8B-B14F-4D97-AF65-F5344CB8AC3E}">
@@ -4813,7 +5041,7 @@
         <p:spPr>
           <a:xfrm>
             <a:off x="609441" y="4819471"/>
-            <a:ext cx="11199971" cy="1384995"/>
+            <a:ext cx="11199971" cy="1569660"/>
           </a:xfrm>
           <a:prstGeom prst="rect">
             <a:avLst/>
@@ -4850,6 +5078,39 @@
               <a:latin typeface="Arial" panose="020B0604020202020204" pitchFamily="34" charset="0"/>
               <a:cs typeface="Arial" panose="020B0604020202020204" pitchFamily="34" charset="0"/>
             </a:endParaRPr>
+          </a:p>
+          <a:p>
+            <a:pPr algn="just"/>
+            <a:r>
+              <a:rPr lang="en-US" sz="1200" dirty="0">
+                <a:solidFill>
+                  <a:srgbClr val="FF0000"/>
+                </a:solidFill>
+                <a:latin typeface="Arial" panose="020B0604020202020204" pitchFamily="34" charset="0"/>
+                <a:cs typeface="Arial" panose="020B0604020202020204" pitchFamily="34" charset="0"/>
+              </a:rPr>
+              <a:t>SE HAN OPTIMIZADO LAS POSICIONES DE LAS ENTRADAS Y SALIDAS (CREEMOS QUE AMBAS), PARA LAS PÉRDIDAS (0.5 Más o </a:t>
+            </a:r>
+            <a:r>
+              <a:rPr lang="en-US" sz="1200" dirty="0" err="1">
+                <a:solidFill>
+                  <a:srgbClr val="FF0000"/>
+                </a:solidFill>
+                <a:latin typeface="Arial" panose="020B0604020202020204" pitchFamily="34" charset="0"/>
+                <a:cs typeface="Arial" panose="020B0604020202020204" pitchFamily="34" charset="0"/>
+              </a:rPr>
+              <a:t>menos</a:t>
+            </a:r>
+            <a:r>
+              <a:rPr lang="en-US" sz="1200" dirty="0">
+                <a:solidFill>
+                  <a:srgbClr val="FF0000"/>
+                </a:solidFill>
+                <a:latin typeface="Arial" panose="020B0604020202020204" pitchFamily="34" charset="0"/>
+                <a:cs typeface="Arial" panose="020B0604020202020204" pitchFamily="34" charset="0"/>
+              </a:rPr>
+              <a:t> de ratio)</a:t>
+            </a:r>
           </a:p>
           <a:p>
             <a:pPr algn="just"/>
@@ -5267,7 +5528,7 @@
         <p:spPr>
           <a:xfrm>
             <a:off x="609441" y="4819471"/>
-            <a:ext cx="11199971" cy="1384995"/>
+            <a:ext cx="11199971" cy="1569660"/>
           </a:xfrm>
           <a:prstGeom prst="rect">
             <a:avLst/>
@@ -5318,6 +5579,89 @@
               <a:latin typeface="Arial" panose="020B0604020202020204" pitchFamily="34" charset="0"/>
               <a:cs typeface="Arial" panose="020B0604020202020204" pitchFamily="34" charset="0"/>
             </a:endParaRPr>
+          </a:p>
+          <a:p>
+            <a:pPr algn="just"/>
+            <a:r>
+              <a:rPr lang="en-US" sz="1200" dirty="0" err="1">
+                <a:solidFill>
+                  <a:srgbClr val="FF0000"/>
+                </a:solidFill>
+                <a:latin typeface="Arial" panose="020B0604020202020204" pitchFamily="34" charset="0"/>
+                <a:cs typeface="Arial" panose="020B0604020202020204" pitchFamily="34" charset="0"/>
+              </a:rPr>
+              <a:t>Optimizar</a:t>
+            </a:r>
+            <a:r>
+              <a:rPr lang="en-US" sz="1200" dirty="0">
+                <a:solidFill>
+                  <a:srgbClr val="FF0000"/>
+                </a:solidFill>
+                <a:latin typeface="Arial" panose="020B0604020202020204" pitchFamily="34" charset="0"/>
+                <a:cs typeface="Arial" panose="020B0604020202020204" pitchFamily="34" charset="0"/>
+              </a:rPr>
+              <a:t> para </a:t>
+            </a:r>
+            <a:r>
+              <a:rPr lang="en-US" sz="1200" dirty="0" err="1">
+                <a:solidFill>
+                  <a:srgbClr val="FF0000"/>
+                </a:solidFill>
+                <a:latin typeface="Arial" panose="020B0604020202020204" pitchFamily="34" charset="0"/>
+                <a:cs typeface="Arial" panose="020B0604020202020204" pitchFamily="34" charset="0"/>
+              </a:rPr>
+              <a:t>conseguir</a:t>
+            </a:r>
+            <a:r>
+              <a:rPr lang="en-US" sz="1200" dirty="0">
+                <a:solidFill>
+                  <a:srgbClr val="FF0000"/>
+                </a:solidFill>
+                <a:latin typeface="Arial" panose="020B0604020202020204" pitchFamily="34" charset="0"/>
+                <a:cs typeface="Arial" panose="020B0604020202020204" pitchFamily="34" charset="0"/>
+              </a:rPr>
+              <a:t> </a:t>
+            </a:r>
+            <a:r>
+              <a:rPr lang="en-US" sz="1200" dirty="0" err="1">
+                <a:solidFill>
+                  <a:srgbClr val="FF0000"/>
+                </a:solidFill>
+                <a:latin typeface="Arial" panose="020B0604020202020204" pitchFamily="34" charset="0"/>
+                <a:cs typeface="Arial" panose="020B0604020202020204" pitchFamily="34" charset="0"/>
+              </a:rPr>
+              <a:t>el</a:t>
+            </a:r>
+            <a:r>
+              <a:rPr lang="en-US" sz="1200" dirty="0">
+                <a:solidFill>
+                  <a:srgbClr val="FF0000"/>
+                </a:solidFill>
+                <a:latin typeface="Arial" panose="020B0604020202020204" pitchFamily="34" charset="0"/>
+                <a:cs typeface="Arial" panose="020B0604020202020204" pitchFamily="34" charset="0"/>
+              </a:rPr>
+              <a:t> 0.5 (lo </a:t>
+            </a:r>
+            <a:r>
+              <a:rPr lang="en-US" sz="1200" dirty="0" err="1">
+                <a:solidFill>
+                  <a:srgbClr val="FF0000"/>
+                </a:solidFill>
+                <a:latin typeface="Arial" panose="020B0604020202020204" pitchFamily="34" charset="0"/>
+                <a:cs typeface="Arial" panose="020B0604020202020204" pitchFamily="34" charset="0"/>
+              </a:rPr>
+              <a:t>posible</a:t>
+            </a:r>
+            <a:r>
+              <a:rPr lang="en-US" sz="1200" dirty="0">
+                <a:solidFill>
+                  <a:srgbClr val="FF0000"/>
+                </a:solidFill>
+                <a:latin typeface="Arial" panose="020B0604020202020204" pitchFamily="34" charset="0"/>
+                <a:cs typeface="Arial" panose="020B0604020202020204" pitchFamily="34" charset="0"/>
+              </a:rPr>
+              <a:t>)</a:t>
+            </a:r>
           </a:p>
           <a:p>
             <a:pPr algn="just"/>
@@ -5592,9 +5936,48 @@
             </a:r>
             <a:r>
               <a:rPr lang="en-US" b="0" dirty="0"/>
-              <a:t> = ? µm</a:t>
+              <a:t> = ? µm </a:t>
+            </a:r>
+            <a:r>
+              <a:rPr lang="en-US" b="0" dirty="0">
+                <a:solidFill>
+                  <a:srgbClr val="FF0000"/>
+                </a:solidFill>
+                <a:highlight>
+                  <a:srgbClr val="FF0000"/>
+                </a:highlight>
+              </a:rPr>
+              <a:t>(</a:t>
+            </a:r>
+            <a:r>
+              <a:rPr lang="en-US" b="0" dirty="0" err="1">
+                <a:solidFill>
+                  <a:srgbClr val="FF0000"/>
+                </a:solidFill>
+                <a:highlight>
+                  <a:srgbClr val="FFFF00"/>
+                </a:highlight>
+              </a:rPr>
+              <a:t>unos</a:t>
+            </a:r>
+            <a:r>
+              <a:rPr lang="en-US" b="0" dirty="0">
+                <a:solidFill>
+                  <a:srgbClr val="FF0000"/>
+                </a:solidFill>
+                <a:highlight>
+                  <a:srgbClr val="FFFF00"/>
+                </a:highlight>
+              </a:rPr>
+              <a:t> 10-12)</a:t>
             </a:r>
             <a:endParaRPr lang="en-US" sz="2500" b="0" dirty="0">
+              <a:solidFill>
+                <a:srgbClr val="FF0000"/>
+              </a:solidFill>
+              <a:highlight>
+                <a:srgbClr val="FFFF00"/>
+              </a:highlight>
               <a:latin typeface="+mj-lt"/>
               <a:cs typeface="Lucida Sans"/>
             </a:endParaRPr>
@@ -5715,7 +6098,7 @@
         <p:spPr>
           <a:xfrm>
             <a:off x="609441" y="4819471"/>
-            <a:ext cx="11199971" cy="1200329"/>
+            <a:ext cx="11199971" cy="1384995"/>
           </a:xfrm>
           <a:prstGeom prst="rect">
             <a:avLst/>
@@ -5743,21 +6126,7 @@
                 <a:latin typeface="Arial" panose="020B0604020202020204" pitchFamily="34" charset="0"/>
                 <a:cs typeface="Arial" panose="020B0604020202020204" pitchFamily="34" charset="0"/>
               </a:rPr>
-              <a:t>Repeat all the design </a:t>
-            </a:r>
-            <a:r>
-              <a:rPr lang="en-US" sz="1200">
-                <a:latin typeface="Arial" panose="020B0604020202020204" pitchFamily="34" charset="0"/>
-                <a:cs typeface="Arial" panose="020B0604020202020204" pitchFamily="34" charset="0"/>
-              </a:rPr>
-              <a:t>process for a </a:t>
-            </a:r>
-            <a:r>
-              <a:rPr lang="en-US" sz="1200" dirty="0">
-                <a:latin typeface="Arial" panose="020B0604020202020204" pitchFamily="34" charset="0"/>
-                <a:cs typeface="Arial" panose="020B0604020202020204" pitchFamily="34" charset="0"/>
-              </a:rPr>
-              <a:t>1x4 MMI Coupler.  </a:t>
+              <a:t>Repeat all the design process for a 1x4 MMI Coupler.  </a:t>
             </a:r>
           </a:p>
           <a:p>
@@ -5777,6 +6146,9 @@
           <a:p>
             <a:pPr algn="just"/>
             <a:endParaRPr lang="en-US" sz="1200" dirty="0">
+              <a:highlight>
+                <a:srgbClr val="FFFF00"/>
+              </a:highlight>
               <a:latin typeface="Arial" panose="020B0604020202020204" pitchFamily="34" charset="0"/>
               <a:cs typeface="Arial" panose="020B0604020202020204" pitchFamily="34" charset="0"/>
             </a:endParaRPr>
@@ -5787,6 +6159,99 @@
               <a:latin typeface="Arial" panose="020B0604020202020204" pitchFamily="34" charset="0"/>
               <a:cs typeface="Arial" panose="020B0604020202020204" pitchFamily="34" charset="0"/>
             </a:endParaRPr>
+          </a:p>
+          <a:p>
+            <a:pPr algn="just"/>
+            <a:r>
+              <a:rPr lang="en-US" sz="1200" dirty="0">
+                <a:solidFill>
+                  <a:srgbClr val="FF0000"/>
+                </a:solidFill>
+                <a:latin typeface="Arial" panose="020B0604020202020204" pitchFamily="34" charset="0"/>
+                <a:cs typeface="Arial" panose="020B0604020202020204" pitchFamily="34" charset="0"/>
+              </a:rPr>
+              <a:t>Hacer </a:t>
+            </a:r>
+            <a:r>
+              <a:rPr lang="en-US" sz="1200" dirty="0" err="1">
+                <a:solidFill>
+                  <a:srgbClr val="FF0000"/>
+                </a:solidFill>
+                <a:latin typeface="Arial" panose="020B0604020202020204" pitchFamily="34" charset="0"/>
+                <a:cs typeface="Arial" panose="020B0604020202020204" pitchFamily="34" charset="0"/>
+              </a:rPr>
+              <a:t>los</a:t>
+            </a:r>
+            <a:r>
+              <a:rPr lang="en-US" sz="1200" dirty="0">
+                <a:solidFill>
+                  <a:srgbClr val="FF0000"/>
+                </a:solidFill>
+                <a:latin typeface="Arial" panose="020B0604020202020204" pitchFamily="34" charset="0"/>
+                <a:cs typeface="Arial" panose="020B0604020202020204" pitchFamily="34" charset="0"/>
+              </a:rPr>
+              <a:t> </a:t>
+            </a:r>
+            <a:r>
+              <a:rPr lang="en-US" sz="1200" dirty="0" err="1">
+                <a:solidFill>
+                  <a:srgbClr val="FF0000"/>
+                </a:solidFill>
+                <a:latin typeface="Arial" panose="020B0604020202020204" pitchFamily="34" charset="0"/>
+                <a:cs typeface="Arial" panose="020B0604020202020204" pitchFamily="34" charset="0"/>
+              </a:rPr>
+              <a:t>mismos</a:t>
+            </a:r>
+            <a:r>
+              <a:rPr lang="en-US" sz="1200" dirty="0">
+                <a:solidFill>
+                  <a:srgbClr val="FF0000"/>
+                </a:solidFill>
+                <a:latin typeface="Arial" panose="020B0604020202020204" pitchFamily="34" charset="0"/>
+                <a:cs typeface="Arial" panose="020B0604020202020204" pitchFamily="34" charset="0"/>
+              </a:rPr>
+              <a:t> pasos </a:t>
+            </a:r>
+            <a:r>
+              <a:rPr lang="en-US" sz="1200" dirty="0" err="1">
+                <a:solidFill>
+                  <a:srgbClr val="FF0000"/>
+                </a:solidFill>
+                <a:latin typeface="Arial" panose="020B0604020202020204" pitchFamily="34" charset="0"/>
+                <a:cs typeface="Arial" panose="020B0604020202020204" pitchFamily="34" charset="0"/>
+              </a:rPr>
+              <a:t>que</a:t>
+            </a:r>
+            <a:r>
+              <a:rPr lang="en-US" sz="1200" dirty="0">
+                <a:solidFill>
+                  <a:srgbClr val="FF0000"/>
+                </a:solidFill>
+                <a:latin typeface="Arial" panose="020B0604020202020204" pitchFamily="34" charset="0"/>
+                <a:cs typeface="Arial" panose="020B0604020202020204" pitchFamily="34" charset="0"/>
+              </a:rPr>
+              <a:t> </a:t>
+            </a:r>
+            <a:r>
+              <a:rPr lang="en-US" sz="1200" dirty="0" err="1">
+                <a:solidFill>
+                  <a:srgbClr val="FF0000"/>
+                </a:solidFill>
+                <a:latin typeface="Arial" panose="020B0604020202020204" pitchFamily="34" charset="0"/>
+                <a:cs typeface="Arial" panose="020B0604020202020204" pitchFamily="34" charset="0"/>
+              </a:rPr>
+              <a:t>el</a:t>
+            </a:r>
+            <a:r>
+              <a:rPr lang="en-US" sz="1200" dirty="0">
+                <a:solidFill>
+                  <a:srgbClr val="FF0000"/>
+                </a:solidFill>
+                <a:latin typeface="Arial" panose="020B0604020202020204" pitchFamily="34" charset="0"/>
+                <a:cs typeface="Arial" panose="020B0604020202020204" pitchFamily="34" charset="0"/>
+              </a:rPr>
+              <a:t> anterior, poco a poco.</a:t>
+            </a:r>
           </a:p>
           <a:p>
             <a:pPr algn="just"/>
@@ -11252,8 +11717,8 @@
           </a:p>
         </p:txBody>
       </p:sp>
-      <mc:AlternateContent xmlns:mc="http://schemas.openxmlformats.org/markup-compatibility/2006">
-        <mc:Choice xmlns:a14="http://schemas.microsoft.com/office/drawing/2010/main" Requires="a14">
+      <mc:AlternateContent xmlns:mc="http://schemas.openxmlformats.org/markup-compatibility/2006" xmlns:a14="http://schemas.microsoft.com/office/drawing/2010/main">
+        <mc:Choice Requires="a14">
           <p:sp>
             <p:nvSpPr>
               <p:cNvPr id="4" name="Marcador de texto 2">
@@ -11487,7 +11952,7 @@
             </p:txBody>
           </p:sp>
         </mc:Choice>
-        <mc:Fallback>
+        <mc:Fallback xmlns="">
           <p:sp>
             <p:nvSpPr>
               <p:cNvPr id="4" name="Marcador de texto 2">
@@ -14439,7 +14904,7 @@
             </a:pPr>
             <a:r>
               <a:rPr lang="en-US" sz="1000" dirty="0"/>
-              <a:t>Gap = 0,2</a:t>
+              <a:t>Gap = 0.2</a:t>
             </a:r>
           </a:p>
         </p:txBody>
@@ -14707,7 +15172,7 @@
             </a:pPr>
             <a:r>
               <a:rPr lang="en-US" sz="1000" dirty="0"/>
-              <a:t>Gap = 0,4</a:t>
+              <a:t>Gap = 0.4</a:t>
             </a:r>
           </a:p>
         </p:txBody>
@@ -14975,7 +15440,7 @@
             </a:pPr>
             <a:r>
               <a:rPr lang="en-US" sz="1000" dirty="0"/>
-              <a:t>Gap = 0,6</a:t>
+              <a:t>Gap = 0.6</a:t>
             </a:r>
           </a:p>
         </p:txBody>
@@ -15243,7 +15708,7 @@
             </a:pPr>
             <a:r>
               <a:rPr lang="en-US" sz="1000" dirty="0"/>
-              <a:t>Gap = 0,8</a:t>
+              <a:t>Gap = 0.8</a:t>
             </a:r>
           </a:p>
         </p:txBody>
@@ -15779,7 +16244,7 @@
             </a:pPr>
             <a:r>
               <a:rPr lang="en-US" sz="1000" dirty="0"/>
-              <a:t>Gap = 1,2</a:t>
+              <a:t>Gap = 1.2</a:t>
             </a:r>
           </a:p>
         </p:txBody>
@@ -15998,7 +16463,7 @@
         <p:spPr>
           <a:xfrm>
             <a:off x="609441" y="4627196"/>
-            <a:ext cx="11199971" cy="3046988"/>
+            <a:ext cx="11199971" cy="3416320"/>
           </a:xfrm>
           <a:prstGeom prst="rect">
             <a:avLst/>
@@ -16580,6 +17045,209 @@
                 <a:cs typeface="Arial" panose="020B0604020202020204" pitchFamily="34" charset="0"/>
               </a:rPr>
               <a:t>HASTA AQUÍ HOY 10/03/2026.</a:t>
+            </a:r>
+          </a:p>
+          <a:p>
+            <a:pPr algn="just"/>
+            <a:endParaRPr lang="en-US" sz="1200" dirty="0">
+              <a:solidFill>
+                <a:srgbClr val="FF0000"/>
+              </a:solidFill>
+              <a:latin typeface="Arial" panose="020B0604020202020204" pitchFamily="34" charset="0"/>
+              <a:cs typeface="Arial" panose="020B0604020202020204" pitchFamily="34" charset="0"/>
+            </a:endParaRPr>
+          </a:p>
+          <a:p>
+            <a:pPr algn="just"/>
+            <a:r>
+              <a:rPr lang="en-US" sz="1200" dirty="0">
+                <a:solidFill>
+                  <a:srgbClr val="FF0000"/>
+                </a:solidFill>
+                <a:latin typeface="Arial" panose="020B0604020202020204" pitchFamily="34" charset="0"/>
+                <a:cs typeface="Arial" panose="020B0604020202020204" pitchFamily="34" charset="0"/>
+              </a:rPr>
+              <a:t>Hoy 24/03 -&gt; lo </a:t>
+            </a:r>
+            <a:r>
+              <a:rPr lang="en-US" sz="1200" dirty="0" err="1">
+                <a:solidFill>
+                  <a:srgbClr val="FF0000"/>
+                </a:solidFill>
+                <a:latin typeface="Arial" panose="020B0604020202020204" pitchFamily="34" charset="0"/>
+                <a:cs typeface="Arial" panose="020B0604020202020204" pitchFamily="34" charset="0"/>
+              </a:rPr>
+              <a:t>hemos</a:t>
+            </a:r>
+            <a:r>
+              <a:rPr lang="en-US" sz="1200" dirty="0">
+                <a:solidFill>
+                  <a:srgbClr val="FF0000"/>
+                </a:solidFill>
+                <a:latin typeface="Arial" panose="020B0604020202020204" pitchFamily="34" charset="0"/>
+                <a:cs typeface="Arial" panose="020B0604020202020204" pitchFamily="34" charset="0"/>
+              </a:rPr>
+              <a:t> </a:t>
+            </a:r>
+            <a:r>
+              <a:rPr lang="en-US" sz="1200" dirty="0" err="1">
+                <a:solidFill>
+                  <a:srgbClr val="FF0000"/>
+                </a:solidFill>
+                <a:latin typeface="Arial" panose="020B0604020202020204" pitchFamily="34" charset="0"/>
+                <a:cs typeface="Arial" panose="020B0604020202020204" pitchFamily="34" charset="0"/>
+              </a:rPr>
+              <a:t>planteado</a:t>
+            </a:r>
+            <a:r>
+              <a:rPr lang="en-US" sz="1200" dirty="0">
+                <a:solidFill>
+                  <a:srgbClr val="FF0000"/>
+                </a:solidFill>
+                <a:latin typeface="Arial" panose="020B0604020202020204" pitchFamily="34" charset="0"/>
+                <a:cs typeface="Arial" panose="020B0604020202020204" pitchFamily="34" charset="0"/>
+              </a:rPr>
+              <a:t> con </a:t>
+            </a:r>
+            <a:r>
+              <a:rPr lang="en-US" sz="1200" dirty="0" err="1">
+                <a:solidFill>
+                  <a:srgbClr val="FF0000"/>
+                </a:solidFill>
+                <a:latin typeface="Arial" panose="020B0604020202020204" pitchFamily="34" charset="0"/>
+                <a:cs typeface="Arial" panose="020B0604020202020204" pitchFamily="34" charset="0"/>
+              </a:rPr>
+              <a:t>el</a:t>
+            </a:r>
+            <a:r>
+              <a:rPr lang="en-US" sz="1200" dirty="0">
+                <a:solidFill>
+                  <a:srgbClr val="FF0000"/>
+                </a:solidFill>
+                <a:latin typeface="Arial" panose="020B0604020202020204" pitchFamily="34" charset="0"/>
+                <a:cs typeface="Arial" panose="020B0604020202020204" pitchFamily="34" charset="0"/>
+              </a:rPr>
+              <a:t> sweep, hay </a:t>
+            </a:r>
+            <a:r>
+              <a:rPr lang="en-US" sz="1200" dirty="0" err="1">
+                <a:solidFill>
+                  <a:srgbClr val="FF0000"/>
+                </a:solidFill>
+                <a:latin typeface="Arial" panose="020B0604020202020204" pitchFamily="34" charset="0"/>
+                <a:cs typeface="Arial" panose="020B0604020202020204" pitchFamily="34" charset="0"/>
+              </a:rPr>
+              <a:t>errores</a:t>
+            </a:r>
+            <a:r>
+              <a:rPr lang="en-US" sz="1200" dirty="0">
+                <a:solidFill>
+                  <a:srgbClr val="FF0000"/>
+                </a:solidFill>
+                <a:latin typeface="Arial" panose="020B0604020202020204" pitchFamily="34" charset="0"/>
+                <a:cs typeface="Arial" panose="020B0604020202020204" pitchFamily="34" charset="0"/>
+              </a:rPr>
+              <a:t> y hay </a:t>
+            </a:r>
+            <a:r>
+              <a:rPr lang="en-US" sz="1200" dirty="0" err="1">
+                <a:solidFill>
+                  <a:srgbClr val="FF0000"/>
+                </a:solidFill>
+                <a:latin typeface="Arial" panose="020B0604020202020204" pitchFamily="34" charset="0"/>
+                <a:cs typeface="Arial" panose="020B0604020202020204" pitchFamily="34" charset="0"/>
+              </a:rPr>
+              <a:t>que</a:t>
+            </a:r>
+            <a:r>
+              <a:rPr lang="en-US" sz="1200" dirty="0">
+                <a:solidFill>
+                  <a:srgbClr val="FF0000"/>
+                </a:solidFill>
+                <a:latin typeface="Arial" panose="020B0604020202020204" pitchFamily="34" charset="0"/>
+                <a:cs typeface="Arial" panose="020B0604020202020204" pitchFamily="34" charset="0"/>
+              </a:rPr>
+              <a:t> </a:t>
+            </a:r>
+            <a:r>
+              <a:rPr lang="en-US" sz="1200" dirty="0" err="1">
+                <a:solidFill>
+                  <a:srgbClr val="FF0000"/>
+                </a:solidFill>
+                <a:latin typeface="Arial" panose="020B0604020202020204" pitchFamily="34" charset="0"/>
+                <a:cs typeface="Arial" panose="020B0604020202020204" pitchFamily="34" charset="0"/>
+              </a:rPr>
+              <a:t>revisarlos</a:t>
+            </a:r>
+            <a:r>
+              <a:rPr lang="en-US" sz="1200" dirty="0">
+                <a:solidFill>
+                  <a:srgbClr val="FF0000"/>
+                </a:solidFill>
+                <a:latin typeface="Arial" panose="020B0604020202020204" pitchFamily="34" charset="0"/>
+                <a:cs typeface="Arial" panose="020B0604020202020204" pitchFamily="34" charset="0"/>
+              </a:rPr>
+              <a:t> (</a:t>
+            </a:r>
+            <a:r>
+              <a:rPr lang="en-US" sz="1200" dirty="0" err="1">
+                <a:solidFill>
+                  <a:srgbClr val="FF0000"/>
+                </a:solidFill>
+                <a:latin typeface="Arial" panose="020B0604020202020204" pitchFamily="34" charset="0"/>
+                <a:cs typeface="Arial" panose="020B0604020202020204" pitchFamily="34" charset="0"/>
+              </a:rPr>
+              <a:t>creemos</a:t>
+            </a:r>
+            <a:r>
+              <a:rPr lang="en-US" sz="1200" dirty="0">
+                <a:solidFill>
+                  <a:srgbClr val="FF0000"/>
+                </a:solidFill>
+                <a:latin typeface="Arial" panose="020B0604020202020204" pitchFamily="34" charset="0"/>
+                <a:cs typeface="Arial" panose="020B0604020202020204" pitchFamily="34" charset="0"/>
+              </a:rPr>
+              <a:t> </a:t>
+            </a:r>
+            <a:r>
+              <a:rPr lang="en-US" sz="1200" dirty="0" err="1">
+                <a:solidFill>
+                  <a:srgbClr val="FF0000"/>
+                </a:solidFill>
+                <a:latin typeface="Arial" panose="020B0604020202020204" pitchFamily="34" charset="0"/>
+                <a:cs typeface="Arial" panose="020B0604020202020204" pitchFamily="34" charset="0"/>
+              </a:rPr>
+              <a:t>que</a:t>
+            </a:r>
+            <a:r>
+              <a:rPr lang="en-US" sz="1200" dirty="0">
+                <a:solidFill>
+                  <a:srgbClr val="FF0000"/>
+                </a:solidFill>
+                <a:latin typeface="Arial" panose="020B0604020202020204" pitchFamily="34" charset="0"/>
+                <a:cs typeface="Arial" panose="020B0604020202020204" pitchFamily="34" charset="0"/>
+              </a:rPr>
+              <a:t> </a:t>
+            </a:r>
+            <a:r>
+              <a:rPr lang="en-US" sz="1200" dirty="0" err="1">
+                <a:solidFill>
+                  <a:srgbClr val="FF0000"/>
+                </a:solidFill>
+                <a:latin typeface="Arial" panose="020B0604020202020204" pitchFamily="34" charset="0"/>
+                <a:cs typeface="Arial" panose="020B0604020202020204" pitchFamily="34" charset="0"/>
+              </a:rPr>
+              <a:t>unidades</a:t>
+            </a:r>
+            <a:r>
+              <a:rPr lang="en-US" sz="1200" dirty="0">
+                <a:solidFill>
+                  <a:srgbClr val="FF0000"/>
+                </a:solidFill>
+                <a:latin typeface="Arial" panose="020B0604020202020204" pitchFamily="34" charset="0"/>
+                <a:cs typeface="Arial" panose="020B0604020202020204" pitchFamily="34" charset="0"/>
+              </a:rPr>
+              <a:t>)</a:t>
             </a:r>
           </a:p>
           <a:p>
@@ -17629,33 +18297,8 @@
                 <a:latin typeface="Arial" panose="020B0604020202020204" pitchFamily="34" charset="0"/>
                 <a:cs typeface="Arial" panose="020B0604020202020204" pitchFamily="34" charset="0"/>
               </a:rPr>
-              <a:t>Document all your results (neff, plot fields </a:t>
-            </a:r>
-            <a:r>
-              <a:rPr lang="en-US" sz="1200">
-                <a:latin typeface="Arial" panose="020B0604020202020204" pitchFamily="34" charset="0"/>
-                <a:cs typeface="Arial" panose="020B0604020202020204" pitchFamily="34" charset="0"/>
-              </a:rPr>
-              <a:t>of different modes, </a:t>
-            </a:r>
-            <a:r>
-              <a:rPr lang="en-US" sz="1200" dirty="0">
-                <a:latin typeface="Arial" panose="020B0604020202020204" pitchFamily="34" charset="0"/>
-                <a:cs typeface="Arial" panose="020B0604020202020204" pitchFamily="34" charset="0"/>
-              </a:rPr>
-              <a:t>comparison between </a:t>
-            </a:r>
-            <a:r>
-              <a:rPr lang="en-US" sz="1200">
-                <a:latin typeface="Arial" panose="020B0604020202020204" pitchFamily="34" charset="0"/>
-                <a:cs typeface="Arial" panose="020B0604020202020204" pitchFamily="34" charset="0"/>
-              </a:rPr>
-              <a:t>different polarizations…)</a:t>
-            </a:r>
-            <a:endParaRPr lang="en-US" sz="1200" dirty="0">
-              <a:latin typeface="Arial" panose="020B0604020202020204" pitchFamily="34" charset="0"/>
-              <a:cs typeface="Arial" panose="020B0604020202020204" pitchFamily="34" charset="0"/>
-            </a:endParaRPr>
+              <a:t>Document all your results (neff, plot fields of different modes, comparison between different polarizations…)</a:t>
+            </a:r>
           </a:p>
           <a:p>
             <a:pPr algn="just"/>
@@ -17666,10 +18309,16 @@
           </a:p>
           <a:p>
             <a:pPr algn="just"/>
-            <a:endParaRPr lang="en-US" sz="1200" dirty="0">
-              <a:latin typeface="Arial" panose="020B0604020202020204" pitchFamily="34" charset="0"/>
-              <a:cs typeface="Arial" panose="020B0604020202020204" pitchFamily="34" charset="0"/>
-            </a:endParaRPr>
+            <a:r>
+              <a:rPr lang="en-US" sz="1200" dirty="0">
+                <a:solidFill>
+                  <a:srgbClr val="FF0000"/>
+                </a:solidFill>
+                <a:latin typeface="Arial" panose="020B0604020202020204" pitchFamily="34" charset="0"/>
+                <a:cs typeface="Arial" panose="020B0604020202020204" pitchFamily="34" charset="0"/>
+              </a:rPr>
+              <a:t>COMENTAR LOS RESULTADOS (NO DARLE MUCHAS VUETLAS)</a:t>
+            </a:r>
           </a:p>
           <a:p>
             <a:pPr algn="just"/>

</xml_diff>